<commit_message>
Introduce week 7 topic, lesson flow and learning outcomes
</commit_message>
<xml_diff>
--- a/lendet/2026-2027/mobile/lectures/ligjerata-07-kontrolli-mvp-rideshare-2026.pptx
+++ b/lendet/2026-2027/mobile/lectures/ligjerata-07-kontrolli-mvp-rideshare-2026.pptx
@@ -2,27 +2,27 @@
 <file path=ppt/presentation.xml><?xml version="1.0" encoding="utf-8"?>
 <p:presentation xmlns:p="http://schemas.openxmlformats.org/presentationml/2006/main">
   <p:sldMasterIdLst>
-    <p:sldMasterId xmlns:r="http://schemas.openxmlformats.org/officeDocument/2006/relationships" id="2147483648" r:id="R5d135ca1a0984155"/>
+    <p:sldMasterId xmlns:r="http://schemas.openxmlformats.org/officeDocument/2006/relationships" id="2147483648" r:id="R3139c077fa664670"/>
   </p:sldMasterIdLst>
   <p:sldIdLst>
-    <p:sldId xmlns:r="http://schemas.openxmlformats.org/officeDocument/2006/relationships" id="256" r:id="Re08db337b4c94301"/>
-    <p:sldId xmlns:r="http://schemas.openxmlformats.org/officeDocument/2006/relationships" id="257" r:id="Rbe74d985c05041c7"/>
-    <p:sldId xmlns:r="http://schemas.openxmlformats.org/officeDocument/2006/relationships" id="258" r:id="R263c826d26c74446"/>
-    <p:sldId xmlns:r="http://schemas.openxmlformats.org/officeDocument/2006/relationships" id="259" r:id="R269f5b8e8f004639"/>
-    <p:sldId xmlns:r="http://schemas.openxmlformats.org/officeDocument/2006/relationships" id="260" r:id="Rc91da2b986994fa0"/>
-    <p:sldId xmlns:r="http://schemas.openxmlformats.org/officeDocument/2006/relationships" id="261" r:id="Rbb3b18922d7f4d82"/>
-    <p:sldId xmlns:r="http://schemas.openxmlformats.org/officeDocument/2006/relationships" id="262" r:id="Rc981dababfc0421a"/>
-    <p:sldId xmlns:r="http://schemas.openxmlformats.org/officeDocument/2006/relationships" id="263" r:id="R3e63953822214575"/>
-    <p:sldId xmlns:r="http://schemas.openxmlformats.org/officeDocument/2006/relationships" id="264" r:id="Rb42f9ae8896e4544"/>
-    <p:sldId xmlns:r="http://schemas.openxmlformats.org/officeDocument/2006/relationships" id="265" r:id="Rbe0fb7fb23bc4cfc"/>
-    <p:sldId xmlns:r="http://schemas.openxmlformats.org/officeDocument/2006/relationships" id="266" r:id="Ra307d64205454fc6"/>
-    <p:sldId xmlns:r="http://schemas.openxmlformats.org/officeDocument/2006/relationships" id="267" r:id="R09dd1184c2a242e0"/>
-    <p:sldId xmlns:r="http://schemas.openxmlformats.org/officeDocument/2006/relationships" id="268" r:id="Raf5a425c13fa4d9a"/>
-    <p:sldId xmlns:r="http://schemas.openxmlformats.org/officeDocument/2006/relationships" id="269" r:id="Rd42d69bac1fd4a1e"/>
-    <p:sldId xmlns:r="http://schemas.openxmlformats.org/officeDocument/2006/relationships" id="270" r:id="R3920b3eb0e834072"/>
-    <p:sldId xmlns:r="http://schemas.openxmlformats.org/officeDocument/2006/relationships" id="271" r:id="R5dc7a80ff4284d4e"/>
-    <p:sldId xmlns:r="http://schemas.openxmlformats.org/officeDocument/2006/relationships" id="272" r:id="R4a1dd100ca144073"/>
-    <p:sldId xmlns:r="http://schemas.openxmlformats.org/officeDocument/2006/relationships" id="273" r:id="Rcf6fabb189b64b91"/>
+    <p:sldId xmlns:r="http://schemas.openxmlformats.org/officeDocument/2006/relationships" id="256" r:id="R9dd59cefbc594cec"/>
+    <p:sldId xmlns:r="http://schemas.openxmlformats.org/officeDocument/2006/relationships" id="257" r:id="R08a3fe49ccdb42e2"/>
+    <p:sldId xmlns:r="http://schemas.openxmlformats.org/officeDocument/2006/relationships" id="258" r:id="R5b31383fb9f04207"/>
+    <p:sldId xmlns:r="http://schemas.openxmlformats.org/officeDocument/2006/relationships" id="259" r:id="Rea22b91b552d4003"/>
+    <p:sldId xmlns:r="http://schemas.openxmlformats.org/officeDocument/2006/relationships" id="260" r:id="Re60326bbf14549a1"/>
+    <p:sldId xmlns:r="http://schemas.openxmlformats.org/officeDocument/2006/relationships" id="261" r:id="R557ef4afd8a84533"/>
+    <p:sldId xmlns:r="http://schemas.openxmlformats.org/officeDocument/2006/relationships" id="262" r:id="R1c70b289079846b3"/>
+    <p:sldId xmlns:r="http://schemas.openxmlformats.org/officeDocument/2006/relationships" id="263" r:id="R93ea9ea005e74f44"/>
+    <p:sldId xmlns:r="http://schemas.openxmlformats.org/officeDocument/2006/relationships" id="264" r:id="Re1e9ca26d86243bd"/>
+    <p:sldId xmlns:r="http://schemas.openxmlformats.org/officeDocument/2006/relationships" id="265" r:id="Ra7b82f1def82495d"/>
+    <p:sldId xmlns:r="http://schemas.openxmlformats.org/officeDocument/2006/relationships" id="266" r:id="Rd0d7b1b81c0e4216"/>
+    <p:sldId xmlns:r="http://schemas.openxmlformats.org/officeDocument/2006/relationships" id="267" r:id="R5e7121a8e3f64ffd"/>
+    <p:sldId xmlns:r="http://schemas.openxmlformats.org/officeDocument/2006/relationships" id="268" r:id="Rf92a60a010d7408e"/>
+    <p:sldId xmlns:r="http://schemas.openxmlformats.org/officeDocument/2006/relationships" id="269" r:id="R1eff110ad57846a2"/>
+    <p:sldId xmlns:r="http://schemas.openxmlformats.org/officeDocument/2006/relationships" id="270" r:id="R0bdc9d44a34441b5"/>
+    <p:sldId xmlns:r="http://schemas.openxmlformats.org/officeDocument/2006/relationships" id="271" r:id="R7b29edc815ae419d"/>
+    <p:sldId xmlns:r="http://schemas.openxmlformats.org/officeDocument/2006/relationships" id="272" r:id="R28267e2e0cc2406f"/>
+    <p:sldId xmlns:r="http://schemas.openxmlformats.org/officeDocument/2006/relationships" id="273" r:id="Rf9289252ee504eae"/>
   </p:sldIdLst>
   <p:sldSz cx="12192000" cy="6858000"/>
   <p:notesSz cx="6858000" cy="9144000"/>
@@ -46,7 +46,7 @@
           <p:cNvPr id="3" name="Title">
             <a:extLst xmlns:a="http://schemas.openxmlformats.org/drawingml/2006/main">
               <a:ext uri="{FF2B5EF4-FFF2-40B4-BE49-F238E27FC236}">
-                <a16:creationId xmlns:a16="http://schemas.microsoft.com/office/drawing/2014/main" id="{6E36BD56-D4D6-42A0-A11B-93888EE31140}"/>
+                <a16:creationId xmlns:a16="http://schemas.microsoft.com/office/drawing/2014/main" id="{D42227B1-23BF-4A8C-A36E-F65714D8022E}"/>
               </a:ext>
             </a:extLst>
           </p:cNvPr>
@@ -275,7 +275,7 @@
           <p:cNvPr id="2" name="Subtitle">
             <a:extLst xmlns:a="http://schemas.openxmlformats.org/drawingml/2006/main">
               <a:ext uri="{FF2B5EF4-FFF2-40B4-BE49-F238E27FC236}">
-                <a16:creationId xmlns:a16="http://schemas.microsoft.com/office/drawing/2014/main" id="{F3CCCE2B-1A0F-4443-8B66-31023B40E288}"/>
+                <a16:creationId xmlns:a16="http://schemas.microsoft.com/office/drawing/2014/main" id="{BB7C38C1-D08F-48C3-9D37-955DCEB60383}"/>
               </a:ext>
             </a:extLst>
           </p:cNvPr>
@@ -521,7 +521,7 @@
           <p:cNvPr id="2" name="Section title">
             <a:extLst xmlns:a="http://schemas.openxmlformats.org/drawingml/2006/main">
               <a:ext uri="{FF2B5EF4-FFF2-40B4-BE49-F238E27FC236}">
-                <a16:creationId xmlns:a16="http://schemas.microsoft.com/office/drawing/2014/main" id="{F42BB268-962D-4A4A-A36F-414E93C8AF79}"/>
+                <a16:creationId xmlns:a16="http://schemas.microsoft.com/office/drawing/2014/main" id="{43AD3D19-B2A5-4FC2-8321-C688ACE60C50}"/>
               </a:ext>
             </a:extLst>
           </p:cNvPr>
@@ -767,7 +767,7 @@
           <p:cNvPr id="3" name="Title">
             <a:extLst xmlns:a="http://schemas.openxmlformats.org/drawingml/2006/main">
               <a:ext uri="{FF2B5EF4-FFF2-40B4-BE49-F238E27FC236}">
-                <a16:creationId xmlns:a16="http://schemas.microsoft.com/office/drawing/2014/main" id="{22868CC3-7522-4FC5-9B4E-8DFC7083C4C6}"/>
+                <a16:creationId xmlns:a16="http://schemas.microsoft.com/office/drawing/2014/main" id="{A253451B-DA6A-4EFB-BF17-050261519107}"/>
               </a:ext>
             </a:extLst>
           </p:cNvPr>
@@ -996,7 +996,7 @@
           <p:cNvPr id="2" name="Body">
             <a:extLst xmlns:a="http://schemas.openxmlformats.org/drawingml/2006/main">
               <a:ext uri="{FF2B5EF4-FFF2-40B4-BE49-F238E27FC236}">
-                <a16:creationId xmlns:a16="http://schemas.microsoft.com/office/drawing/2014/main" id="{43C7679B-C69A-4A3F-B1A7-09103BF9F8F7}"/>
+                <a16:creationId xmlns:a16="http://schemas.microsoft.com/office/drawing/2014/main" id="{08EC6A38-8952-4557-9E08-F68366C703C2}"/>
               </a:ext>
             </a:extLst>
           </p:cNvPr>
@@ -1242,7 +1242,7 @@
           <p:cNvPr id="4" name="Title">
             <a:extLst xmlns:a="http://schemas.openxmlformats.org/drawingml/2006/main">
               <a:ext uri="{FF2B5EF4-FFF2-40B4-BE49-F238E27FC236}">
-                <a16:creationId xmlns:a16="http://schemas.microsoft.com/office/drawing/2014/main" id="{8F8CCA6A-4D7A-4CB3-BC2D-EB3E663B5382}"/>
+                <a16:creationId xmlns:a16="http://schemas.microsoft.com/office/drawing/2014/main" id="{37960D93-3972-4945-AB05-8C81286B7EBE}"/>
               </a:ext>
             </a:extLst>
           </p:cNvPr>
@@ -1471,7 +1471,7 @@
           <p:cNvPr id="2" name="Left column">
             <a:extLst xmlns:a="http://schemas.openxmlformats.org/drawingml/2006/main">
               <a:ext uri="{FF2B5EF4-FFF2-40B4-BE49-F238E27FC236}">
-                <a16:creationId xmlns:a16="http://schemas.microsoft.com/office/drawing/2014/main" id="{B2483A1C-CD43-45BB-88E8-8BFF45CE6144}"/>
+                <a16:creationId xmlns:a16="http://schemas.microsoft.com/office/drawing/2014/main" id="{D885CCF8-6742-4671-8E87-92C0EBE2FDD3}"/>
               </a:ext>
             </a:extLst>
           </p:cNvPr>
@@ -1700,7 +1700,7 @@
           <p:cNvPr id="3" name="Right column">
             <a:extLst xmlns:a="http://schemas.openxmlformats.org/drawingml/2006/main">
               <a:ext uri="{FF2B5EF4-FFF2-40B4-BE49-F238E27FC236}">
-                <a16:creationId xmlns:a16="http://schemas.microsoft.com/office/drawing/2014/main" id="{AFC43F2F-1DBD-4559-9B26-921EEB965F80}"/>
+                <a16:creationId xmlns:a16="http://schemas.microsoft.com/office/drawing/2014/main" id="{B963392F-4BC1-4F54-AA89-68B2567E35E4}"/>
               </a:ext>
             </a:extLst>
           </p:cNvPr>
@@ -1946,7 +1946,7 @@
           <p:cNvPr id="3" name="Title">
             <a:extLst xmlns:a="http://schemas.openxmlformats.org/drawingml/2006/main">
               <a:ext uri="{FF2B5EF4-FFF2-40B4-BE49-F238E27FC236}">
-                <a16:creationId xmlns:a16="http://schemas.microsoft.com/office/drawing/2014/main" id="{AF04AD57-A62C-4573-BF1C-F51FC263851C}"/>
+                <a16:creationId xmlns:a16="http://schemas.microsoft.com/office/drawing/2014/main" id="{C1A1F216-BDE3-416F-B13D-9BD2028338F2}"/>
               </a:ext>
             </a:extLst>
           </p:cNvPr>
@@ -2175,7 +2175,7 @@
           <p:cNvPr id="2" name="Left column">
             <a:extLst xmlns:a="http://schemas.openxmlformats.org/drawingml/2006/main">
               <a:ext uri="{FF2B5EF4-FFF2-40B4-BE49-F238E27FC236}">
-                <a16:creationId xmlns:a16="http://schemas.microsoft.com/office/drawing/2014/main" id="{9CB469D4-184D-48FC-A3E5-274613155F13}"/>
+                <a16:creationId xmlns:a16="http://schemas.microsoft.com/office/drawing/2014/main" id="{DF055F8C-56D1-490F-A93E-EDB560EACF18}"/>
               </a:ext>
             </a:extLst>
           </p:cNvPr>
@@ -2442,12 +2442,12 @@
   </p:cSld>
   <p:clrMap bg1="lt1" tx1="dk1" bg2="lt2" tx2="dk2" accent1="accent1" accent2="accent2" accent3="accent3" accent4="accent4" accent5="accent5" accent6="accent6" hlink="hlink" folHlink="folHlink"/>
   <p:sldLayoutIdLst>
-    <p:sldLayoutId xmlns:r="http://schemas.openxmlformats.org/officeDocument/2006/relationships" id="2147483649" r:id="R6928c59dcab4460b"/>
-    <p:sldLayoutId xmlns:r="http://schemas.openxmlformats.org/officeDocument/2006/relationships" id="2147483650" r:id="Rbb150280d6f14d63"/>
-    <p:sldLayoutId xmlns:r="http://schemas.openxmlformats.org/officeDocument/2006/relationships" id="2147483651" r:id="R9328b11cb18c459c"/>
-    <p:sldLayoutId xmlns:r="http://schemas.openxmlformats.org/officeDocument/2006/relationships" id="2147483652" r:id="R631c62e9da934778"/>
-    <p:sldLayoutId xmlns:r="http://schemas.openxmlformats.org/officeDocument/2006/relationships" id="2147483653" r:id="Rb747c62b15bf4e52"/>
-    <p:sldLayoutId xmlns:r="http://schemas.openxmlformats.org/officeDocument/2006/relationships" id="2147483654" r:id="R3edf7588833d43d8"/>
+    <p:sldLayoutId xmlns:r="http://schemas.openxmlformats.org/officeDocument/2006/relationships" id="2147483649" r:id="R248e36c36c024aec"/>
+    <p:sldLayoutId xmlns:r="http://schemas.openxmlformats.org/officeDocument/2006/relationships" id="2147483650" r:id="R88d21ff2b2b945ac"/>
+    <p:sldLayoutId xmlns:r="http://schemas.openxmlformats.org/officeDocument/2006/relationships" id="2147483651" r:id="R5e726ddb9ab84868"/>
+    <p:sldLayoutId xmlns:r="http://schemas.openxmlformats.org/officeDocument/2006/relationships" id="2147483652" r:id="R5d27c16274354d91"/>
+    <p:sldLayoutId xmlns:r="http://schemas.openxmlformats.org/officeDocument/2006/relationships" id="2147483653" r:id="Re670eb337fe54968"/>
+    <p:sldLayoutId xmlns:r="http://schemas.openxmlformats.org/officeDocument/2006/relationships" id="2147483654" r:id="R662d74552dfc4cb0"/>
   </p:sldLayoutIdLst>
   <p:txStyles>
     <p:titleStyle>
@@ -2995,10 +2995,10 @@
       </p:grpSpPr>
       <p:sp>
         <p:nvSpPr>
-          <p:cNvPr id="12" name="">
+          <p:cNvPr id="15" name="">
             <a:extLst xmlns:a="http://schemas.openxmlformats.org/drawingml/2006/main">
               <a:ext uri="{FF2B5EF4-FFF2-40B4-BE49-F238E27FC236}">
-                <a16:creationId xmlns:a16="http://schemas.microsoft.com/office/drawing/2014/main" id="{D9FAD897-5F10-452A-8E39-C38E3B9FD0DC}"/>
+                <a16:creationId xmlns:a16="http://schemas.microsoft.com/office/drawing/2014/main" id="{66ED5C00-70B0-47CF-B037-9C3E0A707696}"/>
               </a:ext>
             </a:extLst>
           </p:cNvPr>
@@ -3156,7 +3156,7 @@
           <p:cNvPr id="2" name="">
             <a:extLst xmlns:a="http://schemas.openxmlformats.org/drawingml/2006/main">
               <a:ext uri="{FF2B5EF4-FFF2-40B4-BE49-F238E27FC236}">
-                <a16:creationId xmlns:a16="http://schemas.microsoft.com/office/drawing/2014/main" id="{C1DAAA2E-00F3-47D8-83BF-8F5073E4708B}"/>
+                <a16:creationId xmlns:a16="http://schemas.microsoft.com/office/drawing/2014/main" id="{F7514E19-880B-4547-9E99-86199F03DB54}"/>
               </a:ext>
             </a:extLst>
           </p:cNvPr>
@@ -3314,7 +3314,7 @@
           <p:cNvPr id="3" name="">
             <a:extLst xmlns:a="http://schemas.openxmlformats.org/drawingml/2006/main">
               <a:ext uri="{FF2B5EF4-FFF2-40B4-BE49-F238E27FC236}">
-                <a16:creationId xmlns:a16="http://schemas.microsoft.com/office/drawing/2014/main" id="{B8148EF5-6D56-4FD2-9BE8-B86C8D47A1AC}"/>
+                <a16:creationId xmlns:a16="http://schemas.microsoft.com/office/drawing/2014/main" id="{5407464A-DC0E-4E7B-B0C5-33F60FFAD276}"/>
               </a:ext>
             </a:extLst>
           </p:cNvPr>
@@ -3324,7 +3324,7 @@
           <p:nvPr/>
         </p:nvPicPr>
         <p:blipFill>
-          <a:blip xmlns:r="http://schemas.openxmlformats.org/officeDocument/2006/relationships" xmlns:a="http://schemas.openxmlformats.org/drawingml/2006/main" r:embed="R4c9d0e4ed40746a7"/>
+          <a:blip xmlns:r="http://schemas.openxmlformats.org/officeDocument/2006/relationships" xmlns:a="http://schemas.openxmlformats.org/drawingml/2006/main" r:embed="R094029139d5b4448"/>
           <a:stretch xmlns:a="http://schemas.openxmlformats.org/drawingml/2006/main"/>
         </p:blipFill>
         <p:spPr>
@@ -3342,7 +3342,7 @@
           <p:cNvPr id="4" name="">
             <a:extLst xmlns:a="http://schemas.openxmlformats.org/drawingml/2006/main">
               <a:ext uri="{FF2B5EF4-FFF2-40B4-BE49-F238E27FC236}">
-                <a16:creationId xmlns:a16="http://schemas.microsoft.com/office/drawing/2014/main" id="{E4A46018-40D6-4917-8C4D-6D0CB66D71EF}"/>
+                <a16:creationId xmlns:a16="http://schemas.microsoft.com/office/drawing/2014/main" id="{99CCA8A0-C54D-4076-88E5-99D396BB231A}"/>
               </a:ext>
             </a:extLst>
           </p:cNvPr>
@@ -3490,7 +3490,7 @@
                 <a:ea typeface="Arial"/>
                 <a:cs typeface="Arial"/>
               </a:rPr>
-              <a:t>A do t’ia besoje udhëtimin këtij app-i?</a:t>
+              <a:t>Kontrolli i MVP-së së RideShare</a:t>
             </a:r>
           </a:p>
         </p:txBody>
@@ -3500,7 +3500,7 @@
           <p:cNvPr id="5" name="">
             <a:extLst xmlns:a="http://schemas.openxmlformats.org/drawingml/2006/main">
               <a:ext uri="{FF2B5EF4-FFF2-40B4-BE49-F238E27FC236}">
-                <a16:creationId xmlns:a16="http://schemas.microsoft.com/office/drawing/2014/main" id="{53F60BC4-F036-43B1-94A7-C5602B7B2F17}"/>
+                <a16:creationId xmlns:a16="http://schemas.microsoft.com/office/drawing/2014/main" id="{6C12C3EA-F2AF-42FF-94D0-7F7B797469BF}"/>
               </a:ext>
             </a:extLst>
           </p:cNvPr>
@@ -3510,7 +3510,7 @@
           <p:nvPr/>
         </p:nvPicPr>
         <p:blipFill>
-          <a:blip xmlns:r="http://schemas.openxmlformats.org/officeDocument/2006/relationships" xmlns:a="http://schemas.openxmlformats.org/drawingml/2006/main" r:embed="R7d17743fd1ea4380"/>
+          <a:blip xmlns:r="http://schemas.openxmlformats.org/officeDocument/2006/relationships" xmlns:a="http://schemas.openxmlformats.org/drawingml/2006/main" r:embed="R83b885e017b54235"/>
           <a:stretch xmlns:a="http://schemas.openxmlformats.org/drawingml/2006/main"/>
         </p:blipFill>
         <p:spPr>
@@ -3528,7 +3528,7 @@
           <p:cNvPr id="6" name="">
             <a:extLst xmlns:a="http://schemas.openxmlformats.org/drawingml/2006/main">
               <a:ext uri="{FF2B5EF4-FFF2-40B4-BE49-F238E27FC236}">
-                <a16:creationId xmlns:a16="http://schemas.microsoft.com/office/drawing/2014/main" id="{37B565E9-8751-442C-93B2-0C3954AE20DB}"/>
+                <a16:creationId xmlns:a16="http://schemas.microsoft.com/office/drawing/2014/main" id="{772E12DC-AB08-4C04-B5F1-74F229B833B5}"/>
               </a:ext>
             </a:extLst>
           </p:cNvPr>
@@ -3540,7 +3540,7 @@
         <p:spPr>
           <a:xfrm xmlns:a="http://schemas.openxmlformats.org/drawingml/2006/main">
             <a:off x="609600" y="2667000"/>
-            <a:ext cx="5295900" cy="495300"/>
+            <a:ext cx="3409950" cy="495300"/>
           </a:xfrm>
           <a:prstGeom xmlns:a="http://schemas.openxmlformats.org/drawingml/2006/main" prst="rect">
             <a:avLst/>
@@ -3676,7 +3676,7 @@
                 <a:ea typeface="Arial"/>
                 <a:cs typeface="Arial"/>
               </a:rPr>
-              <a:t>Dritoni</a:t>
+              <a:t>Tema e sotme</a:t>
             </a:r>
           </a:p>
         </p:txBody>
@@ -3686,7 +3686,7 @@
           <p:cNvPr id="7" name="">
             <a:extLst xmlns:a="http://schemas.openxmlformats.org/drawingml/2006/main">
               <a:ext uri="{FF2B5EF4-FFF2-40B4-BE49-F238E27FC236}">
-                <a16:creationId xmlns:a16="http://schemas.microsoft.com/office/drawing/2014/main" id="{55A184BC-1498-4691-8011-8F38A0B64DF5}"/>
+                <a16:creationId xmlns:a16="http://schemas.microsoft.com/office/drawing/2014/main" id="{C6B76879-42F3-42A4-B2CE-79654841C91E}"/>
               </a:ext>
             </a:extLst>
           </p:cNvPr>
@@ -3698,7 +3698,7 @@
         <p:spPr>
           <a:xfrm xmlns:a="http://schemas.openxmlformats.org/drawingml/2006/main">
             <a:off x="609600" y="3219450"/>
-            <a:ext cx="5295900" cy="571500"/>
+            <a:ext cx="3409950" cy="571500"/>
           </a:xfrm>
           <a:prstGeom xmlns:a="http://schemas.openxmlformats.org/drawingml/2006/main" prst="rect">
             <a:avLst/>
@@ -3834,7 +3834,7 @@
                 <a:ea typeface="Arial"/>
                 <a:cs typeface="Arial"/>
               </a:rPr>
-              <a:t>Shoferi dhe pronari i udhëtimit</a:t>
+              <a:t>Ekranet, të dhënat dhe lejet</a:t>
             </a:r>
           </a:p>
         </p:txBody>
@@ -3844,7 +3844,7 @@
           <p:cNvPr id="8" name="">
             <a:extLst xmlns:a="http://schemas.openxmlformats.org/drawingml/2006/main">
               <a:ext uri="{FF2B5EF4-FFF2-40B4-BE49-F238E27FC236}">
-                <a16:creationId xmlns:a16="http://schemas.microsoft.com/office/drawing/2014/main" id="{6A93CD08-DB19-4521-A699-B7435DB7BC7F}"/>
+                <a16:creationId xmlns:a16="http://schemas.microsoft.com/office/drawing/2014/main" id="{8ECD087C-4FD0-42D3-A2A1-6C63997972A9}"/>
               </a:ext>
             </a:extLst>
           </p:cNvPr>
@@ -3854,12 +3854,12 @@
           <p:nvPr/>
         </p:nvPicPr>
         <p:blipFill>
-          <a:blip xmlns:r="http://schemas.openxmlformats.org/officeDocument/2006/relationships" xmlns:a="http://schemas.openxmlformats.org/drawingml/2006/main" r:embed="R249921616e9c4f07"/>
+          <a:blip xmlns:r="http://schemas.openxmlformats.org/officeDocument/2006/relationships" xmlns:a="http://schemas.openxmlformats.org/drawingml/2006/main" r:embed="R8bb8bf5600394c40"/>
           <a:stretch xmlns:a="http://schemas.openxmlformats.org/drawingml/2006/main"/>
         </p:blipFill>
         <p:spPr>
           <a:xfrm xmlns:a="http://schemas.openxmlformats.org/drawingml/2006/main">
-            <a:off x="6267450" y="1952625"/>
+            <a:off x="4381500" y="1952625"/>
             <a:ext cx="571500" cy="571500"/>
           </a:xfrm>
           <a:prstGeom xmlns:a="http://schemas.openxmlformats.org/drawingml/2006/main" prst="rect">
@@ -3872,7 +3872,7 @@
           <p:cNvPr id="9" name="">
             <a:extLst xmlns:a="http://schemas.openxmlformats.org/drawingml/2006/main">
               <a:ext uri="{FF2B5EF4-FFF2-40B4-BE49-F238E27FC236}">
-                <a16:creationId xmlns:a16="http://schemas.microsoft.com/office/drawing/2014/main" id="{32A5297E-3970-44D6-829A-6E5FAB5E1C4C}"/>
+                <a16:creationId xmlns:a16="http://schemas.microsoft.com/office/drawing/2014/main" id="{015E85DE-0997-41A9-B869-C2C1AD1DB91F}"/>
               </a:ext>
             </a:extLst>
           </p:cNvPr>
@@ -3883,8 +3883,8 @@
         </p:nvSpPr>
         <p:spPr>
           <a:xfrm xmlns:a="http://schemas.openxmlformats.org/drawingml/2006/main">
-            <a:off x="6267450" y="2667000"/>
-            <a:ext cx="5295900" cy="495300"/>
+            <a:off x="4381500" y="2667000"/>
+            <a:ext cx="3409950" cy="495300"/>
           </a:xfrm>
           <a:prstGeom xmlns:a="http://schemas.openxmlformats.org/drawingml/2006/main" prst="rect">
             <a:avLst/>
@@ -4020,7 +4020,7 @@
                 <a:ea typeface="Arial"/>
                 <a:cs typeface="Arial"/>
               </a:rPr>
-              <a:t>Arta</a:t>
+              <a:t>Si do ta zbërthejmë</a:t>
             </a:r>
           </a:p>
         </p:txBody>
@@ -4030,7 +4030,7 @@
           <p:cNvPr id="10" name="">
             <a:extLst xmlns:a="http://schemas.openxmlformats.org/drawingml/2006/main">
               <a:ext uri="{FF2B5EF4-FFF2-40B4-BE49-F238E27FC236}">
-                <a16:creationId xmlns:a16="http://schemas.microsoft.com/office/drawing/2014/main" id="{E594C630-C950-4FB7-8714-ADFDEC3D6F25}"/>
+                <a16:creationId xmlns:a16="http://schemas.microsoft.com/office/drawing/2014/main" id="{31F781DE-AECD-4977-94A8-AD8047CDCF92}"/>
               </a:ext>
             </a:extLst>
           </p:cNvPr>
@@ -4041,8 +4041,8 @@
         </p:nvSpPr>
         <p:spPr>
           <a:xfrm xmlns:a="http://schemas.openxmlformats.org/drawingml/2006/main">
-            <a:off x="6267450" y="3219450"/>
-            <a:ext cx="5295900" cy="571500"/>
+            <a:off x="4381500" y="3219450"/>
+            <a:ext cx="3409950" cy="571500"/>
           </a:xfrm>
           <a:prstGeom xmlns:a="http://schemas.openxmlformats.org/drawingml/2006/main" prst="rect">
             <a:avLst/>
@@ -4178,17 +4178,361 @@
                 <a:ea typeface="Arial"/>
                 <a:cs typeface="Arial"/>
               </a:rPr>
-              <a:t>Udhëtarja që kërkon vend</a:t>
+              <a:t>Demonstrim, votime dhe prova</a:t>
+            </a:r>
+          </a:p>
+        </p:txBody>
+      </p:sp>
+      <p:pic>
+        <p:nvPicPr>
+          <p:cNvPr id="11" name="">
+            <a:extLst xmlns:a="http://schemas.openxmlformats.org/drawingml/2006/main">
+              <a:ext uri="{FF2B5EF4-FFF2-40B4-BE49-F238E27FC236}">
+                <a16:creationId xmlns:a16="http://schemas.microsoft.com/office/drawing/2014/main" id="{90EED3A6-4644-4F9B-BB2B-0B6E97E1E204}"/>
+              </a:ext>
+            </a:extLst>
+          </p:cNvPr>
+          <p:cNvPicPr>
+            <a:picLocks xmlns:a="http://schemas.openxmlformats.org/drawingml/2006/main" noChangeAspect="1"/>
+          </p:cNvPicPr>
+          <p:nvPr/>
+        </p:nvPicPr>
+        <p:blipFill>
+          <a:blip xmlns:r="http://schemas.openxmlformats.org/officeDocument/2006/relationships" xmlns:a="http://schemas.openxmlformats.org/drawingml/2006/main" r:embed="Rf567afa41db943fb"/>
+          <a:stretch xmlns:a="http://schemas.openxmlformats.org/drawingml/2006/main"/>
+        </p:blipFill>
+        <p:spPr>
+          <a:xfrm xmlns:a="http://schemas.openxmlformats.org/drawingml/2006/main">
+            <a:off x="8153400" y="1952625"/>
+            <a:ext cx="571500" cy="571500"/>
+          </a:xfrm>
+          <a:prstGeom xmlns:a="http://schemas.openxmlformats.org/drawingml/2006/main" prst="rect">
+            <a:avLst/>
+          </a:prstGeom>
+        </p:spPr>
+      </p:pic>
+      <p:sp>
+        <p:nvSpPr>
+          <p:cNvPr id="12" name="">
+            <a:extLst xmlns:a="http://schemas.openxmlformats.org/drawingml/2006/main">
+              <a:ext uri="{FF2B5EF4-FFF2-40B4-BE49-F238E27FC236}">
+                <a16:creationId xmlns:a16="http://schemas.microsoft.com/office/drawing/2014/main" id="{E6C765A6-D1C3-4D7D-BB4B-6ADB8FE8A69F}"/>
+              </a:ext>
+            </a:extLst>
+          </p:cNvPr>
+          <p:cNvSpPr>
+            <a:spLocks xmlns:a="http://schemas.openxmlformats.org/drawingml/2006/main" noGrp="1"/>
+          </p:cNvSpPr>
+          <p:nvPr/>
+        </p:nvSpPr>
+        <p:spPr>
+          <a:xfrm xmlns:a="http://schemas.openxmlformats.org/drawingml/2006/main">
+            <a:off x="8153400" y="2667000"/>
+            <a:ext cx="3409950" cy="495300"/>
+          </a:xfrm>
+          <a:prstGeom xmlns:a="http://schemas.openxmlformats.org/drawingml/2006/main" prst="rect">
+            <a:avLst/>
+          </a:prstGeom>
+          <a:noFill xmlns:a="http://schemas.openxmlformats.org/drawingml/2006/main"/>
+          <a:ln xmlns:a="http://schemas.openxmlformats.org/drawingml/2006/main" w="0">
+            <a:noFill/>
+          </a:ln>
+        </p:spPr>
+        <p:txBody>
+          <a:bodyPr xmlns:a="http://schemas.openxmlformats.org/drawingml/2006/main">
+            <a:noAutofit/>
+          </a:bodyPr>
+          <a:lstStyle xmlns:a="http://schemas.openxmlformats.org/drawingml/2006/main">
+            <a:defPPr>
+              <a:defRPr sz="2025" b="1">
+                <a:solidFill>
+                  <a:srgbClr val="FFFFFF"/>
+                </a:solidFill>
+                <a:latin typeface="Arial"/>
+                <a:ea typeface="Arial"/>
+                <a:cs typeface="Arial"/>
+              </a:defRPr>
+            </a:defPPr>
+            <a:lvl1pPr>
+              <a:defRPr sz="2025" b="1">
+                <a:solidFill>
+                  <a:srgbClr val="FFFFFF"/>
+                </a:solidFill>
+                <a:latin typeface="Arial"/>
+                <a:ea typeface="Arial"/>
+                <a:cs typeface="Arial"/>
+              </a:defRPr>
+            </a:lvl1pPr>
+            <a:lvl2pPr>
+              <a:defRPr sz="2025" b="1">
+                <a:solidFill>
+                  <a:srgbClr val="FFFFFF"/>
+                </a:solidFill>
+                <a:latin typeface="Arial"/>
+                <a:ea typeface="Arial"/>
+                <a:cs typeface="Arial"/>
+              </a:defRPr>
+            </a:lvl2pPr>
+            <a:lvl3pPr>
+              <a:defRPr sz="2025" b="1">
+                <a:solidFill>
+                  <a:srgbClr val="FFFFFF"/>
+                </a:solidFill>
+                <a:latin typeface="Arial"/>
+                <a:ea typeface="Arial"/>
+                <a:cs typeface="Arial"/>
+              </a:defRPr>
+            </a:lvl3pPr>
+            <a:lvl4pPr>
+              <a:defRPr sz="2025" b="1">
+                <a:solidFill>
+                  <a:srgbClr val="FFFFFF"/>
+                </a:solidFill>
+                <a:latin typeface="Arial"/>
+                <a:ea typeface="Arial"/>
+                <a:cs typeface="Arial"/>
+              </a:defRPr>
+            </a:lvl4pPr>
+            <a:lvl5pPr>
+              <a:defRPr sz="2025" b="1">
+                <a:solidFill>
+                  <a:srgbClr val="FFFFFF"/>
+                </a:solidFill>
+                <a:latin typeface="Arial"/>
+                <a:ea typeface="Arial"/>
+                <a:cs typeface="Arial"/>
+              </a:defRPr>
+            </a:lvl5pPr>
+            <a:lvl6pPr>
+              <a:defRPr sz="2025" b="1">
+                <a:solidFill>
+                  <a:srgbClr val="FFFFFF"/>
+                </a:solidFill>
+                <a:latin typeface="Arial"/>
+                <a:ea typeface="Arial"/>
+                <a:cs typeface="Arial"/>
+              </a:defRPr>
+            </a:lvl6pPr>
+            <a:lvl7pPr>
+              <a:defRPr sz="2025" b="1">
+                <a:solidFill>
+                  <a:srgbClr val="FFFFFF"/>
+                </a:solidFill>
+                <a:latin typeface="Arial"/>
+                <a:ea typeface="Arial"/>
+                <a:cs typeface="Arial"/>
+              </a:defRPr>
+            </a:lvl7pPr>
+            <a:lvl8pPr>
+              <a:defRPr sz="2025" b="1">
+                <a:solidFill>
+                  <a:srgbClr val="FFFFFF"/>
+                </a:solidFill>
+                <a:latin typeface="Arial"/>
+                <a:ea typeface="Arial"/>
+                <a:cs typeface="Arial"/>
+              </a:defRPr>
+            </a:lvl8pPr>
+            <a:lvl9pPr>
+              <a:defRPr sz="2025" b="1">
+                <a:solidFill>
+                  <a:srgbClr val="FFFFFF"/>
+                </a:solidFill>
+                <a:latin typeface="Arial"/>
+                <a:ea typeface="Arial"/>
+                <a:cs typeface="Arial"/>
+              </a:defRPr>
+            </a:lvl9pPr>
+          </a:lstStyle>
+          <a:p xmlns:a="http://schemas.openxmlformats.org/drawingml/2006/main">
+            <a:pPr>
+              <a:defRPr sz="2025" b="1">
+                <a:solidFill>
+                  <a:srgbClr val="FFFFFF"/>
+                </a:solidFill>
+                <a:latin typeface="Arial"/>
+                <a:ea typeface="Arial"/>
+                <a:cs typeface="Arial"/>
+              </a:defRPr>
+            </a:pPr>
+            <a:r>
+              <a:rPr sz="2025" b="1">
+                <a:solidFill>
+                  <a:srgbClr val="FFFFFF"/>
+                </a:solidFill>
+                <a:latin typeface="Arial"/>
+                <a:ea typeface="Arial"/>
+                <a:cs typeface="Arial"/>
+              </a:rPr>
+              <a:t>Në fund do të mundesh</a:t>
             </a:r>
           </a:p>
         </p:txBody>
       </p:sp>
       <p:sp>
         <p:nvSpPr>
-          <p:cNvPr id="11" name="">
+          <p:cNvPr id="13" name="">
             <a:extLst xmlns:a="http://schemas.openxmlformats.org/drawingml/2006/main">
               <a:ext uri="{FF2B5EF4-FFF2-40B4-BE49-F238E27FC236}">
-                <a16:creationId xmlns:a16="http://schemas.microsoft.com/office/drawing/2014/main" id="{BB92DCF5-4E9E-4E58-B8BB-445D837C3B96}"/>
+                <a16:creationId xmlns:a16="http://schemas.microsoft.com/office/drawing/2014/main" id="{7B934DF7-C621-49E6-A6B9-6FF8E02A8371}"/>
+              </a:ext>
+            </a:extLst>
+          </p:cNvPr>
+          <p:cNvSpPr>
+            <a:spLocks xmlns:a="http://schemas.openxmlformats.org/drawingml/2006/main" noGrp="1"/>
+          </p:cNvSpPr>
+          <p:nvPr/>
+        </p:nvSpPr>
+        <p:spPr>
+          <a:xfrm xmlns:a="http://schemas.openxmlformats.org/drawingml/2006/main">
+            <a:off x="8153400" y="3219450"/>
+            <a:ext cx="3409950" cy="571500"/>
+          </a:xfrm>
+          <a:prstGeom xmlns:a="http://schemas.openxmlformats.org/drawingml/2006/main" prst="rect">
+            <a:avLst/>
+          </a:prstGeom>
+          <a:noFill xmlns:a="http://schemas.openxmlformats.org/drawingml/2006/main"/>
+          <a:ln xmlns:a="http://schemas.openxmlformats.org/drawingml/2006/main" w="0">
+            <a:noFill/>
+          </a:ln>
+        </p:spPr>
+        <p:txBody>
+          <a:bodyPr xmlns:a="http://schemas.openxmlformats.org/drawingml/2006/main">
+            <a:noAutofit/>
+          </a:bodyPr>
+          <a:lstStyle xmlns:a="http://schemas.openxmlformats.org/drawingml/2006/main">
+            <a:defPPr>
+              <a:defRPr sz="1650" b="0">
+                <a:solidFill>
+                  <a:srgbClr val="C8D3E6"/>
+                </a:solidFill>
+                <a:latin typeface="Arial"/>
+                <a:ea typeface="Arial"/>
+                <a:cs typeface="Arial"/>
+              </a:defRPr>
+            </a:defPPr>
+            <a:lvl1pPr>
+              <a:defRPr sz="1650" b="0">
+                <a:solidFill>
+                  <a:srgbClr val="C8D3E6"/>
+                </a:solidFill>
+                <a:latin typeface="Arial"/>
+                <a:ea typeface="Arial"/>
+                <a:cs typeface="Arial"/>
+              </a:defRPr>
+            </a:lvl1pPr>
+            <a:lvl2pPr>
+              <a:defRPr sz="1650" b="0">
+                <a:solidFill>
+                  <a:srgbClr val="C8D3E6"/>
+                </a:solidFill>
+                <a:latin typeface="Arial"/>
+                <a:ea typeface="Arial"/>
+                <a:cs typeface="Arial"/>
+              </a:defRPr>
+            </a:lvl2pPr>
+            <a:lvl3pPr>
+              <a:defRPr sz="1650" b="0">
+                <a:solidFill>
+                  <a:srgbClr val="C8D3E6"/>
+                </a:solidFill>
+                <a:latin typeface="Arial"/>
+                <a:ea typeface="Arial"/>
+                <a:cs typeface="Arial"/>
+              </a:defRPr>
+            </a:lvl3pPr>
+            <a:lvl4pPr>
+              <a:defRPr sz="1650" b="0">
+                <a:solidFill>
+                  <a:srgbClr val="C8D3E6"/>
+                </a:solidFill>
+                <a:latin typeface="Arial"/>
+                <a:ea typeface="Arial"/>
+                <a:cs typeface="Arial"/>
+              </a:defRPr>
+            </a:lvl4pPr>
+            <a:lvl5pPr>
+              <a:defRPr sz="1650" b="0">
+                <a:solidFill>
+                  <a:srgbClr val="C8D3E6"/>
+                </a:solidFill>
+                <a:latin typeface="Arial"/>
+                <a:ea typeface="Arial"/>
+                <a:cs typeface="Arial"/>
+              </a:defRPr>
+            </a:lvl5pPr>
+            <a:lvl6pPr>
+              <a:defRPr sz="1650" b="0">
+                <a:solidFill>
+                  <a:srgbClr val="C8D3E6"/>
+                </a:solidFill>
+                <a:latin typeface="Arial"/>
+                <a:ea typeface="Arial"/>
+                <a:cs typeface="Arial"/>
+              </a:defRPr>
+            </a:lvl6pPr>
+            <a:lvl7pPr>
+              <a:defRPr sz="1650" b="0">
+                <a:solidFill>
+                  <a:srgbClr val="C8D3E6"/>
+                </a:solidFill>
+                <a:latin typeface="Arial"/>
+                <a:ea typeface="Arial"/>
+                <a:cs typeface="Arial"/>
+              </a:defRPr>
+            </a:lvl7pPr>
+            <a:lvl8pPr>
+              <a:defRPr sz="1650" b="0">
+                <a:solidFill>
+                  <a:srgbClr val="C8D3E6"/>
+                </a:solidFill>
+                <a:latin typeface="Arial"/>
+                <a:ea typeface="Arial"/>
+                <a:cs typeface="Arial"/>
+              </a:defRPr>
+            </a:lvl8pPr>
+            <a:lvl9pPr>
+              <a:defRPr sz="1650" b="0">
+                <a:solidFill>
+                  <a:srgbClr val="C8D3E6"/>
+                </a:solidFill>
+                <a:latin typeface="Arial"/>
+                <a:ea typeface="Arial"/>
+                <a:cs typeface="Arial"/>
+              </a:defRPr>
+            </a:lvl9pPr>
+          </a:lstStyle>
+          <a:p xmlns:a="http://schemas.openxmlformats.org/drawingml/2006/main">
+            <a:pPr>
+              <a:defRPr sz="1650" b="0">
+                <a:solidFill>
+                  <a:srgbClr val="C8D3E6"/>
+                </a:solidFill>
+                <a:latin typeface="Arial"/>
+                <a:ea typeface="Arial"/>
+                <a:cs typeface="Arial"/>
+              </a:defRPr>
+            </a:pPr>
+            <a:r>
+              <a:rPr sz="1650" b="0">
+                <a:solidFill>
+                  <a:srgbClr val="C8D3E6"/>
+                </a:solidFill>
+                <a:latin typeface="Arial"/>
+                <a:ea typeface="Arial"/>
+                <a:cs typeface="Arial"/>
+              </a:rPr>
+              <a:t>Të shpjegosh e të provosh një korrigjim</a:t>
+            </a:r>
+          </a:p>
+        </p:txBody>
+      </p:sp>
+      <p:sp>
+        <p:nvSpPr>
+          <p:cNvPr id="14" name="">
+            <a:extLst xmlns:a="http://schemas.openxmlformats.org/drawingml/2006/main">
+              <a:ext uri="{FF2B5EF4-FFF2-40B4-BE49-F238E27FC236}">
+                <a16:creationId xmlns:a16="http://schemas.microsoft.com/office/drawing/2014/main" id="{0646C069-DC53-4EF3-A84B-7BBB980A3429}"/>
               </a:ext>
             </a:extLst>
           </p:cNvPr>
@@ -4336,7 +4680,7 @@
                 <a:ea typeface="Arial"/>
                 <a:cs typeface="Arial"/>
               </a:rPr>
-              <a:t>Dritoni ofron 2 vende në veturë drejt AAB-së. Arta hap RideShare për të kërkuar njërin.</a:t>
+              <a:t>MVP (Minimum Viable Product) do të thotë produkti minimal i përdorshëm.</a:t>
             </a:r>
           </a:p>
           <a:p xmlns:a="http://schemas.openxmlformats.org/drawingml/2006/main">
@@ -4364,7 +4708,7 @@
                 <a:ea typeface="Arial"/>
                 <a:cs typeface="Arial"/>
               </a:rPr>
-              <a:t>Sot luajmë rolin e përdoruesit dhe provojmë produktin që kemi ndërtuar.</a:t>
+              <a:t>Në fund do të shpjegosh rrjedhën e aplikacionit, të dallosh një problem dhe të provosh korrigjimin.</a:t>
             </a:r>
           </a:p>
         </p:txBody>
@@ -4372,7 +4716,7 @@
     </p:spTree>
     <p:extLst>
       <p:ext uri="{BB962C8B-B14F-4D97-AF65-F5344CB8AC3E}">
-        <p14:creationId xmlns:p14="http://schemas.microsoft.com/office/powerpoint/2010/main" val="2058590411"/>
+        <p14:creationId xmlns:p14="http://schemas.microsoft.com/office/powerpoint/2010/main" val="1750868273"/>
       </p:ext>
     </p:extLst>
   </p:cSld>
@@ -4403,7 +4747,7 @@
           <p:cNvPr id="14" name="">
             <a:extLst xmlns:a="http://schemas.openxmlformats.org/drawingml/2006/main">
               <a:ext uri="{FF2B5EF4-FFF2-40B4-BE49-F238E27FC236}">
-                <a16:creationId xmlns:a16="http://schemas.microsoft.com/office/drawing/2014/main" id="{BB61E350-5DD1-4BB5-B966-8169A8BC60AE}"/>
+                <a16:creationId xmlns:a16="http://schemas.microsoft.com/office/drawing/2014/main" id="{3FF1ACFE-E853-4C21-AB5C-1CE7825CF5A7}"/>
               </a:ext>
             </a:extLst>
           </p:cNvPr>
@@ -4561,7 +4905,7 @@
           <p:cNvPr id="2" name="">
             <a:extLst xmlns:a="http://schemas.openxmlformats.org/drawingml/2006/main">
               <a:ext uri="{FF2B5EF4-FFF2-40B4-BE49-F238E27FC236}">
-                <a16:creationId xmlns:a16="http://schemas.microsoft.com/office/drawing/2014/main" id="{F68C6B2A-437A-4AB6-AA57-E4533C13091F}"/>
+                <a16:creationId xmlns:a16="http://schemas.microsoft.com/office/drawing/2014/main" id="{D30E70B0-9A44-4371-B3AE-BDE1D83A2BDB}"/>
               </a:ext>
             </a:extLst>
           </p:cNvPr>
@@ -4719,7 +5063,7 @@
           <p:cNvPr id="3" name="">
             <a:extLst xmlns:a="http://schemas.openxmlformats.org/drawingml/2006/main">
               <a:ext uri="{FF2B5EF4-FFF2-40B4-BE49-F238E27FC236}">
-                <a16:creationId xmlns:a16="http://schemas.microsoft.com/office/drawing/2014/main" id="{4A2C534C-F209-44FF-B6EB-EE781C0BDA48}"/>
+                <a16:creationId xmlns:a16="http://schemas.microsoft.com/office/drawing/2014/main" id="{5A09D370-068E-430E-B9FF-040990C23D3C}"/>
               </a:ext>
             </a:extLst>
           </p:cNvPr>
@@ -4877,7 +5221,7 @@
           <p:cNvPr id="4" name="">
             <a:extLst xmlns:a="http://schemas.openxmlformats.org/drawingml/2006/main">
               <a:ext uri="{FF2B5EF4-FFF2-40B4-BE49-F238E27FC236}">
-                <a16:creationId xmlns:a16="http://schemas.microsoft.com/office/drawing/2014/main" id="{E50CA957-4A09-402F-BF3A-C694C97CFD8D}"/>
+                <a16:creationId xmlns:a16="http://schemas.microsoft.com/office/drawing/2014/main" id="{2CC5647F-A998-4FDA-9385-E6E53CE6310D}"/>
               </a:ext>
             </a:extLst>
           </p:cNvPr>
@@ -4887,7 +5231,7 @@
           <p:nvPr/>
         </p:nvPicPr>
         <p:blipFill>
-          <a:blip xmlns:r="http://schemas.openxmlformats.org/officeDocument/2006/relationships" xmlns:a="http://schemas.openxmlformats.org/drawingml/2006/main" r:embed="R5bd72ec2fe5a4f0e"/>
+          <a:blip xmlns:r="http://schemas.openxmlformats.org/officeDocument/2006/relationships" xmlns:a="http://schemas.openxmlformats.org/drawingml/2006/main" r:embed="Rdac3d0151e4a44d8"/>
           <a:stretch xmlns:a="http://schemas.openxmlformats.org/drawingml/2006/main"/>
         </p:blipFill>
         <p:spPr>
@@ -4905,7 +5249,7 @@
           <p:cNvPr id="5" name="">
             <a:extLst xmlns:a="http://schemas.openxmlformats.org/drawingml/2006/main">
               <a:ext uri="{FF2B5EF4-FFF2-40B4-BE49-F238E27FC236}">
-                <a16:creationId xmlns:a16="http://schemas.microsoft.com/office/drawing/2014/main" id="{A1A64D7F-BAE3-49F8-9E72-C7B84939D24F}"/>
+                <a16:creationId xmlns:a16="http://schemas.microsoft.com/office/drawing/2014/main" id="{33454821-EDFE-4C8E-BD0B-69966178AEA5}"/>
               </a:ext>
             </a:extLst>
           </p:cNvPr>
@@ -5063,7 +5407,7 @@
           <p:cNvPr id="6" name="">
             <a:extLst xmlns:a="http://schemas.openxmlformats.org/drawingml/2006/main">
               <a:ext uri="{FF2B5EF4-FFF2-40B4-BE49-F238E27FC236}">
-                <a16:creationId xmlns:a16="http://schemas.microsoft.com/office/drawing/2014/main" id="{6D45D747-6E34-46DB-A51F-121AECF846BC}"/>
+                <a16:creationId xmlns:a16="http://schemas.microsoft.com/office/drawing/2014/main" id="{1DF7A7D0-A9E2-4146-8E4B-53085F35A6A4}"/>
               </a:ext>
             </a:extLst>
           </p:cNvPr>
@@ -5221,7 +5565,7 @@
           <p:cNvPr id="7" name="">
             <a:extLst xmlns:a="http://schemas.openxmlformats.org/drawingml/2006/main">
               <a:ext uri="{FF2B5EF4-FFF2-40B4-BE49-F238E27FC236}">
-                <a16:creationId xmlns:a16="http://schemas.microsoft.com/office/drawing/2014/main" id="{8E7162A1-0C07-40E0-B1BD-10423D57628C}"/>
+                <a16:creationId xmlns:a16="http://schemas.microsoft.com/office/drawing/2014/main" id="{C5193A2F-8707-4EBD-9513-6F495B51F11C}"/>
               </a:ext>
             </a:extLst>
           </p:cNvPr>
@@ -5231,7 +5575,7 @@
           <p:nvPr/>
         </p:nvPicPr>
         <p:blipFill>
-          <a:blip xmlns:r="http://schemas.openxmlformats.org/officeDocument/2006/relationships" xmlns:a="http://schemas.openxmlformats.org/drawingml/2006/main" r:embed="Rf2dc154f7da14362"/>
+          <a:blip xmlns:r="http://schemas.openxmlformats.org/officeDocument/2006/relationships" xmlns:a="http://schemas.openxmlformats.org/drawingml/2006/main" r:embed="R4d21bca71db84785"/>
           <a:stretch xmlns:a="http://schemas.openxmlformats.org/drawingml/2006/main"/>
         </p:blipFill>
         <p:spPr>
@@ -5249,7 +5593,7 @@
           <p:cNvPr id="8" name="">
             <a:extLst xmlns:a="http://schemas.openxmlformats.org/drawingml/2006/main">
               <a:ext uri="{FF2B5EF4-FFF2-40B4-BE49-F238E27FC236}">
-                <a16:creationId xmlns:a16="http://schemas.microsoft.com/office/drawing/2014/main" id="{56D61B21-B80F-483C-8D9F-D558D25EC35E}"/>
+                <a16:creationId xmlns:a16="http://schemas.microsoft.com/office/drawing/2014/main" id="{222A4C1B-6825-4DE7-9D7C-DC57F23D4CB4}"/>
               </a:ext>
             </a:extLst>
           </p:cNvPr>
@@ -5407,7 +5751,7 @@
           <p:cNvPr id="9" name="">
             <a:extLst xmlns:a="http://schemas.openxmlformats.org/drawingml/2006/main">
               <a:ext uri="{FF2B5EF4-FFF2-40B4-BE49-F238E27FC236}">
-                <a16:creationId xmlns:a16="http://schemas.microsoft.com/office/drawing/2014/main" id="{E74738F7-DEAF-4C24-BCD9-0B9A00DB5DF7}"/>
+                <a16:creationId xmlns:a16="http://schemas.microsoft.com/office/drawing/2014/main" id="{3E7A66F8-5362-4303-8C9D-7295058B96A4}"/>
               </a:ext>
             </a:extLst>
           </p:cNvPr>
@@ -5565,7 +5909,7 @@
           <p:cNvPr id="10" name="">
             <a:extLst xmlns:a="http://schemas.openxmlformats.org/drawingml/2006/main">
               <a:ext uri="{FF2B5EF4-FFF2-40B4-BE49-F238E27FC236}">
-                <a16:creationId xmlns:a16="http://schemas.microsoft.com/office/drawing/2014/main" id="{239FEF52-E870-4625-BBED-D56E9A9C148F}"/>
+                <a16:creationId xmlns:a16="http://schemas.microsoft.com/office/drawing/2014/main" id="{E88A4C2E-AB0D-45BD-A636-A296F3EE7B45}"/>
               </a:ext>
             </a:extLst>
           </p:cNvPr>
@@ -5723,7 +6067,7 @@
           <p:cNvPr id="11" name="">
             <a:extLst xmlns:a="http://schemas.openxmlformats.org/drawingml/2006/main">
               <a:ext uri="{FF2B5EF4-FFF2-40B4-BE49-F238E27FC236}">
-                <a16:creationId xmlns:a16="http://schemas.microsoft.com/office/drawing/2014/main" id="{8B93499F-8D5B-4AFA-8D3A-21E9872AA831}"/>
+                <a16:creationId xmlns:a16="http://schemas.microsoft.com/office/drawing/2014/main" id="{01F2E7EC-2CF9-4065-8C88-7406F920A7FE}"/>
               </a:ext>
             </a:extLst>
           </p:cNvPr>
@@ -5881,7 +6225,7 @@
           <p:cNvPr id="12" name="">
             <a:extLst xmlns:a="http://schemas.openxmlformats.org/drawingml/2006/main">
               <a:ext uri="{FF2B5EF4-FFF2-40B4-BE49-F238E27FC236}">
-                <a16:creationId xmlns:a16="http://schemas.microsoft.com/office/drawing/2014/main" id="{4856AC6E-A51A-4B93-91AF-9F52BDAAB806}"/>
+                <a16:creationId xmlns:a16="http://schemas.microsoft.com/office/drawing/2014/main" id="{8458DF67-8B9A-47DF-B001-E8477CD8D96A}"/>
               </a:ext>
             </a:extLst>
           </p:cNvPr>
@@ -6085,7 +6429,7 @@
           <p:cNvPr id="13" name="">
             <a:extLst xmlns:a="http://schemas.openxmlformats.org/drawingml/2006/main">
               <a:ext uri="{FF2B5EF4-FFF2-40B4-BE49-F238E27FC236}">
-                <a16:creationId xmlns:a16="http://schemas.microsoft.com/office/drawing/2014/main" id="{AE65A8AE-3FA7-4493-81B8-3E82352C9E82}"/>
+                <a16:creationId xmlns:a16="http://schemas.microsoft.com/office/drawing/2014/main" id="{B185FFAC-F278-41E8-837F-2E5F34AA3892}"/>
               </a:ext>
             </a:extLst>
           </p:cNvPr>
@@ -6241,7 +6585,7 @@
     </p:spTree>
     <p:extLst>
       <p:ext uri="{BB962C8B-B14F-4D97-AF65-F5344CB8AC3E}">
-        <p14:creationId xmlns:p14="http://schemas.microsoft.com/office/powerpoint/2010/main" val="666698916"/>
+        <p14:creationId xmlns:p14="http://schemas.microsoft.com/office/powerpoint/2010/main" val="559790647"/>
       </p:ext>
     </p:extLst>
   </p:cSld>
@@ -6272,7 +6616,7 @@
           <p:cNvPr id="14" name="">
             <a:extLst xmlns:a="http://schemas.openxmlformats.org/drawingml/2006/main">
               <a:ext uri="{FF2B5EF4-FFF2-40B4-BE49-F238E27FC236}">
-                <a16:creationId xmlns:a16="http://schemas.microsoft.com/office/drawing/2014/main" id="{E5671B4C-3E18-4A44-9522-BF789FE2CE1E}"/>
+                <a16:creationId xmlns:a16="http://schemas.microsoft.com/office/drawing/2014/main" id="{181620A3-F1F4-4347-9F30-62C2449F7ADE}"/>
               </a:ext>
             </a:extLst>
           </p:cNvPr>
@@ -6430,7 +6774,7 @@
           <p:cNvPr id="2" name="">
             <a:extLst xmlns:a="http://schemas.openxmlformats.org/drawingml/2006/main">
               <a:ext uri="{FF2B5EF4-FFF2-40B4-BE49-F238E27FC236}">
-                <a16:creationId xmlns:a16="http://schemas.microsoft.com/office/drawing/2014/main" id="{77D5B974-4F6B-4870-82EF-80C941C0861D}"/>
+                <a16:creationId xmlns:a16="http://schemas.microsoft.com/office/drawing/2014/main" id="{DF2ADDE0-2B60-43DF-844B-C6CA77EADB56}"/>
               </a:ext>
             </a:extLst>
           </p:cNvPr>
@@ -6588,7 +6932,7 @@
           <p:cNvPr id="3" name="">
             <a:extLst xmlns:a="http://schemas.openxmlformats.org/drawingml/2006/main">
               <a:ext uri="{FF2B5EF4-FFF2-40B4-BE49-F238E27FC236}">
-                <a16:creationId xmlns:a16="http://schemas.microsoft.com/office/drawing/2014/main" id="{251AF38C-61BC-478C-8D22-B31218A63944}"/>
+                <a16:creationId xmlns:a16="http://schemas.microsoft.com/office/drawing/2014/main" id="{F1898D7A-99E2-4883-9AEC-0413F7C03FB5}"/>
               </a:ext>
             </a:extLst>
           </p:cNvPr>
@@ -6746,7 +7090,7 @@
           <p:cNvPr id="4" name="">
             <a:extLst xmlns:a="http://schemas.openxmlformats.org/drawingml/2006/main">
               <a:ext uri="{FF2B5EF4-FFF2-40B4-BE49-F238E27FC236}">
-                <a16:creationId xmlns:a16="http://schemas.microsoft.com/office/drawing/2014/main" id="{23B28475-99AA-4953-8B63-CB4AD5A919C2}"/>
+                <a16:creationId xmlns:a16="http://schemas.microsoft.com/office/drawing/2014/main" id="{5070A864-2578-4B0D-B462-DEDC8E836BDE}"/>
               </a:ext>
             </a:extLst>
           </p:cNvPr>
@@ -6756,7 +7100,7 @@
           <p:nvPr/>
         </p:nvPicPr>
         <p:blipFill>
-          <a:blip xmlns:r="http://schemas.openxmlformats.org/officeDocument/2006/relationships" xmlns:a="http://schemas.openxmlformats.org/drawingml/2006/main" r:embed="Rf5b6a4520a5d425c"/>
+          <a:blip xmlns:r="http://schemas.openxmlformats.org/officeDocument/2006/relationships" xmlns:a="http://schemas.openxmlformats.org/drawingml/2006/main" r:embed="Rbef2aa66ac064616"/>
           <a:stretch xmlns:a="http://schemas.openxmlformats.org/drawingml/2006/main"/>
         </p:blipFill>
         <p:spPr>
@@ -6774,7 +7118,7 @@
           <p:cNvPr id="5" name="">
             <a:extLst xmlns:a="http://schemas.openxmlformats.org/drawingml/2006/main">
               <a:ext uri="{FF2B5EF4-FFF2-40B4-BE49-F238E27FC236}">
-                <a16:creationId xmlns:a16="http://schemas.microsoft.com/office/drawing/2014/main" id="{4B8CCA39-9D3E-4A07-87D9-9AD1A85B2A71}"/>
+                <a16:creationId xmlns:a16="http://schemas.microsoft.com/office/drawing/2014/main" id="{BD09134F-0BD9-49A4-A648-21B635F68FD9}"/>
               </a:ext>
             </a:extLst>
           </p:cNvPr>
@@ -6932,7 +7276,7 @@
           <p:cNvPr id="6" name="">
             <a:extLst xmlns:a="http://schemas.openxmlformats.org/drawingml/2006/main">
               <a:ext uri="{FF2B5EF4-FFF2-40B4-BE49-F238E27FC236}">
-                <a16:creationId xmlns:a16="http://schemas.microsoft.com/office/drawing/2014/main" id="{AE25FB77-E37A-4972-930D-CCFB2D9C7FD1}"/>
+                <a16:creationId xmlns:a16="http://schemas.microsoft.com/office/drawing/2014/main" id="{10D997DC-E2A3-435D-8C50-2A7681CB8C52}"/>
               </a:ext>
             </a:extLst>
           </p:cNvPr>
@@ -7090,7 +7434,7 @@
           <p:cNvPr id="7" name="">
             <a:extLst xmlns:a="http://schemas.openxmlformats.org/drawingml/2006/main">
               <a:ext uri="{FF2B5EF4-FFF2-40B4-BE49-F238E27FC236}">
-                <a16:creationId xmlns:a16="http://schemas.microsoft.com/office/drawing/2014/main" id="{4E6EBCDD-9281-48BB-9C8A-E1ED76ED417A}"/>
+                <a16:creationId xmlns:a16="http://schemas.microsoft.com/office/drawing/2014/main" id="{3300B78C-18E1-45AE-AA00-B23D6200852F}"/>
               </a:ext>
             </a:extLst>
           </p:cNvPr>
@@ -7100,7 +7444,7 @@
           <p:nvPr/>
         </p:nvPicPr>
         <p:blipFill>
-          <a:blip xmlns:r="http://schemas.openxmlformats.org/officeDocument/2006/relationships" xmlns:a="http://schemas.openxmlformats.org/drawingml/2006/main" r:embed="R8d29232ebb8e4b4b"/>
+          <a:blip xmlns:r="http://schemas.openxmlformats.org/officeDocument/2006/relationships" xmlns:a="http://schemas.openxmlformats.org/drawingml/2006/main" r:embed="R06e03070a8874315"/>
           <a:stretch xmlns:a="http://schemas.openxmlformats.org/drawingml/2006/main"/>
         </p:blipFill>
         <p:spPr>
@@ -7118,7 +7462,7 @@
           <p:cNvPr id="8" name="">
             <a:extLst xmlns:a="http://schemas.openxmlformats.org/drawingml/2006/main">
               <a:ext uri="{FF2B5EF4-FFF2-40B4-BE49-F238E27FC236}">
-                <a16:creationId xmlns:a16="http://schemas.microsoft.com/office/drawing/2014/main" id="{DDCFD9B7-56D0-40E1-9011-ABEBBCFFF92C}"/>
+                <a16:creationId xmlns:a16="http://schemas.microsoft.com/office/drawing/2014/main" id="{1FECC0BB-AC70-49DB-85B3-669C3E02D00F}"/>
               </a:ext>
             </a:extLst>
           </p:cNvPr>
@@ -7276,7 +7620,7 @@
           <p:cNvPr id="9" name="">
             <a:extLst xmlns:a="http://schemas.openxmlformats.org/drawingml/2006/main">
               <a:ext uri="{FF2B5EF4-FFF2-40B4-BE49-F238E27FC236}">
-                <a16:creationId xmlns:a16="http://schemas.microsoft.com/office/drawing/2014/main" id="{D176E789-064D-41E3-9F97-8170F4577ABC}"/>
+                <a16:creationId xmlns:a16="http://schemas.microsoft.com/office/drawing/2014/main" id="{22357D2D-6DE6-4E2C-AFF8-2899568142E4}"/>
               </a:ext>
             </a:extLst>
           </p:cNvPr>
@@ -7434,7 +7778,7 @@
           <p:cNvPr id="10" name="">
             <a:extLst xmlns:a="http://schemas.openxmlformats.org/drawingml/2006/main">
               <a:ext uri="{FF2B5EF4-FFF2-40B4-BE49-F238E27FC236}">
-                <a16:creationId xmlns:a16="http://schemas.microsoft.com/office/drawing/2014/main" id="{0AE635FE-B72C-4993-8A0C-6A4176BE6294}"/>
+                <a16:creationId xmlns:a16="http://schemas.microsoft.com/office/drawing/2014/main" id="{30E5CC10-63D6-4C6C-A7FC-A098625ABF1E}"/>
               </a:ext>
             </a:extLst>
           </p:cNvPr>
@@ -7620,7 +7964,7 @@
           <p:cNvPr id="11" name="">
             <a:extLst xmlns:a="http://schemas.openxmlformats.org/drawingml/2006/main">
               <a:ext uri="{FF2B5EF4-FFF2-40B4-BE49-F238E27FC236}">
-                <a16:creationId xmlns:a16="http://schemas.microsoft.com/office/drawing/2014/main" id="{B32DE860-D73B-4966-A707-5AD9114EBB6B}"/>
+                <a16:creationId xmlns:a16="http://schemas.microsoft.com/office/drawing/2014/main" id="{F59EC297-E148-4783-94DD-1EB7E01D8A9A}"/>
               </a:ext>
             </a:extLst>
           </p:cNvPr>
@@ -7778,7 +8122,7 @@
           <p:cNvPr id="12" name="">
             <a:extLst xmlns:a="http://schemas.openxmlformats.org/drawingml/2006/main">
               <a:ext uri="{FF2B5EF4-FFF2-40B4-BE49-F238E27FC236}">
-                <a16:creationId xmlns:a16="http://schemas.microsoft.com/office/drawing/2014/main" id="{E4A73190-12D6-4ED4-A154-7AC18592E6B0}"/>
+                <a16:creationId xmlns:a16="http://schemas.microsoft.com/office/drawing/2014/main" id="{FFFFEFED-EC9E-40EB-B981-661C44BC370A}"/>
               </a:ext>
             </a:extLst>
           </p:cNvPr>
@@ -7936,7 +8280,7 @@
           <p:cNvPr id="13" name="">
             <a:extLst xmlns:a="http://schemas.openxmlformats.org/drawingml/2006/main">
               <a:ext uri="{FF2B5EF4-FFF2-40B4-BE49-F238E27FC236}">
-                <a16:creationId xmlns:a16="http://schemas.microsoft.com/office/drawing/2014/main" id="{46ADEF17-5A31-4379-9723-BE8ACD86E7D5}"/>
+                <a16:creationId xmlns:a16="http://schemas.microsoft.com/office/drawing/2014/main" id="{89016BD4-8AB0-4CAD-A535-17CD2E4DE80B}"/>
               </a:ext>
             </a:extLst>
           </p:cNvPr>
@@ -8092,7 +8436,7 @@
     </p:spTree>
     <p:extLst>
       <p:ext uri="{BB962C8B-B14F-4D97-AF65-F5344CB8AC3E}">
-        <p14:creationId xmlns:p14="http://schemas.microsoft.com/office/powerpoint/2010/main" val="266479531"/>
+        <p14:creationId xmlns:p14="http://schemas.microsoft.com/office/powerpoint/2010/main" val="283187825"/>
       </p:ext>
     </p:extLst>
   </p:cSld>
@@ -8123,7 +8467,7 @@
           <p:cNvPr id="13" name="">
             <a:extLst xmlns:a="http://schemas.openxmlformats.org/drawingml/2006/main">
               <a:ext uri="{FF2B5EF4-FFF2-40B4-BE49-F238E27FC236}">
-                <a16:creationId xmlns:a16="http://schemas.microsoft.com/office/drawing/2014/main" id="{278345EB-2694-4892-8398-25347DA77CFA}"/>
+                <a16:creationId xmlns:a16="http://schemas.microsoft.com/office/drawing/2014/main" id="{F9DFB8CE-E8EF-4691-8A72-A65F57F3C3BC}"/>
               </a:ext>
             </a:extLst>
           </p:cNvPr>
@@ -8281,7 +8625,7 @@
           <p:cNvPr id="2" name="">
             <a:extLst xmlns:a="http://schemas.openxmlformats.org/drawingml/2006/main">
               <a:ext uri="{FF2B5EF4-FFF2-40B4-BE49-F238E27FC236}">
-                <a16:creationId xmlns:a16="http://schemas.microsoft.com/office/drawing/2014/main" id="{7228D105-FEC4-4A22-B3AC-BFA495603B75}"/>
+                <a16:creationId xmlns:a16="http://schemas.microsoft.com/office/drawing/2014/main" id="{1BBAF590-6B6C-47CC-8FDC-C1BFBC2A760E}"/>
               </a:ext>
             </a:extLst>
           </p:cNvPr>
@@ -8439,7 +8783,7 @@
           <p:cNvPr id="3" name="">
             <a:extLst xmlns:a="http://schemas.openxmlformats.org/drawingml/2006/main">
               <a:ext uri="{FF2B5EF4-FFF2-40B4-BE49-F238E27FC236}">
-                <a16:creationId xmlns:a16="http://schemas.microsoft.com/office/drawing/2014/main" id="{5BDB591B-7FBF-4C0B-AAA6-D86392614878}"/>
+                <a16:creationId xmlns:a16="http://schemas.microsoft.com/office/drawing/2014/main" id="{09D630F3-5D2C-4E4E-878E-815694BD0C76}"/>
               </a:ext>
             </a:extLst>
           </p:cNvPr>
@@ -8597,7 +8941,7 @@
           <p:cNvPr id="4" name="">
             <a:extLst xmlns:a="http://schemas.openxmlformats.org/drawingml/2006/main">
               <a:ext uri="{FF2B5EF4-FFF2-40B4-BE49-F238E27FC236}">
-                <a16:creationId xmlns:a16="http://schemas.microsoft.com/office/drawing/2014/main" id="{DFD74F67-B422-4B5D-BC32-9B7308791D6B}"/>
+                <a16:creationId xmlns:a16="http://schemas.microsoft.com/office/drawing/2014/main" id="{E922BFD8-A144-46B6-929A-86A5B2F3BC1A}"/>
               </a:ext>
             </a:extLst>
           </p:cNvPr>
@@ -8607,7 +8951,7 @@
           <p:nvPr/>
         </p:nvPicPr>
         <p:blipFill>
-          <a:blip xmlns:r="http://schemas.openxmlformats.org/officeDocument/2006/relationships" xmlns:a="http://schemas.openxmlformats.org/drawingml/2006/main" r:embed="R0f79f87ee43a4857"/>
+          <a:blip xmlns:r="http://schemas.openxmlformats.org/officeDocument/2006/relationships" xmlns:a="http://schemas.openxmlformats.org/drawingml/2006/main" r:embed="R9455e6d6e7764cbc"/>
           <a:stretch xmlns:a="http://schemas.openxmlformats.org/drawingml/2006/main"/>
         </p:blipFill>
         <p:spPr>
@@ -8625,7 +8969,7 @@
           <p:cNvPr id="5" name="">
             <a:extLst xmlns:a="http://schemas.openxmlformats.org/drawingml/2006/main">
               <a:ext uri="{FF2B5EF4-FFF2-40B4-BE49-F238E27FC236}">
-                <a16:creationId xmlns:a16="http://schemas.microsoft.com/office/drawing/2014/main" id="{080F0A98-522C-48DA-B9C0-8BCC80D65A21}"/>
+                <a16:creationId xmlns:a16="http://schemas.microsoft.com/office/drawing/2014/main" id="{B01EDC5E-04E5-41AA-A940-B08C12DA169D}"/>
               </a:ext>
             </a:extLst>
           </p:cNvPr>
@@ -8783,7 +9127,7 @@
           <p:cNvPr id="6" name="">
             <a:extLst xmlns:a="http://schemas.openxmlformats.org/drawingml/2006/main">
               <a:ext uri="{FF2B5EF4-FFF2-40B4-BE49-F238E27FC236}">
-                <a16:creationId xmlns:a16="http://schemas.microsoft.com/office/drawing/2014/main" id="{9A9F3AA0-EF1A-49FF-802B-6BC2A09A44CD}"/>
+                <a16:creationId xmlns:a16="http://schemas.microsoft.com/office/drawing/2014/main" id="{C8DBE1A0-6717-4AFA-B24F-B3161273604A}"/>
               </a:ext>
             </a:extLst>
           </p:cNvPr>
@@ -8941,7 +9285,7 @@
           <p:cNvPr id="7" name="">
             <a:extLst xmlns:a="http://schemas.openxmlformats.org/drawingml/2006/main">
               <a:ext uri="{FF2B5EF4-FFF2-40B4-BE49-F238E27FC236}">
-                <a16:creationId xmlns:a16="http://schemas.microsoft.com/office/drawing/2014/main" id="{A837E246-636E-4573-A8FC-1796FB35C174}"/>
+                <a16:creationId xmlns:a16="http://schemas.microsoft.com/office/drawing/2014/main" id="{86F89EDE-2AB8-494E-8B7F-2E6A2D44770C}"/>
               </a:ext>
             </a:extLst>
           </p:cNvPr>
@@ -8951,7 +9295,7 @@
           <p:nvPr/>
         </p:nvPicPr>
         <p:blipFill>
-          <a:blip xmlns:r="http://schemas.openxmlformats.org/officeDocument/2006/relationships" xmlns:a="http://schemas.openxmlformats.org/drawingml/2006/main" r:embed="R55c6111561bb447f"/>
+          <a:blip xmlns:r="http://schemas.openxmlformats.org/officeDocument/2006/relationships" xmlns:a="http://schemas.openxmlformats.org/drawingml/2006/main" r:embed="R12c9155b12754665"/>
           <a:stretch xmlns:a="http://schemas.openxmlformats.org/drawingml/2006/main"/>
         </p:blipFill>
         <p:spPr>
@@ -8969,7 +9313,7 @@
           <p:cNvPr id="8" name="">
             <a:extLst xmlns:a="http://schemas.openxmlformats.org/drawingml/2006/main">
               <a:ext uri="{FF2B5EF4-FFF2-40B4-BE49-F238E27FC236}">
-                <a16:creationId xmlns:a16="http://schemas.microsoft.com/office/drawing/2014/main" id="{251F2A48-B33E-49D3-B49C-632E6D5B53AB}"/>
+                <a16:creationId xmlns:a16="http://schemas.microsoft.com/office/drawing/2014/main" id="{AF470BDC-9C73-4672-8C14-487B21D37C9E}"/>
               </a:ext>
             </a:extLst>
           </p:cNvPr>
@@ -9127,7 +9471,7 @@
           <p:cNvPr id="9" name="">
             <a:extLst xmlns:a="http://schemas.openxmlformats.org/drawingml/2006/main">
               <a:ext uri="{FF2B5EF4-FFF2-40B4-BE49-F238E27FC236}">
-                <a16:creationId xmlns:a16="http://schemas.microsoft.com/office/drawing/2014/main" id="{F6B1FA4E-66DE-49E1-B0B8-FB6A2305B083}"/>
+                <a16:creationId xmlns:a16="http://schemas.microsoft.com/office/drawing/2014/main" id="{0320F5A6-5415-44E9-AFD1-57E8E9B94264}"/>
               </a:ext>
             </a:extLst>
           </p:cNvPr>
@@ -9285,7 +9629,7 @@
           <p:cNvPr id="10" name="">
             <a:extLst xmlns:a="http://schemas.openxmlformats.org/drawingml/2006/main">
               <a:ext uri="{FF2B5EF4-FFF2-40B4-BE49-F238E27FC236}">
-                <a16:creationId xmlns:a16="http://schemas.microsoft.com/office/drawing/2014/main" id="{9A7102A0-0AD6-426C-8DAE-B26D7090628A}"/>
+                <a16:creationId xmlns:a16="http://schemas.microsoft.com/office/drawing/2014/main" id="{4CE72DA5-D69F-4BF7-ADF0-C04A91C47B6E}"/>
               </a:ext>
             </a:extLst>
           </p:cNvPr>
@@ -9471,7 +9815,7 @@
           <p:cNvPr id="11" name="">
             <a:extLst xmlns:a="http://schemas.openxmlformats.org/drawingml/2006/main">
               <a:ext uri="{FF2B5EF4-FFF2-40B4-BE49-F238E27FC236}">
-                <a16:creationId xmlns:a16="http://schemas.microsoft.com/office/drawing/2014/main" id="{8841E591-377F-4344-9609-18C73D36CE28}"/>
+                <a16:creationId xmlns:a16="http://schemas.microsoft.com/office/drawing/2014/main" id="{AED2C757-9ACB-4C4D-BF0F-861E1519EE99}"/>
               </a:ext>
             </a:extLst>
           </p:cNvPr>
@@ -9629,7 +9973,7 @@
           <p:cNvPr id="12" name="">
             <a:extLst xmlns:a="http://schemas.openxmlformats.org/drawingml/2006/main">
               <a:ext uri="{FF2B5EF4-FFF2-40B4-BE49-F238E27FC236}">
-                <a16:creationId xmlns:a16="http://schemas.microsoft.com/office/drawing/2014/main" id="{77CF8605-4649-4E52-9D4F-D2F8FE1793AA}"/>
+                <a16:creationId xmlns:a16="http://schemas.microsoft.com/office/drawing/2014/main" id="{5A430046-9AC2-4DD7-AAFB-3C5FA65780D9}"/>
               </a:ext>
             </a:extLst>
           </p:cNvPr>
@@ -9785,7 +10129,7 @@
     </p:spTree>
     <p:extLst>
       <p:ext uri="{BB962C8B-B14F-4D97-AF65-F5344CB8AC3E}">
-        <p14:creationId xmlns:p14="http://schemas.microsoft.com/office/powerpoint/2010/main" val="1132015317"/>
+        <p14:creationId xmlns:p14="http://schemas.microsoft.com/office/powerpoint/2010/main" val="1618491042"/>
       </p:ext>
     </p:extLst>
   </p:cSld>
@@ -9816,7 +10160,7 @@
           <p:cNvPr id="13" name="">
             <a:extLst xmlns:a="http://schemas.openxmlformats.org/drawingml/2006/main">
               <a:ext uri="{FF2B5EF4-FFF2-40B4-BE49-F238E27FC236}">
-                <a16:creationId xmlns:a16="http://schemas.microsoft.com/office/drawing/2014/main" id="{B5878124-772A-4599-9C20-5943938B3AEB}"/>
+                <a16:creationId xmlns:a16="http://schemas.microsoft.com/office/drawing/2014/main" id="{D3E351A1-7C2C-4A7A-B075-B89B3A5CDA07}"/>
               </a:ext>
             </a:extLst>
           </p:cNvPr>
@@ -9974,7 +10318,7 @@
           <p:cNvPr id="2" name="">
             <a:extLst xmlns:a="http://schemas.openxmlformats.org/drawingml/2006/main">
               <a:ext uri="{FF2B5EF4-FFF2-40B4-BE49-F238E27FC236}">
-                <a16:creationId xmlns:a16="http://schemas.microsoft.com/office/drawing/2014/main" id="{B2C0B875-6465-4687-BE5A-FD55F5A91E73}"/>
+                <a16:creationId xmlns:a16="http://schemas.microsoft.com/office/drawing/2014/main" id="{C990A4F0-59C8-48F9-A6AF-09135490DDFB}"/>
               </a:ext>
             </a:extLst>
           </p:cNvPr>
@@ -10132,7 +10476,7 @@
           <p:cNvPr id="3" name="">
             <a:extLst xmlns:a="http://schemas.openxmlformats.org/drawingml/2006/main">
               <a:ext uri="{FF2B5EF4-FFF2-40B4-BE49-F238E27FC236}">
-                <a16:creationId xmlns:a16="http://schemas.microsoft.com/office/drawing/2014/main" id="{02F5C312-C75D-4468-B38B-5AEF0C8F766E}"/>
+                <a16:creationId xmlns:a16="http://schemas.microsoft.com/office/drawing/2014/main" id="{8FEB37D4-A5CB-4BFA-89F3-E46D5D832182}"/>
               </a:ext>
             </a:extLst>
           </p:cNvPr>
@@ -10290,7 +10634,7 @@
           <p:cNvPr id="4" name="">
             <a:extLst xmlns:a="http://schemas.openxmlformats.org/drawingml/2006/main">
               <a:ext uri="{FF2B5EF4-FFF2-40B4-BE49-F238E27FC236}">
-                <a16:creationId xmlns:a16="http://schemas.microsoft.com/office/drawing/2014/main" id="{F7250C3B-D207-485F-906B-8240969175ED}"/>
+                <a16:creationId xmlns:a16="http://schemas.microsoft.com/office/drawing/2014/main" id="{40C87433-B1C7-4805-A54A-47C2FCC16DD9}"/>
               </a:ext>
             </a:extLst>
           </p:cNvPr>
@@ -10300,7 +10644,7 @@
           <p:nvPr/>
         </p:nvPicPr>
         <p:blipFill>
-          <a:blip xmlns:r="http://schemas.openxmlformats.org/officeDocument/2006/relationships" xmlns:a="http://schemas.openxmlformats.org/drawingml/2006/main" r:embed="R6c35107f631949c1"/>
+          <a:blip xmlns:r="http://schemas.openxmlformats.org/officeDocument/2006/relationships" xmlns:a="http://schemas.openxmlformats.org/drawingml/2006/main" r:embed="Rfb09209f2a3b42e0"/>
           <a:stretch xmlns:a="http://schemas.openxmlformats.org/drawingml/2006/main"/>
         </p:blipFill>
         <p:spPr>
@@ -10318,7 +10662,7 @@
           <p:cNvPr id="5" name="">
             <a:extLst xmlns:a="http://schemas.openxmlformats.org/drawingml/2006/main">
               <a:ext uri="{FF2B5EF4-FFF2-40B4-BE49-F238E27FC236}">
-                <a16:creationId xmlns:a16="http://schemas.microsoft.com/office/drawing/2014/main" id="{332EB539-0BB7-4F42-B5B2-02553A9DC181}"/>
+                <a16:creationId xmlns:a16="http://schemas.microsoft.com/office/drawing/2014/main" id="{429D5F00-AC5D-4D18-B6E3-45BCBA09F329}"/>
               </a:ext>
             </a:extLst>
           </p:cNvPr>
@@ -10476,7 +10820,7 @@
           <p:cNvPr id="6" name="">
             <a:extLst xmlns:a="http://schemas.openxmlformats.org/drawingml/2006/main">
               <a:ext uri="{FF2B5EF4-FFF2-40B4-BE49-F238E27FC236}">
-                <a16:creationId xmlns:a16="http://schemas.microsoft.com/office/drawing/2014/main" id="{318B99A6-90F7-4C70-8554-342757D8FE79}"/>
+                <a16:creationId xmlns:a16="http://schemas.microsoft.com/office/drawing/2014/main" id="{F0EA44F7-E21A-429B-91C1-A2B5E1E12C5C}"/>
               </a:ext>
             </a:extLst>
           </p:cNvPr>
@@ -10634,7 +10978,7 @@
           <p:cNvPr id="7" name="">
             <a:extLst xmlns:a="http://schemas.openxmlformats.org/drawingml/2006/main">
               <a:ext uri="{FF2B5EF4-FFF2-40B4-BE49-F238E27FC236}">
-                <a16:creationId xmlns:a16="http://schemas.microsoft.com/office/drawing/2014/main" id="{AD2B2893-F647-4997-AB2A-A939199070A6}"/>
+                <a16:creationId xmlns:a16="http://schemas.microsoft.com/office/drawing/2014/main" id="{5C3C4DEE-8C83-4ED0-A541-7AD459A7ACE2}"/>
               </a:ext>
             </a:extLst>
           </p:cNvPr>
@@ -10644,7 +10988,7 @@
           <p:nvPr/>
         </p:nvPicPr>
         <p:blipFill>
-          <a:blip xmlns:r="http://schemas.openxmlformats.org/officeDocument/2006/relationships" xmlns:a="http://schemas.openxmlformats.org/drawingml/2006/main" r:embed="Re58697e3f21e401a"/>
+          <a:blip xmlns:r="http://schemas.openxmlformats.org/officeDocument/2006/relationships" xmlns:a="http://schemas.openxmlformats.org/drawingml/2006/main" r:embed="R72c57aad513842cf"/>
           <a:stretch xmlns:a="http://schemas.openxmlformats.org/drawingml/2006/main"/>
         </p:blipFill>
         <p:spPr>
@@ -10662,7 +11006,7 @@
           <p:cNvPr id="8" name="">
             <a:extLst xmlns:a="http://schemas.openxmlformats.org/drawingml/2006/main">
               <a:ext uri="{FF2B5EF4-FFF2-40B4-BE49-F238E27FC236}">
-                <a16:creationId xmlns:a16="http://schemas.microsoft.com/office/drawing/2014/main" id="{55630C51-C469-4DFF-978C-4AB47977BA11}"/>
+                <a16:creationId xmlns:a16="http://schemas.microsoft.com/office/drawing/2014/main" id="{038DB508-E555-4557-93B7-27C90C316F94}"/>
               </a:ext>
             </a:extLst>
           </p:cNvPr>
@@ -10820,7 +11164,7 @@
           <p:cNvPr id="9" name="">
             <a:extLst xmlns:a="http://schemas.openxmlformats.org/drawingml/2006/main">
               <a:ext uri="{FF2B5EF4-FFF2-40B4-BE49-F238E27FC236}">
-                <a16:creationId xmlns:a16="http://schemas.microsoft.com/office/drawing/2014/main" id="{FE1D2DBA-7BC8-4691-BB2A-3C09F4676F9E}"/>
+                <a16:creationId xmlns:a16="http://schemas.microsoft.com/office/drawing/2014/main" id="{E4D5BED5-3CC8-42A6-B171-CF5A0BAD14A7}"/>
               </a:ext>
             </a:extLst>
           </p:cNvPr>
@@ -10978,7 +11322,7 @@
           <p:cNvPr id="10" name="">
             <a:extLst xmlns:a="http://schemas.openxmlformats.org/drawingml/2006/main">
               <a:ext uri="{FF2B5EF4-FFF2-40B4-BE49-F238E27FC236}">
-                <a16:creationId xmlns:a16="http://schemas.microsoft.com/office/drawing/2014/main" id="{34DF9505-E431-4750-98C9-8130E2DC32AE}"/>
+                <a16:creationId xmlns:a16="http://schemas.microsoft.com/office/drawing/2014/main" id="{01FAF6CE-7928-4E0D-BCBD-EA80046AE64C}"/>
               </a:ext>
             </a:extLst>
           </p:cNvPr>
@@ -11164,7 +11508,7 @@
           <p:cNvPr id="11" name="">
             <a:extLst xmlns:a="http://schemas.openxmlformats.org/drawingml/2006/main">
               <a:ext uri="{FF2B5EF4-FFF2-40B4-BE49-F238E27FC236}">
-                <a16:creationId xmlns:a16="http://schemas.microsoft.com/office/drawing/2014/main" id="{8707B4EE-6CEA-4599-9373-E35322C76A77}"/>
+                <a16:creationId xmlns:a16="http://schemas.microsoft.com/office/drawing/2014/main" id="{D8AEF6B0-209F-4772-9033-A420892044FB}"/>
               </a:ext>
             </a:extLst>
           </p:cNvPr>
@@ -11322,7 +11666,7 @@
           <p:cNvPr id="12" name="">
             <a:extLst xmlns:a="http://schemas.openxmlformats.org/drawingml/2006/main">
               <a:ext uri="{FF2B5EF4-FFF2-40B4-BE49-F238E27FC236}">
-                <a16:creationId xmlns:a16="http://schemas.microsoft.com/office/drawing/2014/main" id="{D6B0E26D-2C2B-45A5-98C3-E28B8C9E3197}"/>
+                <a16:creationId xmlns:a16="http://schemas.microsoft.com/office/drawing/2014/main" id="{5C36A15F-6AA9-4234-A5DE-CA55F74CDA60}"/>
               </a:ext>
             </a:extLst>
           </p:cNvPr>
@@ -11478,7 +11822,7 @@
     </p:spTree>
     <p:extLst>
       <p:ext uri="{BB962C8B-B14F-4D97-AF65-F5344CB8AC3E}">
-        <p14:creationId xmlns:p14="http://schemas.microsoft.com/office/powerpoint/2010/main" val="199283342"/>
+        <p14:creationId xmlns:p14="http://schemas.microsoft.com/office/powerpoint/2010/main" val="1615466016"/>
       </p:ext>
     </p:extLst>
   </p:cSld>
@@ -11509,7 +11853,7 @@
           <p:cNvPr id="14" name="">
             <a:extLst xmlns:a="http://schemas.openxmlformats.org/drawingml/2006/main">
               <a:ext uri="{FF2B5EF4-FFF2-40B4-BE49-F238E27FC236}">
-                <a16:creationId xmlns:a16="http://schemas.microsoft.com/office/drawing/2014/main" id="{73B34376-495A-4E37-A03A-FA22CD099BB1}"/>
+                <a16:creationId xmlns:a16="http://schemas.microsoft.com/office/drawing/2014/main" id="{76710A2C-6B35-4C8F-95E0-CEAB6084F17E}"/>
               </a:ext>
             </a:extLst>
           </p:cNvPr>
@@ -11667,7 +12011,7 @@
           <p:cNvPr id="2" name="">
             <a:extLst xmlns:a="http://schemas.openxmlformats.org/drawingml/2006/main">
               <a:ext uri="{FF2B5EF4-FFF2-40B4-BE49-F238E27FC236}">
-                <a16:creationId xmlns:a16="http://schemas.microsoft.com/office/drawing/2014/main" id="{9A510B27-DA42-4374-83C8-6871C068F415}"/>
+                <a16:creationId xmlns:a16="http://schemas.microsoft.com/office/drawing/2014/main" id="{A7F9119A-F19A-44A0-9015-525DF10F3A26}"/>
               </a:ext>
             </a:extLst>
           </p:cNvPr>
@@ -11825,7 +12169,7 @@
           <p:cNvPr id="3" name="">
             <a:extLst xmlns:a="http://schemas.openxmlformats.org/drawingml/2006/main">
               <a:ext uri="{FF2B5EF4-FFF2-40B4-BE49-F238E27FC236}">
-                <a16:creationId xmlns:a16="http://schemas.microsoft.com/office/drawing/2014/main" id="{881CDE45-16C3-48F8-AEAF-C2B0F87AF6BA}"/>
+                <a16:creationId xmlns:a16="http://schemas.microsoft.com/office/drawing/2014/main" id="{CA5C35FA-B318-4B1D-837C-88BCCF278646}"/>
               </a:ext>
             </a:extLst>
           </p:cNvPr>
@@ -11983,7 +12327,7 @@
           <p:cNvPr id="4" name="">
             <a:extLst xmlns:a="http://schemas.openxmlformats.org/drawingml/2006/main">
               <a:ext uri="{FF2B5EF4-FFF2-40B4-BE49-F238E27FC236}">
-                <a16:creationId xmlns:a16="http://schemas.microsoft.com/office/drawing/2014/main" id="{4C56EB6E-34EB-438B-9011-441843AED708}"/>
+                <a16:creationId xmlns:a16="http://schemas.microsoft.com/office/drawing/2014/main" id="{A2C50A8E-8E67-480A-9B86-1029701FBA55}"/>
               </a:ext>
             </a:extLst>
           </p:cNvPr>
@@ -11993,7 +12337,7 @@
           <p:nvPr/>
         </p:nvPicPr>
         <p:blipFill>
-          <a:blip xmlns:r="http://schemas.openxmlformats.org/officeDocument/2006/relationships" xmlns:a="http://schemas.openxmlformats.org/drawingml/2006/main" r:embed="Rc78b377e80624d1b"/>
+          <a:blip xmlns:r="http://schemas.openxmlformats.org/officeDocument/2006/relationships" xmlns:a="http://schemas.openxmlformats.org/drawingml/2006/main" r:embed="Rbe10d9cc76bd4692"/>
           <a:stretch xmlns:a="http://schemas.openxmlformats.org/drawingml/2006/main"/>
         </p:blipFill>
         <p:spPr>
@@ -12011,7 +12355,7 @@
           <p:cNvPr id="5" name="">
             <a:extLst xmlns:a="http://schemas.openxmlformats.org/drawingml/2006/main">
               <a:ext uri="{FF2B5EF4-FFF2-40B4-BE49-F238E27FC236}">
-                <a16:creationId xmlns:a16="http://schemas.microsoft.com/office/drawing/2014/main" id="{7C145D27-A829-40D7-9FBE-654D2FC7C176}"/>
+                <a16:creationId xmlns:a16="http://schemas.microsoft.com/office/drawing/2014/main" id="{07D6D3D3-AD15-472C-A7F8-891BA6E21AD2}"/>
               </a:ext>
             </a:extLst>
           </p:cNvPr>
@@ -12169,7 +12513,7 @@
           <p:cNvPr id="6" name="">
             <a:extLst xmlns:a="http://schemas.openxmlformats.org/drawingml/2006/main">
               <a:ext uri="{FF2B5EF4-FFF2-40B4-BE49-F238E27FC236}">
-                <a16:creationId xmlns:a16="http://schemas.microsoft.com/office/drawing/2014/main" id="{6F42FC7E-4639-48A7-A820-4D59520D3073}"/>
+                <a16:creationId xmlns:a16="http://schemas.microsoft.com/office/drawing/2014/main" id="{39685565-AA6A-4195-9039-73D0F046C58A}"/>
               </a:ext>
             </a:extLst>
           </p:cNvPr>
@@ -12327,7 +12671,7 @@
           <p:cNvPr id="7" name="">
             <a:extLst xmlns:a="http://schemas.openxmlformats.org/drawingml/2006/main">
               <a:ext uri="{FF2B5EF4-FFF2-40B4-BE49-F238E27FC236}">
-                <a16:creationId xmlns:a16="http://schemas.microsoft.com/office/drawing/2014/main" id="{D92FC52E-3FA7-4537-9B33-DA68623A97BE}"/>
+                <a16:creationId xmlns:a16="http://schemas.microsoft.com/office/drawing/2014/main" id="{1F06370D-AC39-4FF7-9E8A-0F6A453D0524}"/>
               </a:ext>
             </a:extLst>
           </p:cNvPr>
@@ -12337,7 +12681,7 @@
           <p:nvPr/>
         </p:nvPicPr>
         <p:blipFill>
-          <a:blip xmlns:r="http://schemas.openxmlformats.org/officeDocument/2006/relationships" xmlns:a="http://schemas.openxmlformats.org/drawingml/2006/main" r:embed="R26bf9d87c7294b2c"/>
+          <a:blip xmlns:r="http://schemas.openxmlformats.org/officeDocument/2006/relationships" xmlns:a="http://schemas.openxmlformats.org/drawingml/2006/main" r:embed="Rbc0550a26f3949f0"/>
           <a:stretch xmlns:a="http://schemas.openxmlformats.org/drawingml/2006/main"/>
         </p:blipFill>
         <p:spPr>
@@ -12355,7 +12699,7 @@
           <p:cNvPr id="8" name="">
             <a:extLst xmlns:a="http://schemas.openxmlformats.org/drawingml/2006/main">
               <a:ext uri="{FF2B5EF4-FFF2-40B4-BE49-F238E27FC236}">
-                <a16:creationId xmlns:a16="http://schemas.microsoft.com/office/drawing/2014/main" id="{A34DEEB3-A81D-4FA3-A305-FA69FC631187}"/>
+                <a16:creationId xmlns:a16="http://schemas.microsoft.com/office/drawing/2014/main" id="{A2906B72-1C50-4D01-A74D-1C3F2BF06BC3}"/>
               </a:ext>
             </a:extLst>
           </p:cNvPr>
@@ -12513,7 +12857,7 @@
           <p:cNvPr id="9" name="">
             <a:extLst xmlns:a="http://schemas.openxmlformats.org/drawingml/2006/main">
               <a:ext uri="{FF2B5EF4-FFF2-40B4-BE49-F238E27FC236}">
-                <a16:creationId xmlns:a16="http://schemas.microsoft.com/office/drawing/2014/main" id="{345D09E5-A86F-4D3F-B4FD-B68B765432A7}"/>
+                <a16:creationId xmlns:a16="http://schemas.microsoft.com/office/drawing/2014/main" id="{4232690B-2CCA-4B1D-BD98-3373F5636C83}"/>
               </a:ext>
             </a:extLst>
           </p:cNvPr>
@@ -12671,7 +13015,7 @@
           <p:cNvPr id="10" name="">
             <a:extLst xmlns:a="http://schemas.openxmlformats.org/drawingml/2006/main">
               <a:ext uri="{FF2B5EF4-FFF2-40B4-BE49-F238E27FC236}">
-                <a16:creationId xmlns:a16="http://schemas.microsoft.com/office/drawing/2014/main" id="{D0944788-044C-4CB1-BEAD-600434BAACF9}"/>
+                <a16:creationId xmlns:a16="http://schemas.microsoft.com/office/drawing/2014/main" id="{E265E73D-DD0A-4911-A0B4-546399476DCC}"/>
               </a:ext>
             </a:extLst>
           </p:cNvPr>
@@ -12829,7 +13173,7 @@
           <p:cNvPr id="11" name="">
             <a:extLst xmlns:a="http://schemas.openxmlformats.org/drawingml/2006/main">
               <a:ext uri="{FF2B5EF4-FFF2-40B4-BE49-F238E27FC236}">
-                <a16:creationId xmlns:a16="http://schemas.microsoft.com/office/drawing/2014/main" id="{FE2E6436-928D-4CAF-8E82-8995319D10E2}"/>
+                <a16:creationId xmlns:a16="http://schemas.microsoft.com/office/drawing/2014/main" id="{866F8612-0BAE-4344-936B-33DABA8F2BED}"/>
               </a:ext>
             </a:extLst>
           </p:cNvPr>
@@ -12987,7 +13331,7 @@
           <p:cNvPr id="12" name="">
             <a:extLst xmlns:a="http://schemas.openxmlformats.org/drawingml/2006/main">
               <a:ext uri="{FF2B5EF4-FFF2-40B4-BE49-F238E27FC236}">
-                <a16:creationId xmlns:a16="http://schemas.microsoft.com/office/drawing/2014/main" id="{88A4AC34-5D4D-4277-8F8F-EACB70245DE7}"/>
+                <a16:creationId xmlns:a16="http://schemas.microsoft.com/office/drawing/2014/main" id="{13DD615E-5F91-4E71-8B23-9A49BC831361}"/>
               </a:ext>
             </a:extLst>
           </p:cNvPr>
@@ -13191,7 +13535,7 @@
           <p:cNvPr id="13" name="">
             <a:extLst xmlns:a="http://schemas.openxmlformats.org/drawingml/2006/main">
               <a:ext uri="{FF2B5EF4-FFF2-40B4-BE49-F238E27FC236}">
-                <a16:creationId xmlns:a16="http://schemas.microsoft.com/office/drawing/2014/main" id="{D6B8F967-F664-4BB7-9A2E-399DEBFED6FC}"/>
+                <a16:creationId xmlns:a16="http://schemas.microsoft.com/office/drawing/2014/main" id="{36794062-5029-48AF-9AF3-293BE01FDB4D}"/>
               </a:ext>
             </a:extLst>
           </p:cNvPr>
@@ -13347,7 +13691,7 @@
     </p:spTree>
     <p:extLst>
       <p:ext uri="{BB962C8B-B14F-4D97-AF65-F5344CB8AC3E}">
-        <p14:creationId xmlns:p14="http://schemas.microsoft.com/office/powerpoint/2010/main" val="324625335"/>
+        <p14:creationId xmlns:p14="http://schemas.microsoft.com/office/powerpoint/2010/main" val="200428823"/>
       </p:ext>
     </p:extLst>
   </p:cSld>
@@ -13378,7 +13722,7 @@
           <p:cNvPr id="14" name="">
             <a:extLst xmlns:a="http://schemas.openxmlformats.org/drawingml/2006/main">
               <a:ext uri="{FF2B5EF4-FFF2-40B4-BE49-F238E27FC236}">
-                <a16:creationId xmlns:a16="http://schemas.microsoft.com/office/drawing/2014/main" id="{19FD63E0-251A-4A23-8E8A-D693C3F10162}"/>
+                <a16:creationId xmlns:a16="http://schemas.microsoft.com/office/drawing/2014/main" id="{11606A85-011D-4E29-91CC-6EDEFB824DC9}"/>
               </a:ext>
             </a:extLst>
           </p:cNvPr>
@@ -13536,7 +13880,7 @@
           <p:cNvPr id="2" name="">
             <a:extLst xmlns:a="http://schemas.openxmlformats.org/drawingml/2006/main">
               <a:ext uri="{FF2B5EF4-FFF2-40B4-BE49-F238E27FC236}">
-                <a16:creationId xmlns:a16="http://schemas.microsoft.com/office/drawing/2014/main" id="{86DCA77C-02A2-4719-B6A1-4E1F7E94DADD}"/>
+                <a16:creationId xmlns:a16="http://schemas.microsoft.com/office/drawing/2014/main" id="{AC38E052-7A05-418B-BF44-B32EE48A8AEA}"/>
               </a:ext>
             </a:extLst>
           </p:cNvPr>
@@ -13694,7 +14038,7 @@
           <p:cNvPr id="3" name="">
             <a:extLst xmlns:a="http://schemas.openxmlformats.org/drawingml/2006/main">
               <a:ext uri="{FF2B5EF4-FFF2-40B4-BE49-F238E27FC236}">
-                <a16:creationId xmlns:a16="http://schemas.microsoft.com/office/drawing/2014/main" id="{DF8A1C73-649F-4FE2-9116-E762439E7024}"/>
+                <a16:creationId xmlns:a16="http://schemas.microsoft.com/office/drawing/2014/main" id="{898CA833-C7A9-47AF-A991-1DAD203F92EC}"/>
               </a:ext>
             </a:extLst>
           </p:cNvPr>
@@ -13852,7 +14196,7 @@
           <p:cNvPr id="4" name="">
             <a:extLst xmlns:a="http://schemas.openxmlformats.org/drawingml/2006/main">
               <a:ext uri="{FF2B5EF4-FFF2-40B4-BE49-F238E27FC236}">
-                <a16:creationId xmlns:a16="http://schemas.microsoft.com/office/drawing/2014/main" id="{6DDDB569-6F9D-49F0-B126-98E62CAEAAB0}"/>
+                <a16:creationId xmlns:a16="http://schemas.microsoft.com/office/drawing/2014/main" id="{7F3D39EC-CD06-4984-AF61-04F40FB3DFE0}"/>
               </a:ext>
             </a:extLst>
           </p:cNvPr>
@@ -13862,7 +14206,7 @@
           <p:nvPr/>
         </p:nvPicPr>
         <p:blipFill>
-          <a:blip xmlns:r="http://schemas.openxmlformats.org/officeDocument/2006/relationships" xmlns:a="http://schemas.openxmlformats.org/drawingml/2006/main" r:embed="Rb7dcf12365e7426c"/>
+          <a:blip xmlns:r="http://schemas.openxmlformats.org/officeDocument/2006/relationships" xmlns:a="http://schemas.openxmlformats.org/drawingml/2006/main" r:embed="R6a122b6e318e460a"/>
           <a:stretch xmlns:a="http://schemas.openxmlformats.org/drawingml/2006/main"/>
         </p:blipFill>
         <p:spPr>
@@ -13880,7 +14224,7 @@
           <p:cNvPr id="5" name="">
             <a:extLst xmlns:a="http://schemas.openxmlformats.org/drawingml/2006/main">
               <a:ext uri="{FF2B5EF4-FFF2-40B4-BE49-F238E27FC236}">
-                <a16:creationId xmlns:a16="http://schemas.microsoft.com/office/drawing/2014/main" id="{90F332F2-6D50-4677-B257-94C4524777A3}"/>
+                <a16:creationId xmlns:a16="http://schemas.microsoft.com/office/drawing/2014/main" id="{BF204C26-EF1D-4D4F-976F-64D256A2AA46}"/>
               </a:ext>
             </a:extLst>
           </p:cNvPr>
@@ -14038,7 +14382,7 @@
           <p:cNvPr id="6" name="">
             <a:extLst xmlns:a="http://schemas.openxmlformats.org/drawingml/2006/main">
               <a:ext uri="{FF2B5EF4-FFF2-40B4-BE49-F238E27FC236}">
-                <a16:creationId xmlns:a16="http://schemas.microsoft.com/office/drawing/2014/main" id="{F2550A80-3CB3-407E-A03B-2149B04BFD93}"/>
+                <a16:creationId xmlns:a16="http://schemas.microsoft.com/office/drawing/2014/main" id="{2F1B7A4B-2710-40BB-8E85-EF1E8CB5D434}"/>
               </a:ext>
             </a:extLst>
           </p:cNvPr>
@@ -14196,7 +14540,7 @@
           <p:cNvPr id="7" name="">
             <a:extLst xmlns:a="http://schemas.openxmlformats.org/drawingml/2006/main">
               <a:ext uri="{FF2B5EF4-FFF2-40B4-BE49-F238E27FC236}">
-                <a16:creationId xmlns:a16="http://schemas.microsoft.com/office/drawing/2014/main" id="{8A71D67F-FF4A-4E2E-9A60-0132768BE1FC}"/>
+                <a16:creationId xmlns:a16="http://schemas.microsoft.com/office/drawing/2014/main" id="{C7A5C8FB-5D53-4FE5-91A2-39FA1F17DA0F}"/>
               </a:ext>
             </a:extLst>
           </p:cNvPr>
@@ -14206,7 +14550,7 @@
           <p:nvPr/>
         </p:nvPicPr>
         <p:blipFill>
-          <a:blip xmlns:r="http://schemas.openxmlformats.org/officeDocument/2006/relationships" xmlns:a="http://schemas.openxmlformats.org/drawingml/2006/main" r:embed="R69e67f2ac25e4e67"/>
+          <a:blip xmlns:r="http://schemas.openxmlformats.org/officeDocument/2006/relationships" xmlns:a="http://schemas.openxmlformats.org/drawingml/2006/main" r:embed="R26b464f9721b4df0"/>
           <a:stretch xmlns:a="http://schemas.openxmlformats.org/drawingml/2006/main"/>
         </p:blipFill>
         <p:spPr>
@@ -14224,7 +14568,7 @@
           <p:cNvPr id="8" name="">
             <a:extLst xmlns:a="http://schemas.openxmlformats.org/drawingml/2006/main">
               <a:ext uri="{FF2B5EF4-FFF2-40B4-BE49-F238E27FC236}">
-                <a16:creationId xmlns:a16="http://schemas.microsoft.com/office/drawing/2014/main" id="{74EE73F5-A13F-40C6-AE8A-7FF9C478FB32}"/>
+                <a16:creationId xmlns:a16="http://schemas.microsoft.com/office/drawing/2014/main" id="{29B6501C-2E95-400C-A519-1109295A671A}"/>
               </a:ext>
             </a:extLst>
           </p:cNvPr>
@@ -14382,7 +14726,7 @@
           <p:cNvPr id="9" name="">
             <a:extLst xmlns:a="http://schemas.openxmlformats.org/drawingml/2006/main">
               <a:ext uri="{FF2B5EF4-FFF2-40B4-BE49-F238E27FC236}">
-                <a16:creationId xmlns:a16="http://schemas.microsoft.com/office/drawing/2014/main" id="{E0DB4163-3FF1-446C-9BC6-7BDC59EB25F1}"/>
+                <a16:creationId xmlns:a16="http://schemas.microsoft.com/office/drawing/2014/main" id="{AC57A070-C702-4A73-9D70-7463A5C1FC3A}"/>
               </a:ext>
             </a:extLst>
           </p:cNvPr>
@@ -14540,7 +14884,7 @@
           <p:cNvPr id="10" name="">
             <a:extLst xmlns:a="http://schemas.openxmlformats.org/drawingml/2006/main">
               <a:ext uri="{FF2B5EF4-FFF2-40B4-BE49-F238E27FC236}">
-                <a16:creationId xmlns:a16="http://schemas.microsoft.com/office/drawing/2014/main" id="{DD028906-530C-4FB2-AA30-C0E032D8A786}"/>
+                <a16:creationId xmlns:a16="http://schemas.microsoft.com/office/drawing/2014/main" id="{942638EF-C9D2-41D9-95DC-C22314DA2B8B}"/>
               </a:ext>
             </a:extLst>
           </p:cNvPr>
@@ -14726,7 +15070,7 @@
           <p:cNvPr id="11" name="">
             <a:extLst xmlns:a="http://schemas.openxmlformats.org/drawingml/2006/main">
               <a:ext uri="{FF2B5EF4-FFF2-40B4-BE49-F238E27FC236}">
-                <a16:creationId xmlns:a16="http://schemas.microsoft.com/office/drawing/2014/main" id="{5AEB9EFE-2454-4D21-A26E-524820DB7666}"/>
+                <a16:creationId xmlns:a16="http://schemas.microsoft.com/office/drawing/2014/main" id="{F0348B27-EF40-4DE2-9BF1-D761572E2711}"/>
               </a:ext>
             </a:extLst>
           </p:cNvPr>
@@ -14884,7 +15228,7 @@
           <p:cNvPr id="12" name="">
             <a:extLst xmlns:a="http://schemas.openxmlformats.org/drawingml/2006/main">
               <a:ext uri="{FF2B5EF4-FFF2-40B4-BE49-F238E27FC236}">
-                <a16:creationId xmlns:a16="http://schemas.microsoft.com/office/drawing/2014/main" id="{17A2A083-D5DC-43EB-BA5C-78C86BA4DC20}"/>
+                <a16:creationId xmlns:a16="http://schemas.microsoft.com/office/drawing/2014/main" id="{7C5A6907-C1F6-45B8-9DB5-1F2770EFCA33}"/>
               </a:ext>
             </a:extLst>
           </p:cNvPr>
@@ -15042,7 +15386,7 @@
           <p:cNvPr id="13" name="">
             <a:extLst xmlns:a="http://schemas.openxmlformats.org/drawingml/2006/main">
               <a:ext uri="{FF2B5EF4-FFF2-40B4-BE49-F238E27FC236}">
-                <a16:creationId xmlns:a16="http://schemas.microsoft.com/office/drawing/2014/main" id="{1256DBF0-28CB-4A71-9420-D6A03A3E2312}"/>
+                <a16:creationId xmlns:a16="http://schemas.microsoft.com/office/drawing/2014/main" id="{B5CF9574-5C95-4358-AA5A-88CF8727DD07}"/>
               </a:ext>
             </a:extLst>
           </p:cNvPr>
@@ -15198,7 +15542,7 @@
     </p:spTree>
     <p:extLst>
       <p:ext uri="{BB962C8B-B14F-4D97-AF65-F5344CB8AC3E}">
-        <p14:creationId xmlns:p14="http://schemas.microsoft.com/office/powerpoint/2010/main" val="991612742"/>
+        <p14:creationId xmlns:p14="http://schemas.microsoft.com/office/powerpoint/2010/main" val="1262496321"/>
       </p:ext>
     </p:extLst>
   </p:cSld>
@@ -15229,7 +15573,7 @@
           <p:cNvPr id="13" name="">
             <a:extLst xmlns:a="http://schemas.openxmlformats.org/drawingml/2006/main">
               <a:ext uri="{FF2B5EF4-FFF2-40B4-BE49-F238E27FC236}">
-                <a16:creationId xmlns:a16="http://schemas.microsoft.com/office/drawing/2014/main" id="{41D2DB5E-83D0-4CE9-826F-3B4B22CF40DD}"/>
+                <a16:creationId xmlns:a16="http://schemas.microsoft.com/office/drawing/2014/main" id="{1CCF7843-B561-4C56-9B0C-FAF37B38A191}"/>
               </a:ext>
             </a:extLst>
           </p:cNvPr>
@@ -15387,7 +15731,7 @@
           <p:cNvPr id="2" name="">
             <a:extLst xmlns:a="http://schemas.openxmlformats.org/drawingml/2006/main">
               <a:ext uri="{FF2B5EF4-FFF2-40B4-BE49-F238E27FC236}">
-                <a16:creationId xmlns:a16="http://schemas.microsoft.com/office/drawing/2014/main" id="{592E412D-F56A-4921-B51A-AB2F7052B396}"/>
+                <a16:creationId xmlns:a16="http://schemas.microsoft.com/office/drawing/2014/main" id="{34912685-233F-49AD-AA21-923B43C0CABE}"/>
               </a:ext>
             </a:extLst>
           </p:cNvPr>
@@ -15545,7 +15889,7 @@
           <p:cNvPr id="3" name="">
             <a:extLst xmlns:a="http://schemas.openxmlformats.org/drawingml/2006/main">
               <a:ext uri="{FF2B5EF4-FFF2-40B4-BE49-F238E27FC236}">
-                <a16:creationId xmlns:a16="http://schemas.microsoft.com/office/drawing/2014/main" id="{9DB89CB2-56EE-4D40-9568-5DEC4BB30E79}"/>
+                <a16:creationId xmlns:a16="http://schemas.microsoft.com/office/drawing/2014/main" id="{7AFA2F1C-E3A1-451E-8D45-DE9A3E3E7E1F}"/>
               </a:ext>
             </a:extLst>
           </p:cNvPr>
@@ -15703,7 +16047,7 @@
           <p:cNvPr id="4" name="">
             <a:extLst xmlns:a="http://schemas.openxmlformats.org/drawingml/2006/main">
               <a:ext uri="{FF2B5EF4-FFF2-40B4-BE49-F238E27FC236}">
-                <a16:creationId xmlns:a16="http://schemas.microsoft.com/office/drawing/2014/main" id="{AF275505-BA7D-47D4-AB2B-BEAB2003256E}"/>
+                <a16:creationId xmlns:a16="http://schemas.microsoft.com/office/drawing/2014/main" id="{6927F0B7-3D38-4A1D-8351-CC9823CE7355}"/>
               </a:ext>
             </a:extLst>
           </p:cNvPr>
@@ -15713,7 +16057,7 @@
           <p:nvPr/>
         </p:nvPicPr>
         <p:blipFill>
-          <a:blip xmlns:r="http://schemas.openxmlformats.org/officeDocument/2006/relationships" xmlns:a="http://schemas.openxmlformats.org/drawingml/2006/main" r:embed="R30ca40c33f5248b0"/>
+          <a:blip xmlns:r="http://schemas.openxmlformats.org/officeDocument/2006/relationships" xmlns:a="http://schemas.openxmlformats.org/drawingml/2006/main" r:embed="R0054615e4f8349b7"/>
           <a:stretch xmlns:a="http://schemas.openxmlformats.org/drawingml/2006/main"/>
         </p:blipFill>
         <p:spPr>
@@ -15731,7 +16075,7 @@
           <p:cNvPr id="5" name="">
             <a:extLst xmlns:a="http://schemas.openxmlformats.org/drawingml/2006/main">
               <a:ext uri="{FF2B5EF4-FFF2-40B4-BE49-F238E27FC236}">
-                <a16:creationId xmlns:a16="http://schemas.microsoft.com/office/drawing/2014/main" id="{6C25D400-88FB-42E6-BE42-F5AE68FB9584}"/>
+                <a16:creationId xmlns:a16="http://schemas.microsoft.com/office/drawing/2014/main" id="{6BD5FDD3-D2EC-4237-A5EA-3FF983CE235A}"/>
               </a:ext>
             </a:extLst>
           </p:cNvPr>
@@ -15889,7 +16233,7 @@
           <p:cNvPr id="6" name="">
             <a:extLst xmlns:a="http://schemas.openxmlformats.org/drawingml/2006/main">
               <a:ext uri="{FF2B5EF4-FFF2-40B4-BE49-F238E27FC236}">
-                <a16:creationId xmlns:a16="http://schemas.microsoft.com/office/drawing/2014/main" id="{0785496B-2558-47E1-A23D-15E5E5E9CE79}"/>
+                <a16:creationId xmlns:a16="http://schemas.microsoft.com/office/drawing/2014/main" id="{615DA0D6-6E10-4AC7-A92F-FFFD422B0441}"/>
               </a:ext>
             </a:extLst>
           </p:cNvPr>
@@ -16047,7 +16391,7 @@
           <p:cNvPr id="7" name="">
             <a:extLst xmlns:a="http://schemas.openxmlformats.org/drawingml/2006/main">
               <a:ext uri="{FF2B5EF4-FFF2-40B4-BE49-F238E27FC236}">
-                <a16:creationId xmlns:a16="http://schemas.microsoft.com/office/drawing/2014/main" id="{062AC3DD-30D0-402E-99E5-374909C8F349}"/>
+                <a16:creationId xmlns:a16="http://schemas.microsoft.com/office/drawing/2014/main" id="{6BF2A3C0-5477-41B5-8F58-C14F44D99BD6}"/>
               </a:ext>
             </a:extLst>
           </p:cNvPr>
@@ -16057,7 +16401,7 @@
           <p:nvPr/>
         </p:nvPicPr>
         <p:blipFill>
-          <a:blip xmlns:r="http://schemas.openxmlformats.org/officeDocument/2006/relationships" xmlns:a="http://schemas.openxmlformats.org/drawingml/2006/main" r:embed="Rf77c12dd2444417c"/>
+          <a:blip xmlns:r="http://schemas.openxmlformats.org/officeDocument/2006/relationships" xmlns:a="http://schemas.openxmlformats.org/drawingml/2006/main" r:embed="R0253bda067f44dd6"/>
           <a:stretch xmlns:a="http://schemas.openxmlformats.org/drawingml/2006/main"/>
         </p:blipFill>
         <p:spPr>
@@ -16075,7 +16419,7 @@
           <p:cNvPr id="8" name="">
             <a:extLst xmlns:a="http://schemas.openxmlformats.org/drawingml/2006/main">
               <a:ext uri="{FF2B5EF4-FFF2-40B4-BE49-F238E27FC236}">
-                <a16:creationId xmlns:a16="http://schemas.microsoft.com/office/drawing/2014/main" id="{91212224-BD5F-484B-8A53-7B700C9B36E7}"/>
+                <a16:creationId xmlns:a16="http://schemas.microsoft.com/office/drawing/2014/main" id="{BB129EB8-3CFF-4C76-B00F-754B1791A564}"/>
               </a:ext>
             </a:extLst>
           </p:cNvPr>
@@ -16233,7 +16577,7 @@
           <p:cNvPr id="9" name="">
             <a:extLst xmlns:a="http://schemas.openxmlformats.org/drawingml/2006/main">
               <a:ext uri="{FF2B5EF4-FFF2-40B4-BE49-F238E27FC236}">
-                <a16:creationId xmlns:a16="http://schemas.microsoft.com/office/drawing/2014/main" id="{090CA5D5-4DB4-4159-BE88-FF0C784DBD09}"/>
+                <a16:creationId xmlns:a16="http://schemas.microsoft.com/office/drawing/2014/main" id="{7BA512E5-5440-4197-A9F1-4F26616472BE}"/>
               </a:ext>
             </a:extLst>
           </p:cNvPr>
@@ -16391,7 +16735,7 @@
           <p:cNvPr id="10" name="">
             <a:extLst xmlns:a="http://schemas.openxmlformats.org/drawingml/2006/main">
               <a:ext uri="{FF2B5EF4-FFF2-40B4-BE49-F238E27FC236}">
-                <a16:creationId xmlns:a16="http://schemas.microsoft.com/office/drawing/2014/main" id="{02920705-0655-4546-8FA0-62F068D38274}"/>
+                <a16:creationId xmlns:a16="http://schemas.microsoft.com/office/drawing/2014/main" id="{B9597863-396B-4289-906B-3B8AB67E2406}"/>
               </a:ext>
             </a:extLst>
           </p:cNvPr>
@@ -16577,7 +16921,7 @@
           <p:cNvPr id="11" name="">
             <a:extLst xmlns:a="http://schemas.openxmlformats.org/drawingml/2006/main">
               <a:ext uri="{FF2B5EF4-FFF2-40B4-BE49-F238E27FC236}">
-                <a16:creationId xmlns:a16="http://schemas.microsoft.com/office/drawing/2014/main" id="{CB20EBE8-87F8-4083-A485-391073185A33}"/>
+                <a16:creationId xmlns:a16="http://schemas.microsoft.com/office/drawing/2014/main" id="{CEF0BB40-A138-4B82-9CA1-667990CE1A89}"/>
               </a:ext>
             </a:extLst>
           </p:cNvPr>
@@ -16735,7 +17079,7 @@
           <p:cNvPr id="12" name="">
             <a:extLst xmlns:a="http://schemas.openxmlformats.org/drawingml/2006/main">
               <a:ext uri="{FF2B5EF4-FFF2-40B4-BE49-F238E27FC236}">
-                <a16:creationId xmlns:a16="http://schemas.microsoft.com/office/drawing/2014/main" id="{9526D5CE-3C19-4141-90E6-7B697047F003}"/>
+                <a16:creationId xmlns:a16="http://schemas.microsoft.com/office/drawing/2014/main" id="{F4073244-68D6-4DE5-922B-A7DDB32B2CBD}"/>
               </a:ext>
             </a:extLst>
           </p:cNvPr>
@@ -16892,7 +17236,7 @@
     </p:spTree>
     <p:extLst>
       <p:ext uri="{BB962C8B-B14F-4D97-AF65-F5344CB8AC3E}">
-        <p14:creationId xmlns:p14="http://schemas.microsoft.com/office/powerpoint/2010/main" val="104967007"/>
+        <p14:creationId xmlns:p14="http://schemas.microsoft.com/office/powerpoint/2010/main" val="125880501"/>
       </p:ext>
     </p:extLst>
   </p:cSld>
@@ -16923,7 +17267,7 @@
           <p:cNvPr id="13" name="">
             <a:extLst xmlns:a="http://schemas.openxmlformats.org/drawingml/2006/main">
               <a:ext uri="{FF2B5EF4-FFF2-40B4-BE49-F238E27FC236}">
-                <a16:creationId xmlns:a16="http://schemas.microsoft.com/office/drawing/2014/main" id="{20454FE1-4A00-4E58-BCE4-622B83E1DE4C}"/>
+                <a16:creationId xmlns:a16="http://schemas.microsoft.com/office/drawing/2014/main" id="{87CCB663-AA63-44F3-813A-7F44848FAE9F}"/>
               </a:ext>
             </a:extLst>
           </p:cNvPr>
@@ -17081,7 +17425,7 @@
           <p:cNvPr id="2" name="">
             <a:extLst xmlns:a="http://schemas.openxmlformats.org/drawingml/2006/main">
               <a:ext uri="{FF2B5EF4-FFF2-40B4-BE49-F238E27FC236}">
-                <a16:creationId xmlns:a16="http://schemas.microsoft.com/office/drawing/2014/main" id="{B123B2C2-4026-48F0-9FB3-FCCB8D92FE90}"/>
+                <a16:creationId xmlns:a16="http://schemas.microsoft.com/office/drawing/2014/main" id="{DDA90A20-DA0A-4270-B9D7-EEBDDABBC0A8}"/>
               </a:ext>
             </a:extLst>
           </p:cNvPr>
@@ -17239,7 +17583,7 @@
           <p:cNvPr id="3" name="">
             <a:extLst xmlns:a="http://schemas.openxmlformats.org/drawingml/2006/main">
               <a:ext uri="{FF2B5EF4-FFF2-40B4-BE49-F238E27FC236}">
-                <a16:creationId xmlns:a16="http://schemas.microsoft.com/office/drawing/2014/main" id="{02B8D559-B05B-4A23-A7F2-DBBD919C0C84}"/>
+                <a16:creationId xmlns:a16="http://schemas.microsoft.com/office/drawing/2014/main" id="{1674B27C-4B95-4D83-947F-27B797B62411}"/>
               </a:ext>
             </a:extLst>
           </p:cNvPr>
@@ -17397,7 +17741,7 @@
           <p:cNvPr id="4" name="">
             <a:extLst xmlns:a="http://schemas.openxmlformats.org/drawingml/2006/main">
               <a:ext uri="{FF2B5EF4-FFF2-40B4-BE49-F238E27FC236}">
-                <a16:creationId xmlns:a16="http://schemas.microsoft.com/office/drawing/2014/main" id="{808DB78E-C43F-463A-8153-03AAF6CCD961}"/>
+                <a16:creationId xmlns:a16="http://schemas.microsoft.com/office/drawing/2014/main" id="{7BA6F795-9743-4F21-B465-FE0F4296F9A5}"/>
               </a:ext>
             </a:extLst>
           </p:cNvPr>
@@ -17407,7 +17751,7 @@
           <p:nvPr/>
         </p:nvPicPr>
         <p:blipFill>
-          <a:blip xmlns:r="http://schemas.openxmlformats.org/officeDocument/2006/relationships" xmlns:a="http://schemas.openxmlformats.org/drawingml/2006/main" r:embed="R2d62b307d3cf4021"/>
+          <a:blip xmlns:r="http://schemas.openxmlformats.org/officeDocument/2006/relationships" xmlns:a="http://schemas.openxmlformats.org/drawingml/2006/main" r:embed="R1dd66f6501874e78"/>
           <a:stretch xmlns:a="http://schemas.openxmlformats.org/drawingml/2006/main"/>
         </p:blipFill>
         <p:spPr>
@@ -17425,7 +17769,7 @@
           <p:cNvPr id="5" name="">
             <a:extLst xmlns:a="http://schemas.openxmlformats.org/drawingml/2006/main">
               <a:ext uri="{FF2B5EF4-FFF2-40B4-BE49-F238E27FC236}">
-                <a16:creationId xmlns:a16="http://schemas.microsoft.com/office/drawing/2014/main" id="{102F7757-80EC-4230-9247-0158AEC0DE52}"/>
+                <a16:creationId xmlns:a16="http://schemas.microsoft.com/office/drawing/2014/main" id="{D3E02F88-D48A-4AAC-B9E8-0CD2CBEB8CEF}"/>
               </a:ext>
             </a:extLst>
           </p:cNvPr>
@@ -17583,7 +17927,7 @@
           <p:cNvPr id="6" name="">
             <a:extLst xmlns:a="http://schemas.openxmlformats.org/drawingml/2006/main">
               <a:ext uri="{FF2B5EF4-FFF2-40B4-BE49-F238E27FC236}">
-                <a16:creationId xmlns:a16="http://schemas.microsoft.com/office/drawing/2014/main" id="{4330A5FE-4FBE-449E-A9B9-5DE8BEE3D07E}"/>
+                <a16:creationId xmlns:a16="http://schemas.microsoft.com/office/drawing/2014/main" id="{76BDF96F-4F51-4328-84B8-E785D086BBD3}"/>
               </a:ext>
             </a:extLst>
           </p:cNvPr>
@@ -17741,7 +18085,7 @@
           <p:cNvPr id="7" name="">
             <a:extLst xmlns:a="http://schemas.openxmlformats.org/drawingml/2006/main">
               <a:ext uri="{FF2B5EF4-FFF2-40B4-BE49-F238E27FC236}">
-                <a16:creationId xmlns:a16="http://schemas.microsoft.com/office/drawing/2014/main" id="{AC5072F6-4ECB-4899-81B8-01BB3F6BF928}"/>
+                <a16:creationId xmlns:a16="http://schemas.microsoft.com/office/drawing/2014/main" id="{5997947A-567D-4E3F-ACF1-17C5284D718F}"/>
               </a:ext>
             </a:extLst>
           </p:cNvPr>
@@ -17751,7 +18095,7 @@
           <p:nvPr/>
         </p:nvPicPr>
         <p:blipFill>
-          <a:blip xmlns:r="http://schemas.openxmlformats.org/officeDocument/2006/relationships" xmlns:a="http://schemas.openxmlformats.org/drawingml/2006/main" r:embed="R97b53706e1834b13"/>
+          <a:blip xmlns:r="http://schemas.openxmlformats.org/officeDocument/2006/relationships" xmlns:a="http://schemas.openxmlformats.org/drawingml/2006/main" r:embed="R93278c7b0fa04a30"/>
           <a:stretch xmlns:a="http://schemas.openxmlformats.org/drawingml/2006/main"/>
         </p:blipFill>
         <p:spPr>
@@ -17769,7 +18113,7 @@
           <p:cNvPr id="8" name="">
             <a:extLst xmlns:a="http://schemas.openxmlformats.org/drawingml/2006/main">
               <a:ext uri="{FF2B5EF4-FFF2-40B4-BE49-F238E27FC236}">
-                <a16:creationId xmlns:a16="http://schemas.microsoft.com/office/drawing/2014/main" id="{8D75DC64-1ABF-44FC-9E7A-475546A8229B}"/>
+                <a16:creationId xmlns:a16="http://schemas.microsoft.com/office/drawing/2014/main" id="{133CCB0C-D4E7-4B0A-9257-DD21ED6443C0}"/>
               </a:ext>
             </a:extLst>
           </p:cNvPr>
@@ -17927,7 +18271,7 @@
           <p:cNvPr id="9" name="">
             <a:extLst xmlns:a="http://schemas.openxmlformats.org/drawingml/2006/main">
               <a:ext uri="{FF2B5EF4-FFF2-40B4-BE49-F238E27FC236}">
-                <a16:creationId xmlns:a16="http://schemas.microsoft.com/office/drawing/2014/main" id="{3E4FE19C-5E5C-45E3-A2E9-A2D236199938}"/>
+                <a16:creationId xmlns:a16="http://schemas.microsoft.com/office/drawing/2014/main" id="{9E2D51C7-5120-4C3A-8A59-C6F30DEFF753}"/>
               </a:ext>
             </a:extLst>
           </p:cNvPr>
@@ -18085,7 +18429,7 @@
           <p:cNvPr id="10" name="">
             <a:extLst xmlns:a="http://schemas.openxmlformats.org/drawingml/2006/main">
               <a:ext uri="{FF2B5EF4-FFF2-40B4-BE49-F238E27FC236}">
-                <a16:creationId xmlns:a16="http://schemas.microsoft.com/office/drawing/2014/main" id="{92202CE9-DC6B-4B02-AB9C-67B98C619EEF}"/>
+                <a16:creationId xmlns:a16="http://schemas.microsoft.com/office/drawing/2014/main" id="{23770ACC-181B-4A4B-ADDD-EDF00A06CE97}"/>
               </a:ext>
             </a:extLst>
           </p:cNvPr>
@@ -18271,7 +18615,7 @@
           <p:cNvPr id="11" name="">
             <a:extLst xmlns:a="http://schemas.openxmlformats.org/drawingml/2006/main">
               <a:ext uri="{FF2B5EF4-FFF2-40B4-BE49-F238E27FC236}">
-                <a16:creationId xmlns:a16="http://schemas.microsoft.com/office/drawing/2014/main" id="{CF25D554-A871-4F51-BF11-61CC71767F3B}"/>
+                <a16:creationId xmlns:a16="http://schemas.microsoft.com/office/drawing/2014/main" id="{F9721D05-D763-4A37-B6AE-5DD8007C8846}"/>
               </a:ext>
             </a:extLst>
           </p:cNvPr>
@@ -18429,7 +18773,7 @@
           <p:cNvPr id="12" name="">
             <a:extLst xmlns:a="http://schemas.openxmlformats.org/drawingml/2006/main">
               <a:ext uri="{FF2B5EF4-FFF2-40B4-BE49-F238E27FC236}">
-                <a16:creationId xmlns:a16="http://schemas.microsoft.com/office/drawing/2014/main" id="{67F42C7C-B7FF-4BB5-B56E-9F34CE7DDF75}"/>
+                <a16:creationId xmlns:a16="http://schemas.microsoft.com/office/drawing/2014/main" id="{58D1B518-C1E8-44E5-BDDE-869E3C95CD36}"/>
               </a:ext>
             </a:extLst>
           </p:cNvPr>
@@ -18585,7 +18929,7 @@
     </p:spTree>
     <p:extLst>
       <p:ext uri="{BB962C8B-B14F-4D97-AF65-F5344CB8AC3E}">
-        <p14:creationId xmlns:p14="http://schemas.microsoft.com/office/powerpoint/2010/main" val="1196811467"/>
+        <p14:creationId xmlns:p14="http://schemas.microsoft.com/office/powerpoint/2010/main" val="180938520"/>
       </p:ext>
     </p:extLst>
   </p:cSld>
@@ -18616,7 +18960,7 @@
           <p:cNvPr id="13" name="">
             <a:extLst xmlns:a="http://schemas.openxmlformats.org/drawingml/2006/main">
               <a:ext uri="{FF2B5EF4-FFF2-40B4-BE49-F238E27FC236}">
-                <a16:creationId xmlns:a16="http://schemas.microsoft.com/office/drawing/2014/main" id="{89996B3C-70D0-4F76-82E4-5149B800EEC7}"/>
+                <a16:creationId xmlns:a16="http://schemas.microsoft.com/office/drawing/2014/main" id="{414D659B-3BE7-4C2A-B5B7-7C155E6D1FD1}"/>
               </a:ext>
             </a:extLst>
           </p:cNvPr>
@@ -18774,7 +19118,7 @@
           <p:cNvPr id="2" name="">
             <a:extLst xmlns:a="http://schemas.openxmlformats.org/drawingml/2006/main">
               <a:ext uri="{FF2B5EF4-FFF2-40B4-BE49-F238E27FC236}">
-                <a16:creationId xmlns:a16="http://schemas.microsoft.com/office/drawing/2014/main" id="{D41E9E27-4A09-4612-AF55-3487731585CE}"/>
+                <a16:creationId xmlns:a16="http://schemas.microsoft.com/office/drawing/2014/main" id="{7F26D2E6-A8D9-4A95-B7D4-0AFBF233C637}"/>
               </a:ext>
             </a:extLst>
           </p:cNvPr>
@@ -18932,7 +19276,7 @@
           <p:cNvPr id="3" name="">
             <a:extLst xmlns:a="http://schemas.openxmlformats.org/drawingml/2006/main">
               <a:ext uri="{FF2B5EF4-FFF2-40B4-BE49-F238E27FC236}">
-                <a16:creationId xmlns:a16="http://schemas.microsoft.com/office/drawing/2014/main" id="{443F643A-773A-4C45-8100-18C0D9951234}"/>
+                <a16:creationId xmlns:a16="http://schemas.microsoft.com/office/drawing/2014/main" id="{A7C12207-5972-4AEF-A6B2-F16508C41100}"/>
               </a:ext>
             </a:extLst>
           </p:cNvPr>
@@ -19090,7 +19434,7 @@
           <p:cNvPr id="4" name="">
             <a:extLst xmlns:a="http://schemas.openxmlformats.org/drawingml/2006/main">
               <a:ext uri="{FF2B5EF4-FFF2-40B4-BE49-F238E27FC236}">
-                <a16:creationId xmlns:a16="http://schemas.microsoft.com/office/drawing/2014/main" id="{D7924EB1-3EDB-45D7-BB44-07375F9C6F40}"/>
+                <a16:creationId xmlns:a16="http://schemas.microsoft.com/office/drawing/2014/main" id="{C9E82187-DB2A-481A-9AAB-F7CA513B82E7}"/>
               </a:ext>
             </a:extLst>
           </p:cNvPr>
@@ -19100,7 +19444,7 @@
           <p:nvPr/>
         </p:nvPicPr>
         <p:blipFill>
-          <a:blip xmlns:r="http://schemas.openxmlformats.org/officeDocument/2006/relationships" xmlns:a="http://schemas.openxmlformats.org/drawingml/2006/main" r:embed="Rc2caae34f12244b1"/>
+          <a:blip xmlns:r="http://schemas.openxmlformats.org/officeDocument/2006/relationships" xmlns:a="http://schemas.openxmlformats.org/drawingml/2006/main" r:embed="R01b1d6a2929b4a02"/>
           <a:stretch xmlns:a="http://schemas.openxmlformats.org/drawingml/2006/main"/>
         </p:blipFill>
         <p:spPr>
@@ -19118,7 +19462,7 @@
           <p:cNvPr id="5" name="">
             <a:extLst xmlns:a="http://schemas.openxmlformats.org/drawingml/2006/main">
               <a:ext uri="{FF2B5EF4-FFF2-40B4-BE49-F238E27FC236}">
-                <a16:creationId xmlns:a16="http://schemas.microsoft.com/office/drawing/2014/main" id="{77931CEB-EEE3-426E-80D0-82B467D098EA}"/>
+                <a16:creationId xmlns:a16="http://schemas.microsoft.com/office/drawing/2014/main" id="{89A153F2-18A6-4F99-BC1A-1BCC5BD148D7}"/>
               </a:ext>
             </a:extLst>
           </p:cNvPr>
@@ -19276,7 +19620,7 @@
           <p:cNvPr id="6" name="">
             <a:extLst xmlns:a="http://schemas.openxmlformats.org/drawingml/2006/main">
               <a:ext uri="{FF2B5EF4-FFF2-40B4-BE49-F238E27FC236}">
-                <a16:creationId xmlns:a16="http://schemas.microsoft.com/office/drawing/2014/main" id="{6423375F-D577-4A04-BABC-CC7CDEF3CC7C}"/>
+                <a16:creationId xmlns:a16="http://schemas.microsoft.com/office/drawing/2014/main" id="{E93D0954-CD62-4584-B2A7-B090DC5B62BD}"/>
               </a:ext>
             </a:extLst>
           </p:cNvPr>
@@ -19434,7 +19778,7 @@
           <p:cNvPr id="7" name="">
             <a:extLst xmlns:a="http://schemas.openxmlformats.org/drawingml/2006/main">
               <a:ext uri="{FF2B5EF4-FFF2-40B4-BE49-F238E27FC236}">
-                <a16:creationId xmlns:a16="http://schemas.microsoft.com/office/drawing/2014/main" id="{E6C296A1-2F67-4408-84AF-6ECF0E39C109}"/>
+                <a16:creationId xmlns:a16="http://schemas.microsoft.com/office/drawing/2014/main" id="{4327BE45-2431-4127-8CB4-6DE02AC04044}"/>
               </a:ext>
             </a:extLst>
           </p:cNvPr>
@@ -19444,7 +19788,7 @@
           <p:nvPr/>
         </p:nvPicPr>
         <p:blipFill>
-          <a:blip xmlns:r="http://schemas.openxmlformats.org/officeDocument/2006/relationships" xmlns:a="http://schemas.openxmlformats.org/drawingml/2006/main" r:embed="Rc7962c77ffc448c8"/>
+          <a:blip xmlns:r="http://schemas.openxmlformats.org/officeDocument/2006/relationships" xmlns:a="http://schemas.openxmlformats.org/drawingml/2006/main" r:embed="R41f4d9e2c2034ae3"/>
           <a:stretch xmlns:a="http://schemas.openxmlformats.org/drawingml/2006/main"/>
         </p:blipFill>
         <p:spPr>
@@ -19462,7 +19806,7 @@
           <p:cNvPr id="8" name="">
             <a:extLst xmlns:a="http://schemas.openxmlformats.org/drawingml/2006/main">
               <a:ext uri="{FF2B5EF4-FFF2-40B4-BE49-F238E27FC236}">
-                <a16:creationId xmlns:a16="http://schemas.microsoft.com/office/drawing/2014/main" id="{45A6C748-CCB2-4609-A7A9-0F8A013898FF}"/>
+                <a16:creationId xmlns:a16="http://schemas.microsoft.com/office/drawing/2014/main" id="{FA735C1B-B9FF-4392-97F2-5E00ED266C4B}"/>
               </a:ext>
             </a:extLst>
           </p:cNvPr>
@@ -19620,7 +19964,7 @@
           <p:cNvPr id="9" name="">
             <a:extLst xmlns:a="http://schemas.openxmlformats.org/drawingml/2006/main">
               <a:ext uri="{FF2B5EF4-FFF2-40B4-BE49-F238E27FC236}">
-                <a16:creationId xmlns:a16="http://schemas.microsoft.com/office/drawing/2014/main" id="{973722F7-77F9-4DE5-9889-692011C02ABC}"/>
+                <a16:creationId xmlns:a16="http://schemas.microsoft.com/office/drawing/2014/main" id="{5DA7A37C-3D9B-4AEA-853D-DA0D55A609AE}"/>
               </a:ext>
             </a:extLst>
           </p:cNvPr>
@@ -19778,7 +20122,7 @@
           <p:cNvPr id="10" name="">
             <a:extLst xmlns:a="http://schemas.openxmlformats.org/drawingml/2006/main">
               <a:ext uri="{FF2B5EF4-FFF2-40B4-BE49-F238E27FC236}">
-                <a16:creationId xmlns:a16="http://schemas.microsoft.com/office/drawing/2014/main" id="{572FF1CD-9060-480C-BBB2-EA59EE2A3760}"/>
+                <a16:creationId xmlns:a16="http://schemas.microsoft.com/office/drawing/2014/main" id="{8BC588F7-78B8-4ABC-8213-B4B7DE95AFB1}"/>
               </a:ext>
             </a:extLst>
           </p:cNvPr>
@@ -19964,7 +20308,7 @@
           <p:cNvPr id="11" name="">
             <a:extLst xmlns:a="http://schemas.openxmlformats.org/drawingml/2006/main">
               <a:ext uri="{FF2B5EF4-FFF2-40B4-BE49-F238E27FC236}">
-                <a16:creationId xmlns:a16="http://schemas.microsoft.com/office/drawing/2014/main" id="{1675BF57-2EC1-4011-B467-6409721035D5}"/>
+                <a16:creationId xmlns:a16="http://schemas.microsoft.com/office/drawing/2014/main" id="{8F315425-875C-45D2-BD13-72824F356D85}"/>
               </a:ext>
             </a:extLst>
           </p:cNvPr>
@@ -20122,7 +20466,7 @@
           <p:cNvPr id="12" name="">
             <a:extLst xmlns:a="http://schemas.openxmlformats.org/drawingml/2006/main">
               <a:ext uri="{FF2B5EF4-FFF2-40B4-BE49-F238E27FC236}">
-                <a16:creationId xmlns:a16="http://schemas.microsoft.com/office/drawing/2014/main" id="{E79AAF55-8398-403D-8C1A-50C1BC269AA0}"/>
+                <a16:creationId xmlns:a16="http://schemas.microsoft.com/office/drawing/2014/main" id="{7FE06024-179A-495A-B900-509322DCD65B}"/>
               </a:ext>
             </a:extLst>
           </p:cNvPr>
@@ -20278,7 +20622,7 @@
     </p:spTree>
     <p:extLst>
       <p:ext uri="{BB962C8B-B14F-4D97-AF65-F5344CB8AC3E}">
-        <p14:creationId xmlns:p14="http://schemas.microsoft.com/office/powerpoint/2010/main" val="1851701597"/>
+        <p14:creationId xmlns:p14="http://schemas.microsoft.com/office/powerpoint/2010/main" val="1575964576"/>
       </p:ext>
     </p:extLst>
   </p:cSld>
@@ -20309,7 +20653,7 @@
           <p:cNvPr id="14" name="">
             <a:extLst xmlns:a="http://schemas.openxmlformats.org/drawingml/2006/main">
               <a:ext uri="{FF2B5EF4-FFF2-40B4-BE49-F238E27FC236}">
-                <a16:creationId xmlns:a16="http://schemas.microsoft.com/office/drawing/2014/main" id="{6AB5BE40-F74C-48C8-9E70-1F6E9B764F90}"/>
+                <a16:creationId xmlns:a16="http://schemas.microsoft.com/office/drawing/2014/main" id="{B7E0D47F-F1EC-41D6-8B74-EB42B8C6D91B}"/>
               </a:ext>
             </a:extLst>
           </p:cNvPr>
@@ -20467,7 +20811,7 @@
           <p:cNvPr id="2" name="">
             <a:extLst xmlns:a="http://schemas.openxmlformats.org/drawingml/2006/main">
               <a:ext uri="{FF2B5EF4-FFF2-40B4-BE49-F238E27FC236}">
-                <a16:creationId xmlns:a16="http://schemas.microsoft.com/office/drawing/2014/main" id="{9C485713-729C-4E7C-B730-5654E91B4211}"/>
+                <a16:creationId xmlns:a16="http://schemas.microsoft.com/office/drawing/2014/main" id="{94CEF824-33D9-4B9B-92C2-21884F08A035}"/>
               </a:ext>
             </a:extLst>
           </p:cNvPr>
@@ -20625,7 +20969,7 @@
           <p:cNvPr id="3" name="">
             <a:extLst xmlns:a="http://schemas.openxmlformats.org/drawingml/2006/main">
               <a:ext uri="{FF2B5EF4-FFF2-40B4-BE49-F238E27FC236}">
-                <a16:creationId xmlns:a16="http://schemas.microsoft.com/office/drawing/2014/main" id="{84729002-4F5B-4057-B83D-B7D055971D04}"/>
+                <a16:creationId xmlns:a16="http://schemas.microsoft.com/office/drawing/2014/main" id="{F34D98F9-1832-4BEE-B1A4-44684D25D295}"/>
               </a:ext>
             </a:extLst>
           </p:cNvPr>
@@ -20783,7 +21127,7 @@
           <p:cNvPr id="4" name="">
             <a:extLst xmlns:a="http://schemas.openxmlformats.org/drawingml/2006/main">
               <a:ext uri="{FF2B5EF4-FFF2-40B4-BE49-F238E27FC236}">
-                <a16:creationId xmlns:a16="http://schemas.microsoft.com/office/drawing/2014/main" id="{3F96B6FE-7D58-4FFC-8BC9-B3BFF8546127}"/>
+                <a16:creationId xmlns:a16="http://schemas.microsoft.com/office/drawing/2014/main" id="{92B32510-EDC7-4CC0-AE81-14A64A4C1163}"/>
               </a:ext>
             </a:extLst>
           </p:cNvPr>
@@ -20793,7 +21137,7 @@
           <p:nvPr/>
         </p:nvPicPr>
         <p:blipFill>
-          <a:blip xmlns:r="http://schemas.openxmlformats.org/officeDocument/2006/relationships" xmlns:a="http://schemas.openxmlformats.org/drawingml/2006/main" r:embed="Rb89f1209bbc54b7d"/>
+          <a:blip xmlns:r="http://schemas.openxmlformats.org/officeDocument/2006/relationships" xmlns:a="http://schemas.openxmlformats.org/drawingml/2006/main" r:embed="R1622c0210c40447f"/>
           <a:stretch xmlns:a="http://schemas.openxmlformats.org/drawingml/2006/main"/>
         </p:blipFill>
         <p:spPr>
@@ -20811,7 +21155,7 @@
           <p:cNvPr id="5" name="">
             <a:extLst xmlns:a="http://schemas.openxmlformats.org/drawingml/2006/main">
               <a:ext uri="{FF2B5EF4-FFF2-40B4-BE49-F238E27FC236}">
-                <a16:creationId xmlns:a16="http://schemas.microsoft.com/office/drawing/2014/main" id="{4D8C6B44-E9E0-4D6E-9A5F-7210F899827E}"/>
+                <a16:creationId xmlns:a16="http://schemas.microsoft.com/office/drawing/2014/main" id="{9D40182B-D962-42F8-A78B-8086D453C827}"/>
               </a:ext>
             </a:extLst>
           </p:cNvPr>
@@ -20969,7 +21313,7 @@
           <p:cNvPr id="6" name="">
             <a:extLst xmlns:a="http://schemas.openxmlformats.org/drawingml/2006/main">
               <a:ext uri="{FF2B5EF4-FFF2-40B4-BE49-F238E27FC236}">
-                <a16:creationId xmlns:a16="http://schemas.microsoft.com/office/drawing/2014/main" id="{3343FFB5-63A4-4B54-B3A8-5792783F8DDA}"/>
+                <a16:creationId xmlns:a16="http://schemas.microsoft.com/office/drawing/2014/main" id="{E78C7804-EF3D-4DF4-B10C-D36336632ED7}"/>
               </a:ext>
             </a:extLst>
           </p:cNvPr>
@@ -21127,7 +21471,7 @@
           <p:cNvPr id="7" name="">
             <a:extLst xmlns:a="http://schemas.openxmlformats.org/drawingml/2006/main">
               <a:ext uri="{FF2B5EF4-FFF2-40B4-BE49-F238E27FC236}">
-                <a16:creationId xmlns:a16="http://schemas.microsoft.com/office/drawing/2014/main" id="{DBF7E3EB-E9C9-41F0-9D80-16FC7CDC94EF}"/>
+                <a16:creationId xmlns:a16="http://schemas.microsoft.com/office/drawing/2014/main" id="{BA39B946-EAA6-497D-A043-13371F6A0987}"/>
               </a:ext>
             </a:extLst>
           </p:cNvPr>
@@ -21137,7 +21481,7 @@
           <p:nvPr/>
         </p:nvPicPr>
         <p:blipFill>
-          <a:blip xmlns:r="http://schemas.openxmlformats.org/officeDocument/2006/relationships" xmlns:a="http://schemas.openxmlformats.org/drawingml/2006/main" r:embed="R42246fec17b04759"/>
+          <a:blip xmlns:r="http://schemas.openxmlformats.org/officeDocument/2006/relationships" xmlns:a="http://schemas.openxmlformats.org/drawingml/2006/main" r:embed="R3284f576faee4062"/>
           <a:stretch xmlns:a="http://schemas.openxmlformats.org/drawingml/2006/main"/>
         </p:blipFill>
         <p:spPr>
@@ -21155,7 +21499,7 @@
           <p:cNvPr id="8" name="">
             <a:extLst xmlns:a="http://schemas.openxmlformats.org/drawingml/2006/main">
               <a:ext uri="{FF2B5EF4-FFF2-40B4-BE49-F238E27FC236}">
-                <a16:creationId xmlns:a16="http://schemas.microsoft.com/office/drawing/2014/main" id="{1DAC46ED-CE6A-41D5-9825-6DAC381115AB}"/>
+                <a16:creationId xmlns:a16="http://schemas.microsoft.com/office/drawing/2014/main" id="{0017D27D-64E9-4302-9D96-84C35D70AC61}"/>
               </a:ext>
             </a:extLst>
           </p:cNvPr>
@@ -21313,7 +21657,7 @@
           <p:cNvPr id="9" name="">
             <a:extLst xmlns:a="http://schemas.openxmlformats.org/drawingml/2006/main">
               <a:ext uri="{FF2B5EF4-FFF2-40B4-BE49-F238E27FC236}">
-                <a16:creationId xmlns:a16="http://schemas.microsoft.com/office/drawing/2014/main" id="{0660C224-964C-4945-B162-452B4ADAFE39}"/>
+                <a16:creationId xmlns:a16="http://schemas.microsoft.com/office/drawing/2014/main" id="{BA1A0399-C1BA-4D96-B7B0-1C4404A96ACD}"/>
               </a:ext>
             </a:extLst>
           </p:cNvPr>
@@ -21471,7 +21815,7 @@
           <p:cNvPr id="10" name="">
             <a:extLst xmlns:a="http://schemas.openxmlformats.org/drawingml/2006/main">
               <a:ext uri="{FF2B5EF4-FFF2-40B4-BE49-F238E27FC236}">
-                <a16:creationId xmlns:a16="http://schemas.microsoft.com/office/drawing/2014/main" id="{1463C3E3-F245-4C5F-A30B-5DF5E5396F50}"/>
+                <a16:creationId xmlns:a16="http://schemas.microsoft.com/office/drawing/2014/main" id="{8D8B2FBE-AB88-4F35-895A-9DAD05CF4116}"/>
               </a:ext>
             </a:extLst>
           </p:cNvPr>
@@ -21481,7 +21825,7 @@
           <p:nvPr/>
         </p:nvPicPr>
         <p:blipFill>
-          <a:blip xmlns:r="http://schemas.openxmlformats.org/officeDocument/2006/relationships" xmlns:a="http://schemas.openxmlformats.org/drawingml/2006/main" r:embed="Rc04f514a6f3c4a49"/>
+          <a:blip xmlns:r="http://schemas.openxmlformats.org/officeDocument/2006/relationships" xmlns:a="http://schemas.openxmlformats.org/drawingml/2006/main" r:embed="Rfcb028e1ba334eae"/>
           <a:stretch xmlns:a="http://schemas.openxmlformats.org/drawingml/2006/main"/>
         </p:blipFill>
         <p:spPr>
@@ -21499,7 +21843,7 @@
           <p:cNvPr id="11" name="">
             <a:extLst xmlns:a="http://schemas.openxmlformats.org/drawingml/2006/main">
               <a:ext uri="{FF2B5EF4-FFF2-40B4-BE49-F238E27FC236}">
-                <a16:creationId xmlns:a16="http://schemas.microsoft.com/office/drawing/2014/main" id="{24D87A34-46FE-4628-B5CF-FB80342404AC}"/>
+                <a16:creationId xmlns:a16="http://schemas.microsoft.com/office/drawing/2014/main" id="{BC19CF98-5995-44FE-B251-D6872DF989FA}"/>
               </a:ext>
             </a:extLst>
           </p:cNvPr>
@@ -21657,7 +22001,7 @@
           <p:cNvPr id="12" name="">
             <a:extLst xmlns:a="http://schemas.openxmlformats.org/drawingml/2006/main">
               <a:ext uri="{FF2B5EF4-FFF2-40B4-BE49-F238E27FC236}">
-                <a16:creationId xmlns:a16="http://schemas.microsoft.com/office/drawing/2014/main" id="{43A95E57-782A-4B6A-AFE9-C5AE7C48AEE3}"/>
+                <a16:creationId xmlns:a16="http://schemas.microsoft.com/office/drawing/2014/main" id="{665E202F-7E77-42F8-976F-1BA1BE201F8E}"/>
               </a:ext>
             </a:extLst>
           </p:cNvPr>
@@ -21815,7 +22159,7 @@
           <p:cNvPr id="13" name="">
             <a:extLst xmlns:a="http://schemas.openxmlformats.org/drawingml/2006/main">
               <a:ext uri="{FF2B5EF4-FFF2-40B4-BE49-F238E27FC236}">
-                <a16:creationId xmlns:a16="http://schemas.microsoft.com/office/drawing/2014/main" id="{11B354B3-838A-44DF-A14B-E408768DA7A6}"/>
+                <a16:creationId xmlns:a16="http://schemas.microsoft.com/office/drawing/2014/main" id="{AFD9CF5A-B5A0-477C-9F51-FC80D188A322}"/>
               </a:ext>
             </a:extLst>
           </p:cNvPr>
@@ -21999,7 +22343,7 @@
     </p:spTree>
     <p:extLst>
       <p:ext uri="{BB962C8B-B14F-4D97-AF65-F5344CB8AC3E}">
-        <p14:creationId xmlns:p14="http://schemas.microsoft.com/office/powerpoint/2010/main" val="649623959"/>
+        <p14:creationId xmlns:p14="http://schemas.microsoft.com/office/powerpoint/2010/main" val="3979251"/>
       </p:ext>
     </p:extLst>
   </p:cSld>
@@ -22030,7 +22374,7 @@
           <p:cNvPr id="14" name="">
             <a:extLst xmlns:a="http://schemas.openxmlformats.org/drawingml/2006/main">
               <a:ext uri="{FF2B5EF4-FFF2-40B4-BE49-F238E27FC236}">
-                <a16:creationId xmlns:a16="http://schemas.microsoft.com/office/drawing/2014/main" id="{1F6442DF-7B24-4694-8CFF-7C6021D8329C}"/>
+                <a16:creationId xmlns:a16="http://schemas.microsoft.com/office/drawing/2014/main" id="{8016DCDB-F6DF-499D-9B25-0B61B369C177}"/>
               </a:ext>
             </a:extLst>
           </p:cNvPr>
@@ -22188,7 +22532,7 @@
           <p:cNvPr id="2" name="">
             <a:extLst xmlns:a="http://schemas.openxmlformats.org/drawingml/2006/main">
               <a:ext uri="{FF2B5EF4-FFF2-40B4-BE49-F238E27FC236}">
-                <a16:creationId xmlns:a16="http://schemas.microsoft.com/office/drawing/2014/main" id="{D8712F61-E1A9-481F-B161-93C79391FFEF}"/>
+                <a16:creationId xmlns:a16="http://schemas.microsoft.com/office/drawing/2014/main" id="{627B8000-72C3-4707-9D8F-F16C3A9F6211}"/>
               </a:ext>
             </a:extLst>
           </p:cNvPr>
@@ -22346,7 +22690,7 @@
           <p:cNvPr id="3" name="">
             <a:extLst xmlns:a="http://schemas.openxmlformats.org/drawingml/2006/main">
               <a:ext uri="{FF2B5EF4-FFF2-40B4-BE49-F238E27FC236}">
-                <a16:creationId xmlns:a16="http://schemas.microsoft.com/office/drawing/2014/main" id="{7619BC1C-39AF-458A-A913-441F73431D1D}"/>
+                <a16:creationId xmlns:a16="http://schemas.microsoft.com/office/drawing/2014/main" id="{0682EE01-C43A-460D-A337-93C066D2BDE1}"/>
               </a:ext>
             </a:extLst>
           </p:cNvPr>
@@ -22504,7 +22848,7 @@
           <p:cNvPr id="4" name="">
             <a:extLst xmlns:a="http://schemas.openxmlformats.org/drawingml/2006/main">
               <a:ext uri="{FF2B5EF4-FFF2-40B4-BE49-F238E27FC236}">
-                <a16:creationId xmlns:a16="http://schemas.microsoft.com/office/drawing/2014/main" id="{60B2A061-558C-469C-9618-1A2356654F5A}"/>
+                <a16:creationId xmlns:a16="http://schemas.microsoft.com/office/drawing/2014/main" id="{5275C64B-F553-494F-AFAE-75B19DE654A1}"/>
               </a:ext>
             </a:extLst>
           </p:cNvPr>
@@ -22514,7 +22858,7 @@
           <p:nvPr/>
         </p:nvPicPr>
         <p:blipFill>
-          <a:blip xmlns:r="http://schemas.openxmlformats.org/officeDocument/2006/relationships" xmlns:a="http://schemas.openxmlformats.org/drawingml/2006/main" r:embed="Re9979cd09bd841a1"/>
+          <a:blip xmlns:r="http://schemas.openxmlformats.org/officeDocument/2006/relationships" xmlns:a="http://schemas.openxmlformats.org/drawingml/2006/main" r:embed="Rfc082bd455cb4995"/>
           <a:stretch xmlns:a="http://schemas.openxmlformats.org/drawingml/2006/main"/>
         </p:blipFill>
         <p:spPr>
@@ -22532,7 +22876,7 @@
           <p:cNvPr id="5" name="">
             <a:extLst xmlns:a="http://schemas.openxmlformats.org/drawingml/2006/main">
               <a:ext uri="{FF2B5EF4-FFF2-40B4-BE49-F238E27FC236}">
-                <a16:creationId xmlns:a16="http://schemas.microsoft.com/office/drawing/2014/main" id="{70FEBEA2-DD5A-4A8F-8FDB-F4350AEE64A7}"/>
+                <a16:creationId xmlns:a16="http://schemas.microsoft.com/office/drawing/2014/main" id="{A4A01892-A952-435E-966C-FCAFFC53358D}"/>
               </a:ext>
             </a:extLst>
           </p:cNvPr>
@@ -22690,7 +23034,7 @@
           <p:cNvPr id="6" name="">
             <a:extLst xmlns:a="http://schemas.openxmlformats.org/drawingml/2006/main">
               <a:ext uri="{FF2B5EF4-FFF2-40B4-BE49-F238E27FC236}">
-                <a16:creationId xmlns:a16="http://schemas.microsoft.com/office/drawing/2014/main" id="{519BCEB2-4829-4A90-AFDC-E5111719D77B}"/>
+                <a16:creationId xmlns:a16="http://schemas.microsoft.com/office/drawing/2014/main" id="{2F2349A6-C52F-4204-A2EF-9CF65FE0A241}"/>
               </a:ext>
             </a:extLst>
           </p:cNvPr>
@@ -22848,7 +23192,7 @@
           <p:cNvPr id="7" name="">
             <a:extLst xmlns:a="http://schemas.openxmlformats.org/drawingml/2006/main">
               <a:ext uri="{FF2B5EF4-FFF2-40B4-BE49-F238E27FC236}">
-                <a16:creationId xmlns:a16="http://schemas.microsoft.com/office/drawing/2014/main" id="{1F05A6E0-C1A5-4E12-B95A-55D15F6580E7}"/>
+                <a16:creationId xmlns:a16="http://schemas.microsoft.com/office/drawing/2014/main" id="{F045B895-2624-4517-A205-1D5D9E224DAF}"/>
               </a:ext>
             </a:extLst>
           </p:cNvPr>
@@ -22858,7 +23202,7 @@
           <p:nvPr/>
         </p:nvPicPr>
         <p:blipFill>
-          <a:blip xmlns:r="http://schemas.openxmlformats.org/officeDocument/2006/relationships" xmlns:a="http://schemas.openxmlformats.org/drawingml/2006/main" r:embed="Rc78de3a64e584f27"/>
+          <a:blip xmlns:r="http://schemas.openxmlformats.org/officeDocument/2006/relationships" xmlns:a="http://schemas.openxmlformats.org/drawingml/2006/main" r:embed="Re77712f8e9af4480"/>
           <a:stretch xmlns:a="http://schemas.openxmlformats.org/drawingml/2006/main"/>
         </p:blipFill>
         <p:spPr>
@@ -22876,7 +23220,7 @@
           <p:cNvPr id="8" name="">
             <a:extLst xmlns:a="http://schemas.openxmlformats.org/drawingml/2006/main">
               <a:ext uri="{FF2B5EF4-FFF2-40B4-BE49-F238E27FC236}">
-                <a16:creationId xmlns:a16="http://schemas.microsoft.com/office/drawing/2014/main" id="{4E450226-414D-493E-A375-735E7B97B568}"/>
+                <a16:creationId xmlns:a16="http://schemas.microsoft.com/office/drawing/2014/main" id="{FDDD8B89-E41A-4B45-BFA5-290206D79C71}"/>
               </a:ext>
             </a:extLst>
           </p:cNvPr>
@@ -23034,7 +23378,7 @@
           <p:cNvPr id="9" name="">
             <a:extLst xmlns:a="http://schemas.openxmlformats.org/drawingml/2006/main">
               <a:ext uri="{FF2B5EF4-FFF2-40B4-BE49-F238E27FC236}">
-                <a16:creationId xmlns:a16="http://schemas.microsoft.com/office/drawing/2014/main" id="{E4278C0E-BCCD-4CA5-A7F8-1D45B58D584D}"/>
+                <a16:creationId xmlns:a16="http://schemas.microsoft.com/office/drawing/2014/main" id="{756340B0-2305-4EBA-96D9-E558732E9D8F}"/>
               </a:ext>
             </a:extLst>
           </p:cNvPr>
@@ -23192,7 +23536,7 @@
           <p:cNvPr id="10" name="">
             <a:extLst xmlns:a="http://schemas.openxmlformats.org/drawingml/2006/main">
               <a:ext uri="{FF2B5EF4-FFF2-40B4-BE49-F238E27FC236}">
-                <a16:creationId xmlns:a16="http://schemas.microsoft.com/office/drawing/2014/main" id="{CFFA0ACC-944E-4D36-BB21-0D28B35DC9C6}"/>
+                <a16:creationId xmlns:a16="http://schemas.microsoft.com/office/drawing/2014/main" id="{122E2E31-D16E-4745-A22B-E70273D56285}"/>
               </a:ext>
             </a:extLst>
           </p:cNvPr>
@@ -23373,7 +23717,7 @@
           <p:cNvPr id="11" name="">
             <a:extLst xmlns:a="http://schemas.openxmlformats.org/drawingml/2006/main">
               <a:ext uri="{FF2B5EF4-FFF2-40B4-BE49-F238E27FC236}">
-                <a16:creationId xmlns:a16="http://schemas.microsoft.com/office/drawing/2014/main" id="{C8BD3872-9D62-46C8-8E98-69D220225A1A}"/>
+                <a16:creationId xmlns:a16="http://schemas.microsoft.com/office/drawing/2014/main" id="{2643D501-9297-4153-8E69-5F7F45EF6949}"/>
               </a:ext>
             </a:extLst>
           </p:cNvPr>
@@ -23531,7 +23875,7 @@
           <p:cNvPr id="12" name="">
             <a:extLst xmlns:a="http://schemas.openxmlformats.org/drawingml/2006/main">
               <a:ext uri="{FF2B5EF4-FFF2-40B4-BE49-F238E27FC236}">
-                <a16:creationId xmlns:a16="http://schemas.microsoft.com/office/drawing/2014/main" id="{55978CFD-F508-406F-ADD5-E62B2BF9B8DF}"/>
+                <a16:creationId xmlns:a16="http://schemas.microsoft.com/office/drawing/2014/main" id="{384D16CD-ADE2-4B31-90C7-D5988204FBDF}"/>
               </a:ext>
             </a:extLst>
           </p:cNvPr>
@@ -23735,7 +24079,7 @@
           <p:cNvPr id="13" name="">
             <a:extLst xmlns:a="http://schemas.openxmlformats.org/drawingml/2006/main">
               <a:ext uri="{FF2B5EF4-FFF2-40B4-BE49-F238E27FC236}">
-                <a16:creationId xmlns:a16="http://schemas.microsoft.com/office/drawing/2014/main" id="{B6B10216-0424-4F72-B96A-ADB8A8FDF8A7}"/>
+                <a16:creationId xmlns:a16="http://schemas.microsoft.com/office/drawing/2014/main" id="{1F5998EE-857C-44C7-8A20-25B35A3E0721}"/>
               </a:ext>
             </a:extLst>
           </p:cNvPr>
@@ -23891,7 +24235,7 @@
     </p:spTree>
     <p:extLst>
       <p:ext uri="{BB962C8B-B14F-4D97-AF65-F5344CB8AC3E}">
-        <p14:creationId xmlns:p14="http://schemas.microsoft.com/office/powerpoint/2010/main" val="748277984"/>
+        <p14:creationId xmlns:p14="http://schemas.microsoft.com/office/powerpoint/2010/main" val="1163149145"/>
       </p:ext>
     </p:extLst>
   </p:cSld>
@@ -23922,7 +24266,7 @@
           <p:cNvPr id="13" name="">
             <a:extLst xmlns:a="http://schemas.openxmlformats.org/drawingml/2006/main">
               <a:ext uri="{FF2B5EF4-FFF2-40B4-BE49-F238E27FC236}">
-                <a16:creationId xmlns:a16="http://schemas.microsoft.com/office/drawing/2014/main" id="{E45FE8C6-4776-4A3D-A9B9-3C60D51E87BA}"/>
+                <a16:creationId xmlns:a16="http://schemas.microsoft.com/office/drawing/2014/main" id="{B2CDC65F-7ACA-4011-9F05-290ACD8C902D}"/>
               </a:ext>
             </a:extLst>
           </p:cNvPr>
@@ -24080,7 +24424,7 @@
           <p:cNvPr id="2" name="">
             <a:extLst xmlns:a="http://schemas.openxmlformats.org/drawingml/2006/main">
               <a:ext uri="{FF2B5EF4-FFF2-40B4-BE49-F238E27FC236}">
-                <a16:creationId xmlns:a16="http://schemas.microsoft.com/office/drawing/2014/main" id="{43EEE813-370A-4DBA-A7F4-3D2A9D7DF7C5}"/>
+                <a16:creationId xmlns:a16="http://schemas.microsoft.com/office/drawing/2014/main" id="{CF8D86F5-3B84-4DA0-BB87-0599F2A35383}"/>
               </a:ext>
             </a:extLst>
           </p:cNvPr>
@@ -24238,7 +24582,7 @@
           <p:cNvPr id="3" name="">
             <a:extLst xmlns:a="http://schemas.openxmlformats.org/drawingml/2006/main">
               <a:ext uri="{FF2B5EF4-FFF2-40B4-BE49-F238E27FC236}">
-                <a16:creationId xmlns:a16="http://schemas.microsoft.com/office/drawing/2014/main" id="{EC9B60DF-FF55-40CA-AB1A-AF52A4919E29}"/>
+                <a16:creationId xmlns:a16="http://schemas.microsoft.com/office/drawing/2014/main" id="{E3F6C1D0-DAC5-456A-84D3-A8F2DB323228}"/>
               </a:ext>
             </a:extLst>
           </p:cNvPr>
@@ -24396,7 +24740,7 @@
           <p:cNvPr id="4" name="">
             <a:extLst xmlns:a="http://schemas.openxmlformats.org/drawingml/2006/main">
               <a:ext uri="{FF2B5EF4-FFF2-40B4-BE49-F238E27FC236}">
-                <a16:creationId xmlns:a16="http://schemas.microsoft.com/office/drawing/2014/main" id="{D64AEA10-2E22-40AF-83F6-12146699736A}"/>
+                <a16:creationId xmlns:a16="http://schemas.microsoft.com/office/drawing/2014/main" id="{88241A2B-A0AB-485D-B5FA-24A403E4F741}"/>
               </a:ext>
             </a:extLst>
           </p:cNvPr>
@@ -24406,7 +24750,7 @@
           <p:nvPr/>
         </p:nvPicPr>
         <p:blipFill>
-          <a:blip xmlns:r="http://schemas.openxmlformats.org/officeDocument/2006/relationships" xmlns:a="http://schemas.openxmlformats.org/drawingml/2006/main" r:embed="R29e9b21fe57747e1"/>
+          <a:blip xmlns:r="http://schemas.openxmlformats.org/officeDocument/2006/relationships" xmlns:a="http://schemas.openxmlformats.org/drawingml/2006/main" r:embed="R3551ed630aa94564"/>
           <a:stretch xmlns:a="http://schemas.openxmlformats.org/drawingml/2006/main"/>
         </p:blipFill>
         <p:spPr>
@@ -24424,7 +24768,7 @@
           <p:cNvPr id="5" name="">
             <a:extLst xmlns:a="http://schemas.openxmlformats.org/drawingml/2006/main">
               <a:ext uri="{FF2B5EF4-FFF2-40B4-BE49-F238E27FC236}">
-                <a16:creationId xmlns:a16="http://schemas.microsoft.com/office/drawing/2014/main" id="{DBC2A461-22A6-4338-BCBD-08AB36C46940}"/>
+                <a16:creationId xmlns:a16="http://schemas.microsoft.com/office/drawing/2014/main" id="{EEB54A54-ED0D-4D8B-BEDB-4EA9D123471A}"/>
               </a:ext>
             </a:extLst>
           </p:cNvPr>
@@ -24582,7 +24926,7 @@
           <p:cNvPr id="6" name="">
             <a:extLst xmlns:a="http://schemas.openxmlformats.org/drawingml/2006/main">
               <a:ext uri="{FF2B5EF4-FFF2-40B4-BE49-F238E27FC236}">
-                <a16:creationId xmlns:a16="http://schemas.microsoft.com/office/drawing/2014/main" id="{4992A790-BB2D-4C72-86AF-36BA7F52FF97}"/>
+                <a16:creationId xmlns:a16="http://schemas.microsoft.com/office/drawing/2014/main" id="{333209B9-1C8F-455F-A85C-F086740A5410}"/>
               </a:ext>
             </a:extLst>
           </p:cNvPr>
@@ -24740,7 +25084,7 @@
           <p:cNvPr id="7" name="">
             <a:extLst xmlns:a="http://schemas.openxmlformats.org/drawingml/2006/main">
               <a:ext uri="{FF2B5EF4-FFF2-40B4-BE49-F238E27FC236}">
-                <a16:creationId xmlns:a16="http://schemas.microsoft.com/office/drawing/2014/main" id="{6D71BD7C-FB59-40D4-AF2D-91DF5ED8E8E6}"/>
+                <a16:creationId xmlns:a16="http://schemas.microsoft.com/office/drawing/2014/main" id="{56092E0C-0C20-4075-BFE9-C3D96D9E8F4E}"/>
               </a:ext>
             </a:extLst>
           </p:cNvPr>
@@ -24750,7 +25094,7 @@
           <p:nvPr/>
         </p:nvPicPr>
         <p:blipFill>
-          <a:blip xmlns:r="http://schemas.openxmlformats.org/officeDocument/2006/relationships" xmlns:a="http://schemas.openxmlformats.org/drawingml/2006/main" r:embed="R2fa2aa3cbe8f4080"/>
+          <a:blip xmlns:r="http://schemas.openxmlformats.org/officeDocument/2006/relationships" xmlns:a="http://schemas.openxmlformats.org/drawingml/2006/main" r:embed="R7d91dd60087a4e57"/>
           <a:stretch xmlns:a="http://schemas.openxmlformats.org/drawingml/2006/main"/>
         </p:blipFill>
         <p:spPr>
@@ -24768,7 +25112,7 @@
           <p:cNvPr id="8" name="">
             <a:extLst xmlns:a="http://schemas.openxmlformats.org/drawingml/2006/main">
               <a:ext uri="{FF2B5EF4-FFF2-40B4-BE49-F238E27FC236}">
-                <a16:creationId xmlns:a16="http://schemas.microsoft.com/office/drawing/2014/main" id="{4E5D3A4B-B4BB-490E-A4F1-614173A542FB}"/>
+                <a16:creationId xmlns:a16="http://schemas.microsoft.com/office/drawing/2014/main" id="{4F5CE6DA-625A-4CD3-BC81-11DEB4815745}"/>
               </a:ext>
             </a:extLst>
           </p:cNvPr>
@@ -24926,7 +25270,7 @@
           <p:cNvPr id="9" name="">
             <a:extLst xmlns:a="http://schemas.openxmlformats.org/drawingml/2006/main">
               <a:ext uri="{FF2B5EF4-FFF2-40B4-BE49-F238E27FC236}">
-                <a16:creationId xmlns:a16="http://schemas.microsoft.com/office/drawing/2014/main" id="{7F52FA5B-FDDD-4A2D-95C5-B862E1126436}"/>
+                <a16:creationId xmlns:a16="http://schemas.microsoft.com/office/drawing/2014/main" id="{BB0A75F7-FC98-4703-8357-CBB0EFB15F40}"/>
               </a:ext>
             </a:extLst>
           </p:cNvPr>
@@ -25084,7 +25428,7 @@
           <p:cNvPr id="10" name="">
             <a:extLst xmlns:a="http://schemas.openxmlformats.org/drawingml/2006/main">
               <a:ext uri="{FF2B5EF4-FFF2-40B4-BE49-F238E27FC236}">
-                <a16:creationId xmlns:a16="http://schemas.microsoft.com/office/drawing/2014/main" id="{4B2E0AC8-1B2C-47E6-B37F-DE5AE7CCAD13}"/>
+                <a16:creationId xmlns:a16="http://schemas.microsoft.com/office/drawing/2014/main" id="{826AF48F-4096-458A-B221-BF9B5CF7EFDF}"/>
               </a:ext>
             </a:extLst>
           </p:cNvPr>
@@ -25270,7 +25614,7 @@
           <p:cNvPr id="11" name="">
             <a:extLst xmlns:a="http://schemas.openxmlformats.org/drawingml/2006/main">
               <a:ext uri="{FF2B5EF4-FFF2-40B4-BE49-F238E27FC236}">
-                <a16:creationId xmlns:a16="http://schemas.microsoft.com/office/drawing/2014/main" id="{BB90F6F7-4922-4E49-B904-843F52220C9A}"/>
+                <a16:creationId xmlns:a16="http://schemas.microsoft.com/office/drawing/2014/main" id="{EEC0C84D-2EE5-42A4-BF77-C9410ED56379}"/>
               </a:ext>
             </a:extLst>
           </p:cNvPr>
@@ -25428,7 +25772,7 @@
           <p:cNvPr id="12" name="">
             <a:extLst xmlns:a="http://schemas.openxmlformats.org/drawingml/2006/main">
               <a:ext uri="{FF2B5EF4-FFF2-40B4-BE49-F238E27FC236}">
-                <a16:creationId xmlns:a16="http://schemas.microsoft.com/office/drawing/2014/main" id="{713B176D-132F-42CB-B093-861DF62BBBBD}"/>
+                <a16:creationId xmlns:a16="http://schemas.microsoft.com/office/drawing/2014/main" id="{095D4AE2-A946-41DB-AFA0-42659756AFEC}"/>
               </a:ext>
             </a:extLst>
           </p:cNvPr>
@@ -25584,7 +25928,7 @@
     </p:spTree>
     <p:extLst>
       <p:ext uri="{BB962C8B-B14F-4D97-AF65-F5344CB8AC3E}">
-        <p14:creationId xmlns:p14="http://schemas.microsoft.com/office/powerpoint/2010/main" val="1226709893"/>
+        <p14:creationId xmlns:p14="http://schemas.microsoft.com/office/powerpoint/2010/main" val="40241806"/>
       </p:ext>
     </p:extLst>
   </p:cSld>
@@ -25615,7 +25959,7 @@
           <p:cNvPr id="11" name="">
             <a:extLst xmlns:a="http://schemas.openxmlformats.org/drawingml/2006/main">
               <a:ext uri="{FF2B5EF4-FFF2-40B4-BE49-F238E27FC236}">
-                <a16:creationId xmlns:a16="http://schemas.microsoft.com/office/drawing/2014/main" id="{0712E668-1881-4AD6-9FAE-4712DA8305F5}"/>
+                <a16:creationId xmlns:a16="http://schemas.microsoft.com/office/drawing/2014/main" id="{200BDF9F-68FB-4F0C-AEEE-D5F201A55411}"/>
               </a:ext>
             </a:extLst>
           </p:cNvPr>
@@ -25773,7 +26117,7 @@
           <p:cNvPr id="2" name="">
             <a:extLst xmlns:a="http://schemas.openxmlformats.org/drawingml/2006/main">
               <a:ext uri="{FF2B5EF4-FFF2-40B4-BE49-F238E27FC236}">
-                <a16:creationId xmlns:a16="http://schemas.microsoft.com/office/drawing/2014/main" id="{E2EEA86F-C50B-4D39-8CD0-0163E91B8E5F}"/>
+                <a16:creationId xmlns:a16="http://schemas.microsoft.com/office/drawing/2014/main" id="{7C5E5922-CDCF-4AC6-83A6-6ADE24A56CC4}"/>
               </a:ext>
             </a:extLst>
           </p:cNvPr>
@@ -25931,7 +26275,7 @@
           <p:cNvPr id="3" name="">
             <a:extLst xmlns:a="http://schemas.openxmlformats.org/drawingml/2006/main">
               <a:ext uri="{FF2B5EF4-FFF2-40B4-BE49-F238E27FC236}">
-                <a16:creationId xmlns:a16="http://schemas.microsoft.com/office/drawing/2014/main" id="{4405FF4D-E000-4949-8F44-E8DAB4BD9202}"/>
+                <a16:creationId xmlns:a16="http://schemas.microsoft.com/office/drawing/2014/main" id="{E531BDAF-63FA-474F-AB3F-DC8F9BB630DF}"/>
               </a:ext>
             </a:extLst>
           </p:cNvPr>
@@ -26089,7 +26433,7 @@
           <p:cNvPr id="4" name="">
             <a:extLst xmlns:a="http://schemas.openxmlformats.org/drawingml/2006/main">
               <a:ext uri="{FF2B5EF4-FFF2-40B4-BE49-F238E27FC236}">
-                <a16:creationId xmlns:a16="http://schemas.microsoft.com/office/drawing/2014/main" id="{259C0BD1-1D8E-471E-B83B-70694DB365D0}"/>
+                <a16:creationId xmlns:a16="http://schemas.microsoft.com/office/drawing/2014/main" id="{ECBA563F-498A-4E03-A00B-60ED403EEFCC}"/>
               </a:ext>
             </a:extLst>
           </p:cNvPr>
@@ -26247,7 +26591,7 @@
           <p:cNvPr id="5" name="">
             <a:extLst xmlns:a="http://schemas.openxmlformats.org/drawingml/2006/main">
               <a:ext uri="{FF2B5EF4-FFF2-40B4-BE49-F238E27FC236}">
-                <a16:creationId xmlns:a16="http://schemas.microsoft.com/office/drawing/2014/main" id="{6FD7A884-801C-43B8-97E2-BC55DC964DF2}"/>
+                <a16:creationId xmlns:a16="http://schemas.microsoft.com/office/drawing/2014/main" id="{3A301333-CDD6-4F07-A7E9-778BB2BEC701}"/>
               </a:ext>
             </a:extLst>
           </p:cNvPr>
@@ -26405,7 +26749,7 @@
           <p:cNvPr id="6" name="">
             <a:extLst xmlns:a="http://schemas.openxmlformats.org/drawingml/2006/main">
               <a:ext uri="{FF2B5EF4-FFF2-40B4-BE49-F238E27FC236}">
-                <a16:creationId xmlns:a16="http://schemas.microsoft.com/office/drawing/2014/main" id="{529DFDFC-DAEA-431D-B27A-6ABFAF471622}"/>
+                <a16:creationId xmlns:a16="http://schemas.microsoft.com/office/drawing/2014/main" id="{37B5F8FD-0F11-4902-9A2D-C8FAEAF492DD}"/>
               </a:ext>
             </a:extLst>
           </p:cNvPr>
@@ -26563,7 +26907,7 @@
           <p:cNvPr id="7" name="">
             <a:extLst xmlns:a="http://schemas.openxmlformats.org/drawingml/2006/main">
               <a:ext uri="{FF2B5EF4-FFF2-40B4-BE49-F238E27FC236}">
-                <a16:creationId xmlns:a16="http://schemas.microsoft.com/office/drawing/2014/main" id="{5364BB4D-9D21-4686-B102-7D6541C0646A}"/>
+                <a16:creationId xmlns:a16="http://schemas.microsoft.com/office/drawing/2014/main" id="{8071B7A1-491F-40CD-9F68-C46A0D47D0DC}"/>
               </a:ext>
             </a:extLst>
           </p:cNvPr>
@@ -26721,7 +27065,7 @@
           <p:cNvPr id="8" name="">
             <a:extLst xmlns:a="http://schemas.openxmlformats.org/drawingml/2006/main">
               <a:ext uri="{FF2B5EF4-FFF2-40B4-BE49-F238E27FC236}">
-                <a16:creationId xmlns:a16="http://schemas.microsoft.com/office/drawing/2014/main" id="{BB6BEB04-C087-4BBE-9462-C2BF07C2D59B}"/>
+                <a16:creationId xmlns:a16="http://schemas.microsoft.com/office/drawing/2014/main" id="{656AF0AF-3C49-4315-AE7E-4511CEEE704A}"/>
               </a:ext>
             </a:extLst>
           </p:cNvPr>
@@ -26879,7 +27223,7 @@
           <p:cNvPr id="9" name="">
             <a:extLst xmlns:a="http://schemas.openxmlformats.org/drawingml/2006/main">
               <a:ext uri="{FF2B5EF4-FFF2-40B4-BE49-F238E27FC236}">
-                <a16:creationId xmlns:a16="http://schemas.microsoft.com/office/drawing/2014/main" id="{98DAE4D9-3ADD-40C3-BB3D-20DEB24F4E0B}"/>
+                <a16:creationId xmlns:a16="http://schemas.microsoft.com/office/drawing/2014/main" id="{9A66D640-3C3F-4B0B-9003-AB593FD670DE}"/>
               </a:ext>
             </a:extLst>
           </p:cNvPr>
@@ -27065,7 +27409,7 @@
           <p:cNvPr id="10" name="">
             <a:extLst xmlns:a="http://schemas.openxmlformats.org/drawingml/2006/main">
               <a:ext uri="{FF2B5EF4-FFF2-40B4-BE49-F238E27FC236}">
-                <a16:creationId xmlns:a16="http://schemas.microsoft.com/office/drawing/2014/main" id="{7C9A3CB1-1C43-4080-9E16-B580949C1443}"/>
+                <a16:creationId xmlns:a16="http://schemas.microsoft.com/office/drawing/2014/main" id="{332F2F52-0D0F-47A6-8A66-ADE1624BB864}"/>
               </a:ext>
             </a:extLst>
           </p:cNvPr>
@@ -27221,7 +27565,7 @@
     </p:spTree>
     <p:extLst>
       <p:ext uri="{BB962C8B-B14F-4D97-AF65-F5344CB8AC3E}">
-        <p14:creationId xmlns:p14="http://schemas.microsoft.com/office/powerpoint/2010/main" val="1949204258"/>
+        <p14:creationId xmlns:p14="http://schemas.microsoft.com/office/powerpoint/2010/main" val="1633491276"/>
       </p:ext>
     </p:extLst>
   </p:cSld>
@@ -27252,7 +27596,7 @@
           <p:cNvPr id="13" name="">
             <a:extLst xmlns:a="http://schemas.openxmlformats.org/drawingml/2006/main">
               <a:ext uri="{FF2B5EF4-FFF2-40B4-BE49-F238E27FC236}">
-                <a16:creationId xmlns:a16="http://schemas.microsoft.com/office/drawing/2014/main" id="{59980C8C-787E-4FD0-A6E4-E908F3845126}"/>
+                <a16:creationId xmlns:a16="http://schemas.microsoft.com/office/drawing/2014/main" id="{89BEDC3D-2177-42A2-AB75-CB5E08DED673}"/>
               </a:ext>
             </a:extLst>
           </p:cNvPr>
@@ -27410,7 +27754,7 @@
           <p:cNvPr id="2" name="">
             <a:extLst xmlns:a="http://schemas.openxmlformats.org/drawingml/2006/main">
               <a:ext uri="{FF2B5EF4-FFF2-40B4-BE49-F238E27FC236}">
-                <a16:creationId xmlns:a16="http://schemas.microsoft.com/office/drawing/2014/main" id="{5040CA98-43D0-4CCC-9E75-233D58940EBF}"/>
+                <a16:creationId xmlns:a16="http://schemas.microsoft.com/office/drawing/2014/main" id="{F75A3537-8FDF-44F6-9858-C4B15EF8386A}"/>
               </a:ext>
             </a:extLst>
           </p:cNvPr>
@@ -27568,7 +27912,7 @@
           <p:cNvPr id="3" name="">
             <a:extLst xmlns:a="http://schemas.openxmlformats.org/drawingml/2006/main">
               <a:ext uri="{FF2B5EF4-FFF2-40B4-BE49-F238E27FC236}">
-                <a16:creationId xmlns:a16="http://schemas.microsoft.com/office/drawing/2014/main" id="{82751409-214F-450F-9F4E-FFEAC026B136}"/>
+                <a16:creationId xmlns:a16="http://schemas.microsoft.com/office/drawing/2014/main" id="{2FBF5D04-70D2-44BE-A1D1-136107975AFE}"/>
               </a:ext>
             </a:extLst>
           </p:cNvPr>
@@ -27726,7 +28070,7 @@
           <p:cNvPr id="4" name="">
             <a:extLst xmlns:a="http://schemas.openxmlformats.org/drawingml/2006/main">
               <a:ext uri="{FF2B5EF4-FFF2-40B4-BE49-F238E27FC236}">
-                <a16:creationId xmlns:a16="http://schemas.microsoft.com/office/drawing/2014/main" id="{90947A29-208B-4843-ADDD-CD42F4D26BEA}"/>
+                <a16:creationId xmlns:a16="http://schemas.microsoft.com/office/drawing/2014/main" id="{24493716-6F05-4ADD-A305-DFA7DE10B968}"/>
               </a:ext>
             </a:extLst>
           </p:cNvPr>
@@ -27736,7 +28080,7 @@
           <p:nvPr/>
         </p:nvPicPr>
         <p:blipFill>
-          <a:blip xmlns:r="http://schemas.openxmlformats.org/officeDocument/2006/relationships" xmlns:a="http://schemas.openxmlformats.org/drawingml/2006/main" r:embed="R7f09050fd892484e"/>
+          <a:blip xmlns:r="http://schemas.openxmlformats.org/officeDocument/2006/relationships" xmlns:a="http://schemas.openxmlformats.org/drawingml/2006/main" r:embed="Rea3c801441e9433a"/>
           <a:stretch xmlns:a="http://schemas.openxmlformats.org/drawingml/2006/main"/>
         </p:blipFill>
         <p:spPr>
@@ -27754,7 +28098,7 @@
           <p:cNvPr id="5" name="">
             <a:extLst xmlns:a="http://schemas.openxmlformats.org/drawingml/2006/main">
               <a:ext uri="{FF2B5EF4-FFF2-40B4-BE49-F238E27FC236}">
-                <a16:creationId xmlns:a16="http://schemas.microsoft.com/office/drawing/2014/main" id="{9CF0CA58-4D59-4F8A-ACFA-ED114A0DC258}"/>
+                <a16:creationId xmlns:a16="http://schemas.microsoft.com/office/drawing/2014/main" id="{418CDF5D-F619-49BF-ACAA-256CDD0CDABB}"/>
               </a:ext>
             </a:extLst>
           </p:cNvPr>
@@ -27912,7 +28256,7 @@
           <p:cNvPr id="6" name="">
             <a:extLst xmlns:a="http://schemas.openxmlformats.org/drawingml/2006/main">
               <a:ext uri="{FF2B5EF4-FFF2-40B4-BE49-F238E27FC236}">
-                <a16:creationId xmlns:a16="http://schemas.microsoft.com/office/drawing/2014/main" id="{077DF06E-99F6-4310-9265-9AE8C2EA3576}"/>
+                <a16:creationId xmlns:a16="http://schemas.microsoft.com/office/drawing/2014/main" id="{317B665C-F4F3-46C7-8C1A-7D6920C97D7A}"/>
               </a:ext>
             </a:extLst>
           </p:cNvPr>
@@ -28070,7 +28414,7 @@
           <p:cNvPr id="7" name="">
             <a:extLst xmlns:a="http://schemas.openxmlformats.org/drawingml/2006/main">
               <a:ext uri="{FF2B5EF4-FFF2-40B4-BE49-F238E27FC236}">
-                <a16:creationId xmlns:a16="http://schemas.microsoft.com/office/drawing/2014/main" id="{09321971-6227-4342-987D-F9D149EE0A75}"/>
+                <a16:creationId xmlns:a16="http://schemas.microsoft.com/office/drawing/2014/main" id="{C7728334-9611-4913-B970-3AEE4D269410}"/>
               </a:ext>
             </a:extLst>
           </p:cNvPr>
@@ -28080,7 +28424,7 @@
           <p:nvPr/>
         </p:nvPicPr>
         <p:blipFill>
-          <a:blip xmlns:r="http://schemas.openxmlformats.org/officeDocument/2006/relationships" xmlns:a="http://schemas.openxmlformats.org/drawingml/2006/main" r:embed="Raa32430b854f4451"/>
+          <a:blip xmlns:r="http://schemas.openxmlformats.org/officeDocument/2006/relationships" xmlns:a="http://schemas.openxmlformats.org/drawingml/2006/main" r:embed="R9658980daf314548"/>
           <a:stretch xmlns:a="http://schemas.openxmlformats.org/drawingml/2006/main"/>
         </p:blipFill>
         <p:spPr>
@@ -28098,7 +28442,7 @@
           <p:cNvPr id="8" name="">
             <a:extLst xmlns:a="http://schemas.openxmlformats.org/drawingml/2006/main">
               <a:ext uri="{FF2B5EF4-FFF2-40B4-BE49-F238E27FC236}">
-                <a16:creationId xmlns:a16="http://schemas.microsoft.com/office/drawing/2014/main" id="{31CE2F97-870E-4F09-B437-34B2DC09B198}"/>
+                <a16:creationId xmlns:a16="http://schemas.microsoft.com/office/drawing/2014/main" id="{3038C5D2-A879-4DA4-9FEB-D7E2EC6A9888}"/>
               </a:ext>
             </a:extLst>
           </p:cNvPr>
@@ -28256,7 +28600,7 @@
           <p:cNvPr id="9" name="">
             <a:extLst xmlns:a="http://schemas.openxmlformats.org/drawingml/2006/main">
               <a:ext uri="{FF2B5EF4-FFF2-40B4-BE49-F238E27FC236}">
-                <a16:creationId xmlns:a16="http://schemas.microsoft.com/office/drawing/2014/main" id="{130F5953-8A9C-4DE3-A703-0E09191FEAD7}"/>
+                <a16:creationId xmlns:a16="http://schemas.microsoft.com/office/drawing/2014/main" id="{399EDF1D-5611-4C00-A36A-43BAA5B751CA}"/>
               </a:ext>
             </a:extLst>
           </p:cNvPr>
@@ -28414,7 +28758,7 @@
           <p:cNvPr id="10" name="">
             <a:extLst xmlns:a="http://schemas.openxmlformats.org/drawingml/2006/main">
               <a:ext uri="{FF2B5EF4-FFF2-40B4-BE49-F238E27FC236}">
-                <a16:creationId xmlns:a16="http://schemas.microsoft.com/office/drawing/2014/main" id="{7622AB0B-6573-4145-8CC7-272E1B28ADF1}"/>
+                <a16:creationId xmlns:a16="http://schemas.microsoft.com/office/drawing/2014/main" id="{9239747B-30AC-491F-9580-9CD0F12EF3F8}"/>
               </a:ext>
             </a:extLst>
           </p:cNvPr>
@@ -28600,7 +28944,7 @@
           <p:cNvPr id="11" name="">
             <a:extLst xmlns:a="http://schemas.openxmlformats.org/drawingml/2006/main">
               <a:ext uri="{FF2B5EF4-FFF2-40B4-BE49-F238E27FC236}">
-                <a16:creationId xmlns:a16="http://schemas.microsoft.com/office/drawing/2014/main" id="{E0DAE5A5-10F5-4D3D-8427-E5CB685E0DEB}"/>
+                <a16:creationId xmlns:a16="http://schemas.microsoft.com/office/drawing/2014/main" id="{EC3CE22B-780D-460B-87B1-DD5FF0243A36}"/>
               </a:ext>
             </a:extLst>
           </p:cNvPr>
@@ -28758,7 +29102,7 @@
           <p:cNvPr id="12" name="">
             <a:extLst xmlns:a="http://schemas.openxmlformats.org/drawingml/2006/main">
               <a:ext uri="{FF2B5EF4-FFF2-40B4-BE49-F238E27FC236}">
-                <a16:creationId xmlns:a16="http://schemas.microsoft.com/office/drawing/2014/main" id="{8A070441-3EA9-4E9E-AC81-D73ED40796FF}"/>
+                <a16:creationId xmlns:a16="http://schemas.microsoft.com/office/drawing/2014/main" id="{903D6B3D-7339-493D-AA23-DCB242E0199F}"/>
               </a:ext>
             </a:extLst>
           </p:cNvPr>
@@ -28915,7 +29259,7 @@
     </p:spTree>
     <p:extLst>
       <p:ext uri="{BB962C8B-B14F-4D97-AF65-F5344CB8AC3E}">
-        <p14:creationId xmlns:p14="http://schemas.microsoft.com/office/powerpoint/2010/main" val="1665035451"/>
+        <p14:creationId xmlns:p14="http://schemas.microsoft.com/office/powerpoint/2010/main" val="1970757419"/>
       </p:ext>
     </p:extLst>
   </p:cSld>
@@ -28946,7 +29290,7 @@
           <p:cNvPr id="14" name="">
             <a:extLst xmlns:a="http://schemas.openxmlformats.org/drawingml/2006/main">
               <a:ext uri="{FF2B5EF4-FFF2-40B4-BE49-F238E27FC236}">
-                <a16:creationId xmlns:a16="http://schemas.microsoft.com/office/drawing/2014/main" id="{41E89FD6-C5AF-4553-8E50-D6C3A2F11017}"/>
+                <a16:creationId xmlns:a16="http://schemas.microsoft.com/office/drawing/2014/main" id="{AEFB64BE-6A61-4558-95BB-509486863BCF}"/>
               </a:ext>
             </a:extLst>
           </p:cNvPr>
@@ -29104,7 +29448,7 @@
           <p:cNvPr id="2" name="">
             <a:extLst xmlns:a="http://schemas.openxmlformats.org/drawingml/2006/main">
               <a:ext uri="{FF2B5EF4-FFF2-40B4-BE49-F238E27FC236}">
-                <a16:creationId xmlns:a16="http://schemas.microsoft.com/office/drawing/2014/main" id="{1A153A86-9523-41E5-9E21-27A82680B47A}"/>
+                <a16:creationId xmlns:a16="http://schemas.microsoft.com/office/drawing/2014/main" id="{ED06F4F1-E41A-4B3A-92E7-64F96964DB26}"/>
               </a:ext>
             </a:extLst>
           </p:cNvPr>
@@ -29262,7 +29606,7 @@
           <p:cNvPr id="3" name="">
             <a:extLst xmlns:a="http://schemas.openxmlformats.org/drawingml/2006/main">
               <a:ext uri="{FF2B5EF4-FFF2-40B4-BE49-F238E27FC236}">
-                <a16:creationId xmlns:a16="http://schemas.microsoft.com/office/drawing/2014/main" id="{C9B079DD-F237-4735-9D7A-7FF09B3EC939}"/>
+                <a16:creationId xmlns:a16="http://schemas.microsoft.com/office/drawing/2014/main" id="{46C4ABD3-9F79-4BD3-82ED-C7321FE9D575}"/>
               </a:ext>
             </a:extLst>
           </p:cNvPr>
@@ -29420,7 +29764,7 @@
           <p:cNvPr id="4" name="">
             <a:extLst xmlns:a="http://schemas.openxmlformats.org/drawingml/2006/main">
               <a:ext uri="{FF2B5EF4-FFF2-40B4-BE49-F238E27FC236}">
-                <a16:creationId xmlns:a16="http://schemas.microsoft.com/office/drawing/2014/main" id="{0896FA01-A88B-4881-8D6A-4D4C846BD61C}"/>
+                <a16:creationId xmlns:a16="http://schemas.microsoft.com/office/drawing/2014/main" id="{95D3FF6B-EF3B-4B75-B3F9-7F05366D23D1}"/>
               </a:ext>
             </a:extLst>
           </p:cNvPr>
@@ -29430,7 +29774,7 @@
           <p:nvPr/>
         </p:nvPicPr>
         <p:blipFill>
-          <a:blip xmlns:r="http://schemas.openxmlformats.org/officeDocument/2006/relationships" xmlns:a="http://schemas.openxmlformats.org/drawingml/2006/main" r:embed="Rf89f7ff5915843fd"/>
+          <a:blip xmlns:r="http://schemas.openxmlformats.org/officeDocument/2006/relationships" xmlns:a="http://schemas.openxmlformats.org/drawingml/2006/main" r:embed="Rf9030b1b56674c9f"/>
           <a:stretch xmlns:a="http://schemas.openxmlformats.org/drawingml/2006/main"/>
         </p:blipFill>
         <p:spPr>
@@ -29448,7 +29792,7 @@
           <p:cNvPr id="5" name="">
             <a:extLst xmlns:a="http://schemas.openxmlformats.org/drawingml/2006/main">
               <a:ext uri="{FF2B5EF4-FFF2-40B4-BE49-F238E27FC236}">
-                <a16:creationId xmlns:a16="http://schemas.microsoft.com/office/drawing/2014/main" id="{4232F6FE-2134-4952-A14D-68193A3B4BAF}"/>
+                <a16:creationId xmlns:a16="http://schemas.microsoft.com/office/drawing/2014/main" id="{B473D521-9F45-4720-A071-E706F5C1BD1A}"/>
               </a:ext>
             </a:extLst>
           </p:cNvPr>
@@ -29606,7 +29950,7 @@
           <p:cNvPr id="6" name="">
             <a:extLst xmlns:a="http://schemas.openxmlformats.org/drawingml/2006/main">
               <a:ext uri="{FF2B5EF4-FFF2-40B4-BE49-F238E27FC236}">
-                <a16:creationId xmlns:a16="http://schemas.microsoft.com/office/drawing/2014/main" id="{5D800F05-2684-4D70-A8AA-A9191BA315DA}"/>
+                <a16:creationId xmlns:a16="http://schemas.microsoft.com/office/drawing/2014/main" id="{F63C6A4D-3D32-4DA0-9174-06A8DC97AA9C}"/>
               </a:ext>
             </a:extLst>
           </p:cNvPr>
@@ -29764,7 +30108,7 @@
           <p:cNvPr id="7" name="">
             <a:extLst xmlns:a="http://schemas.openxmlformats.org/drawingml/2006/main">
               <a:ext uri="{FF2B5EF4-FFF2-40B4-BE49-F238E27FC236}">
-                <a16:creationId xmlns:a16="http://schemas.microsoft.com/office/drawing/2014/main" id="{507FFD8C-9C86-49CF-AD70-3B96A8549DF7}"/>
+                <a16:creationId xmlns:a16="http://schemas.microsoft.com/office/drawing/2014/main" id="{A709698E-C4AC-47CC-81AB-21AD8A950745}"/>
               </a:ext>
             </a:extLst>
           </p:cNvPr>
@@ -29774,7 +30118,7 @@
           <p:nvPr/>
         </p:nvPicPr>
         <p:blipFill>
-          <a:blip xmlns:r="http://schemas.openxmlformats.org/officeDocument/2006/relationships" xmlns:a="http://schemas.openxmlformats.org/drawingml/2006/main" r:embed="R9f1b1363295c417f"/>
+          <a:blip xmlns:r="http://schemas.openxmlformats.org/officeDocument/2006/relationships" xmlns:a="http://schemas.openxmlformats.org/drawingml/2006/main" r:embed="Rb00c50cb77fd4463"/>
           <a:stretch xmlns:a="http://schemas.openxmlformats.org/drawingml/2006/main"/>
         </p:blipFill>
         <p:spPr>
@@ -29792,7 +30136,7 @@
           <p:cNvPr id="8" name="">
             <a:extLst xmlns:a="http://schemas.openxmlformats.org/drawingml/2006/main">
               <a:ext uri="{FF2B5EF4-FFF2-40B4-BE49-F238E27FC236}">
-                <a16:creationId xmlns:a16="http://schemas.microsoft.com/office/drawing/2014/main" id="{B5265873-44CF-4175-9D7B-55A6B6CFD0B8}"/>
+                <a16:creationId xmlns:a16="http://schemas.microsoft.com/office/drawing/2014/main" id="{1F0788B4-2529-45C4-A809-0EF7A268B177}"/>
               </a:ext>
             </a:extLst>
           </p:cNvPr>
@@ -29950,7 +30294,7 @@
           <p:cNvPr id="9" name="">
             <a:extLst xmlns:a="http://schemas.openxmlformats.org/drawingml/2006/main">
               <a:ext uri="{FF2B5EF4-FFF2-40B4-BE49-F238E27FC236}">
-                <a16:creationId xmlns:a16="http://schemas.microsoft.com/office/drawing/2014/main" id="{C07588C7-DA0F-4361-950B-C7D495DC4106}"/>
+                <a16:creationId xmlns:a16="http://schemas.microsoft.com/office/drawing/2014/main" id="{2FB465CD-F3F6-4356-A385-DD1B6C615FC6}"/>
               </a:ext>
             </a:extLst>
           </p:cNvPr>
@@ -30108,7 +30452,7 @@
           <p:cNvPr id="10" name="">
             <a:extLst xmlns:a="http://schemas.openxmlformats.org/drawingml/2006/main">
               <a:ext uri="{FF2B5EF4-FFF2-40B4-BE49-F238E27FC236}">
-                <a16:creationId xmlns:a16="http://schemas.microsoft.com/office/drawing/2014/main" id="{A4AF8AB5-817F-47A4-BB1C-ED0C42DA9D47}"/>
+                <a16:creationId xmlns:a16="http://schemas.microsoft.com/office/drawing/2014/main" id="{D9C9330C-E800-42F2-A772-FC1401FB62BD}"/>
               </a:ext>
             </a:extLst>
           </p:cNvPr>
@@ -30266,7 +30610,7 @@
           <p:cNvPr id="11" name="">
             <a:extLst xmlns:a="http://schemas.openxmlformats.org/drawingml/2006/main">
               <a:ext uri="{FF2B5EF4-FFF2-40B4-BE49-F238E27FC236}">
-                <a16:creationId xmlns:a16="http://schemas.microsoft.com/office/drawing/2014/main" id="{64CF60BB-28A3-4C99-8FDC-690E3B0C9BDC}"/>
+                <a16:creationId xmlns:a16="http://schemas.microsoft.com/office/drawing/2014/main" id="{69C618A7-85EC-4A7C-90AD-D8E0CD1EFCA7}"/>
               </a:ext>
             </a:extLst>
           </p:cNvPr>
@@ -30424,7 +30768,7 @@
           <p:cNvPr id="12" name="">
             <a:extLst xmlns:a="http://schemas.openxmlformats.org/drawingml/2006/main">
               <a:ext uri="{FF2B5EF4-FFF2-40B4-BE49-F238E27FC236}">
-                <a16:creationId xmlns:a16="http://schemas.microsoft.com/office/drawing/2014/main" id="{6CA8D17C-876F-40E0-A492-09C3CA139676}"/>
+                <a16:creationId xmlns:a16="http://schemas.microsoft.com/office/drawing/2014/main" id="{4160B996-7951-4526-8794-C27DE3928706}"/>
               </a:ext>
             </a:extLst>
           </p:cNvPr>
@@ -30628,7 +30972,7 @@
           <p:cNvPr id="13" name="">
             <a:extLst xmlns:a="http://schemas.openxmlformats.org/drawingml/2006/main">
               <a:ext uri="{FF2B5EF4-FFF2-40B4-BE49-F238E27FC236}">
-                <a16:creationId xmlns:a16="http://schemas.microsoft.com/office/drawing/2014/main" id="{9E6EA92E-6D9E-408E-B552-EC2EA120072C}"/>
+                <a16:creationId xmlns:a16="http://schemas.microsoft.com/office/drawing/2014/main" id="{D87632F5-696F-4A54-9A66-F1CF91B6E8E2}"/>
               </a:ext>
             </a:extLst>
           </p:cNvPr>
@@ -30784,7 +31128,7 @@
     </p:spTree>
     <p:extLst>
       <p:ext uri="{BB962C8B-B14F-4D97-AF65-F5344CB8AC3E}">
-        <p14:creationId xmlns:p14="http://schemas.microsoft.com/office/powerpoint/2010/main" val="777709170"/>
+        <p14:creationId xmlns:p14="http://schemas.microsoft.com/office/powerpoint/2010/main" val="1611608039"/>
       </p:ext>
     </p:extLst>
   </p:cSld>
@@ -30815,7 +31159,7 @@
           <p:cNvPr id="13" name="">
             <a:extLst xmlns:a="http://schemas.openxmlformats.org/drawingml/2006/main">
               <a:ext uri="{FF2B5EF4-FFF2-40B4-BE49-F238E27FC236}">
-                <a16:creationId xmlns:a16="http://schemas.microsoft.com/office/drawing/2014/main" id="{4A89A4C7-46E4-43CD-9334-2B16701FB9AD}"/>
+                <a16:creationId xmlns:a16="http://schemas.microsoft.com/office/drawing/2014/main" id="{D98EDDC9-78FC-4A53-B7B6-698077B2E72D}"/>
               </a:ext>
             </a:extLst>
           </p:cNvPr>
@@ -30973,7 +31317,7 @@
           <p:cNvPr id="2" name="">
             <a:extLst xmlns:a="http://schemas.openxmlformats.org/drawingml/2006/main">
               <a:ext uri="{FF2B5EF4-FFF2-40B4-BE49-F238E27FC236}">
-                <a16:creationId xmlns:a16="http://schemas.microsoft.com/office/drawing/2014/main" id="{788A75B1-FFEE-4D01-B1E5-43D4F7210A6C}"/>
+                <a16:creationId xmlns:a16="http://schemas.microsoft.com/office/drawing/2014/main" id="{6C34E62B-DBB2-4CF2-B154-57CB6857B56A}"/>
               </a:ext>
             </a:extLst>
           </p:cNvPr>
@@ -31131,7 +31475,7 @@
           <p:cNvPr id="3" name="">
             <a:extLst xmlns:a="http://schemas.openxmlformats.org/drawingml/2006/main">
               <a:ext uri="{FF2B5EF4-FFF2-40B4-BE49-F238E27FC236}">
-                <a16:creationId xmlns:a16="http://schemas.microsoft.com/office/drawing/2014/main" id="{F449EBC8-505A-403E-A367-4D384867995E}"/>
+                <a16:creationId xmlns:a16="http://schemas.microsoft.com/office/drawing/2014/main" id="{4964B2F2-A93A-49B1-BCC6-0BFB58EDC222}"/>
               </a:ext>
             </a:extLst>
           </p:cNvPr>
@@ -31289,7 +31633,7 @@
           <p:cNvPr id="4" name="">
             <a:extLst xmlns:a="http://schemas.openxmlformats.org/drawingml/2006/main">
               <a:ext uri="{FF2B5EF4-FFF2-40B4-BE49-F238E27FC236}">
-                <a16:creationId xmlns:a16="http://schemas.microsoft.com/office/drawing/2014/main" id="{6A1DC4DD-3FED-49A0-B995-92FE402D1F8E}"/>
+                <a16:creationId xmlns:a16="http://schemas.microsoft.com/office/drawing/2014/main" id="{2E19B841-C9C3-4534-9BE4-53270C0B5F30}"/>
               </a:ext>
             </a:extLst>
           </p:cNvPr>
@@ -31299,7 +31643,7 @@
           <p:nvPr/>
         </p:nvPicPr>
         <p:blipFill>
-          <a:blip xmlns:r="http://schemas.openxmlformats.org/officeDocument/2006/relationships" xmlns:a="http://schemas.openxmlformats.org/drawingml/2006/main" r:embed="R0181269b5b0d4f77"/>
+          <a:blip xmlns:r="http://schemas.openxmlformats.org/officeDocument/2006/relationships" xmlns:a="http://schemas.openxmlformats.org/drawingml/2006/main" r:embed="R07fe27c83cbc4d99"/>
           <a:stretch xmlns:a="http://schemas.openxmlformats.org/drawingml/2006/main"/>
         </p:blipFill>
         <p:spPr>
@@ -31317,7 +31661,7 @@
           <p:cNvPr id="5" name="">
             <a:extLst xmlns:a="http://schemas.openxmlformats.org/drawingml/2006/main">
               <a:ext uri="{FF2B5EF4-FFF2-40B4-BE49-F238E27FC236}">
-                <a16:creationId xmlns:a16="http://schemas.microsoft.com/office/drawing/2014/main" id="{B608A12E-E0FB-4BEF-806A-CC2D876CAE29}"/>
+                <a16:creationId xmlns:a16="http://schemas.microsoft.com/office/drawing/2014/main" id="{9BB2FD4E-F4B3-40A9-9C45-9CC02413ED85}"/>
               </a:ext>
             </a:extLst>
           </p:cNvPr>
@@ -31475,7 +31819,7 @@
           <p:cNvPr id="6" name="">
             <a:extLst xmlns:a="http://schemas.openxmlformats.org/drawingml/2006/main">
               <a:ext uri="{FF2B5EF4-FFF2-40B4-BE49-F238E27FC236}">
-                <a16:creationId xmlns:a16="http://schemas.microsoft.com/office/drawing/2014/main" id="{CDC02FE8-0282-4127-8C27-38487D1BFE41}"/>
+                <a16:creationId xmlns:a16="http://schemas.microsoft.com/office/drawing/2014/main" id="{B2674D2C-40BC-4E2E-BF34-AC8342CF49F0}"/>
               </a:ext>
             </a:extLst>
           </p:cNvPr>
@@ -31633,7 +31977,7 @@
           <p:cNvPr id="7" name="">
             <a:extLst xmlns:a="http://schemas.openxmlformats.org/drawingml/2006/main">
               <a:ext uri="{FF2B5EF4-FFF2-40B4-BE49-F238E27FC236}">
-                <a16:creationId xmlns:a16="http://schemas.microsoft.com/office/drawing/2014/main" id="{705A7290-9093-4A26-A6E7-B2322455EC95}"/>
+                <a16:creationId xmlns:a16="http://schemas.microsoft.com/office/drawing/2014/main" id="{971E869F-804E-42E8-B70E-6E98F01FCE3C}"/>
               </a:ext>
             </a:extLst>
           </p:cNvPr>
@@ -31643,7 +31987,7 @@
           <p:nvPr/>
         </p:nvPicPr>
         <p:blipFill>
-          <a:blip xmlns:r="http://schemas.openxmlformats.org/officeDocument/2006/relationships" xmlns:a="http://schemas.openxmlformats.org/drawingml/2006/main" r:embed="Re3bd5aee034c4d2a"/>
+          <a:blip xmlns:r="http://schemas.openxmlformats.org/officeDocument/2006/relationships" xmlns:a="http://schemas.openxmlformats.org/drawingml/2006/main" r:embed="R37df77b5a9004cd0"/>
           <a:stretch xmlns:a="http://schemas.openxmlformats.org/drawingml/2006/main"/>
         </p:blipFill>
         <p:spPr>
@@ -31661,7 +32005,7 @@
           <p:cNvPr id="8" name="">
             <a:extLst xmlns:a="http://schemas.openxmlformats.org/drawingml/2006/main">
               <a:ext uri="{FF2B5EF4-FFF2-40B4-BE49-F238E27FC236}">
-                <a16:creationId xmlns:a16="http://schemas.microsoft.com/office/drawing/2014/main" id="{A34856C2-1468-46C8-8D78-5DD443CDDC00}"/>
+                <a16:creationId xmlns:a16="http://schemas.microsoft.com/office/drawing/2014/main" id="{138FBD24-5D20-4094-BE2C-20BA885115C1}"/>
               </a:ext>
             </a:extLst>
           </p:cNvPr>
@@ -31819,7 +32163,7 @@
           <p:cNvPr id="9" name="">
             <a:extLst xmlns:a="http://schemas.openxmlformats.org/drawingml/2006/main">
               <a:ext uri="{FF2B5EF4-FFF2-40B4-BE49-F238E27FC236}">
-                <a16:creationId xmlns:a16="http://schemas.microsoft.com/office/drawing/2014/main" id="{06C97D5F-94B3-42C0-A87D-CFA9858F64F0}"/>
+                <a16:creationId xmlns:a16="http://schemas.microsoft.com/office/drawing/2014/main" id="{DA8C4A1F-85E3-4780-9779-693DD4D69510}"/>
               </a:ext>
             </a:extLst>
           </p:cNvPr>
@@ -31977,7 +32321,7 @@
           <p:cNvPr id="10" name="">
             <a:extLst xmlns:a="http://schemas.openxmlformats.org/drawingml/2006/main">
               <a:ext uri="{FF2B5EF4-FFF2-40B4-BE49-F238E27FC236}">
-                <a16:creationId xmlns:a16="http://schemas.microsoft.com/office/drawing/2014/main" id="{E8E01FB1-BBDE-48CC-B468-8D49955442D7}"/>
+                <a16:creationId xmlns:a16="http://schemas.microsoft.com/office/drawing/2014/main" id="{DEF70EE2-9FBA-4113-A592-A07A17D3BD0E}"/>
               </a:ext>
             </a:extLst>
           </p:cNvPr>
@@ -32163,7 +32507,7 @@
           <p:cNvPr id="11" name="">
             <a:extLst xmlns:a="http://schemas.openxmlformats.org/drawingml/2006/main">
               <a:ext uri="{FF2B5EF4-FFF2-40B4-BE49-F238E27FC236}">
-                <a16:creationId xmlns:a16="http://schemas.microsoft.com/office/drawing/2014/main" id="{833A6B81-25E9-413F-ABA9-91A8E3FB075C}"/>
+                <a16:creationId xmlns:a16="http://schemas.microsoft.com/office/drawing/2014/main" id="{1684EBFA-4A1F-4AC9-83AE-630C3B090325}"/>
               </a:ext>
             </a:extLst>
           </p:cNvPr>
@@ -32321,7 +32665,7 @@
           <p:cNvPr id="12" name="">
             <a:extLst xmlns:a="http://schemas.openxmlformats.org/drawingml/2006/main">
               <a:ext uri="{FF2B5EF4-FFF2-40B4-BE49-F238E27FC236}">
-                <a16:creationId xmlns:a16="http://schemas.microsoft.com/office/drawing/2014/main" id="{FCFDA231-1D07-4212-90CC-3A59D9E84BCA}"/>
+                <a16:creationId xmlns:a16="http://schemas.microsoft.com/office/drawing/2014/main" id="{C29310AF-24C5-45A9-8F05-43AEB3D37509}"/>
               </a:ext>
             </a:extLst>
           </p:cNvPr>
@@ -32477,7 +32821,7 @@
     </p:spTree>
     <p:extLst>
       <p:ext uri="{BB962C8B-B14F-4D97-AF65-F5344CB8AC3E}">
-        <p14:creationId xmlns:p14="http://schemas.microsoft.com/office/powerpoint/2010/main" val="139257226"/>
+        <p14:creationId xmlns:p14="http://schemas.microsoft.com/office/powerpoint/2010/main" val="870807884"/>
       </p:ext>
     </p:extLst>
   </p:cSld>
@@ -32508,7 +32852,7 @@
           <p:cNvPr id="14" name="">
             <a:extLst xmlns:a="http://schemas.openxmlformats.org/drawingml/2006/main">
               <a:ext uri="{FF2B5EF4-FFF2-40B4-BE49-F238E27FC236}">
-                <a16:creationId xmlns:a16="http://schemas.microsoft.com/office/drawing/2014/main" id="{D2096DBB-6AF0-4FC5-BFF7-E7634E8E7F3E}"/>
+                <a16:creationId xmlns:a16="http://schemas.microsoft.com/office/drawing/2014/main" id="{D21EF80B-576E-408A-B5AE-F7632AED9742}"/>
               </a:ext>
             </a:extLst>
           </p:cNvPr>
@@ -32666,7 +33010,7 @@
           <p:cNvPr id="2" name="">
             <a:extLst xmlns:a="http://schemas.openxmlformats.org/drawingml/2006/main">
               <a:ext uri="{FF2B5EF4-FFF2-40B4-BE49-F238E27FC236}">
-                <a16:creationId xmlns:a16="http://schemas.microsoft.com/office/drawing/2014/main" id="{F4919C8B-21C9-45AF-A9E2-527DEF6473F2}"/>
+                <a16:creationId xmlns:a16="http://schemas.microsoft.com/office/drawing/2014/main" id="{150C0012-669C-4DBC-9AFE-277EC6477B0E}"/>
               </a:ext>
             </a:extLst>
           </p:cNvPr>
@@ -32824,7 +33168,7 @@
           <p:cNvPr id="3" name="">
             <a:extLst xmlns:a="http://schemas.openxmlformats.org/drawingml/2006/main">
               <a:ext uri="{FF2B5EF4-FFF2-40B4-BE49-F238E27FC236}">
-                <a16:creationId xmlns:a16="http://schemas.microsoft.com/office/drawing/2014/main" id="{E2533364-001C-415E-BBBE-B019FBBC6A56}"/>
+                <a16:creationId xmlns:a16="http://schemas.microsoft.com/office/drawing/2014/main" id="{9CD3BD4A-2716-4C46-9452-DA16C5CC6490}"/>
               </a:ext>
             </a:extLst>
           </p:cNvPr>
@@ -32982,7 +33326,7 @@
           <p:cNvPr id="4" name="">
             <a:extLst xmlns:a="http://schemas.openxmlformats.org/drawingml/2006/main">
               <a:ext uri="{FF2B5EF4-FFF2-40B4-BE49-F238E27FC236}">
-                <a16:creationId xmlns:a16="http://schemas.microsoft.com/office/drawing/2014/main" id="{B69ABCCC-5D90-4243-A129-729B657D109F}"/>
+                <a16:creationId xmlns:a16="http://schemas.microsoft.com/office/drawing/2014/main" id="{AF5B00D8-8F5A-4588-89B5-F15595FE8035}"/>
               </a:ext>
             </a:extLst>
           </p:cNvPr>
@@ -32992,7 +33336,7 @@
           <p:nvPr/>
         </p:nvPicPr>
         <p:blipFill>
-          <a:blip xmlns:r="http://schemas.openxmlformats.org/officeDocument/2006/relationships" xmlns:a="http://schemas.openxmlformats.org/drawingml/2006/main" r:embed="R3e3e7a1fee8041c9"/>
+          <a:blip xmlns:r="http://schemas.openxmlformats.org/officeDocument/2006/relationships" xmlns:a="http://schemas.openxmlformats.org/drawingml/2006/main" r:embed="Rdf1214cdbdcd453d"/>
           <a:stretch xmlns:a="http://schemas.openxmlformats.org/drawingml/2006/main"/>
         </p:blipFill>
         <p:spPr>
@@ -33010,7 +33354,7 @@
           <p:cNvPr id="5" name="">
             <a:extLst xmlns:a="http://schemas.openxmlformats.org/drawingml/2006/main">
               <a:ext uri="{FF2B5EF4-FFF2-40B4-BE49-F238E27FC236}">
-                <a16:creationId xmlns:a16="http://schemas.microsoft.com/office/drawing/2014/main" id="{816E4A98-8D31-4AF7-88CC-C27AEA5BCE0A}"/>
+                <a16:creationId xmlns:a16="http://schemas.microsoft.com/office/drawing/2014/main" id="{0F33EC1F-385E-4871-AD9E-A24496EE3E4B}"/>
               </a:ext>
             </a:extLst>
           </p:cNvPr>
@@ -33168,7 +33512,7 @@
           <p:cNvPr id="6" name="">
             <a:extLst xmlns:a="http://schemas.openxmlformats.org/drawingml/2006/main">
               <a:ext uri="{FF2B5EF4-FFF2-40B4-BE49-F238E27FC236}">
-                <a16:creationId xmlns:a16="http://schemas.microsoft.com/office/drawing/2014/main" id="{CDAC7606-4BC1-41AA-B82D-FFC74B2C5C78}"/>
+                <a16:creationId xmlns:a16="http://schemas.microsoft.com/office/drawing/2014/main" id="{5C47943D-F4BF-4413-AE01-1C1992C3D409}"/>
               </a:ext>
             </a:extLst>
           </p:cNvPr>
@@ -33326,7 +33670,7 @@
           <p:cNvPr id="7" name="">
             <a:extLst xmlns:a="http://schemas.openxmlformats.org/drawingml/2006/main">
               <a:ext uri="{FF2B5EF4-FFF2-40B4-BE49-F238E27FC236}">
-                <a16:creationId xmlns:a16="http://schemas.microsoft.com/office/drawing/2014/main" id="{77877777-1559-4DDB-BBED-95F12AF97434}"/>
+                <a16:creationId xmlns:a16="http://schemas.microsoft.com/office/drawing/2014/main" id="{916212A3-EA4B-4FF8-9DFB-FFAA4D226396}"/>
               </a:ext>
             </a:extLst>
           </p:cNvPr>
@@ -33336,7 +33680,7 @@
           <p:nvPr/>
         </p:nvPicPr>
         <p:blipFill>
-          <a:blip xmlns:r="http://schemas.openxmlformats.org/officeDocument/2006/relationships" xmlns:a="http://schemas.openxmlformats.org/drawingml/2006/main" r:embed="R035f99866893477f"/>
+          <a:blip xmlns:r="http://schemas.openxmlformats.org/officeDocument/2006/relationships" xmlns:a="http://schemas.openxmlformats.org/drawingml/2006/main" r:embed="R2aca734347aa4483"/>
           <a:stretch xmlns:a="http://schemas.openxmlformats.org/drawingml/2006/main"/>
         </p:blipFill>
         <p:spPr>
@@ -33354,7 +33698,7 @@
           <p:cNvPr id="8" name="">
             <a:extLst xmlns:a="http://schemas.openxmlformats.org/drawingml/2006/main">
               <a:ext uri="{FF2B5EF4-FFF2-40B4-BE49-F238E27FC236}">
-                <a16:creationId xmlns:a16="http://schemas.microsoft.com/office/drawing/2014/main" id="{A6036EA2-9C2B-40A4-B50D-0B6F0A5A5451}"/>
+                <a16:creationId xmlns:a16="http://schemas.microsoft.com/office/drawing/2014/main" id="{C946FD60-215B-4D25-9FF8-D647EA7961A3}"/>
               </a:ext>
             </a:extLst>
           </p:cNvPr>
@@ -33512,7 +33856,7 @@
           <p:cNvPr id="9" name="">
             <a:extLst xmlns:a="http://schemas.openxmlformats.org/drawingml/2006/main">
               <a:ext uri="{FF2B5EF4-FFF2-40B4-BE49-F238E27FC236}">
-                <a16:creationId xmlns:a16="http://schemas.microsoft.com/office/drawing/2014/main" id="{A1DB8ED4-8B0F-4441-AE3C-62100F8CC9FC}"/>
+                <a16:creationId xmlns:a16="http://schemas.microsoft.com/office/drawing/2014/main" id="{3FD06E1B-7777-42D1-AEEF-637702ABFA7D}"/>
               </a:ext>
             </a:extLst>
           </p:cNvPr>
@@ -33670,7 +34014,7 @@
           <p:cNvPr id="10" name="">
             <a:extLst xmlns:a="http://schemas.openxmlformats.org/drawingml/2006/main">
               <a:ext uri="{FF2B5EF4-FFF2-40B4-BE49-F238E27FC236}">
-                <a16:creationId xmlns:a16="http://schemas.microsoft.com/office/drawing/2014/main" id="{1FFB7092-0B38-44CE-BC63-19C625C570C1}"/>
+                <a16:creationId xmlns:a16="http://schemas.microsoft.com/office/drawing/2014/main" id="{C32FE250-AD9C-4ED2-9464-F5E26A8209E6}"/>
               </a:ext>
             </a:extLst>
           </p:cNvPr>
@@ -33680,7 +34024,7 @@
           <p:nvPr/>
         </p:nvPicPr>
         <p:blipFill>
-          <a:blip xmlns:r="http://schemas.openxmlformats.org/officeDocument/2006/relationships" xmlns:a="http://schemas.openxmlformats.org/drawingml/2006/main" r:embed="R3457891adbce469b"/>
+          <a:blip xmlns:r="http://schemas.openxmlformats.org/officeDocument/2006/relationships" xmlns:a="http://schemas.openxmlformats.org/drawingml/2006/main" r:embed="R24464d35f7114461"/>
           <a:stretch xmlns:a="http://schemas.openxmlformats.org/drawingml/2006/main"/>
         </p:blipFill>
         <p:spPr>
@@ -33698,7 +34042,7 @@
           <p:cNvPr id="11" name="">
             <a:extLst xmlns:a="http://schemas.openxmlformats.org/drawingml/2006/main">
               <a:ext uri="{FF2B5EF4-FFF2-40B4-BE49-F238E27FC236}">
-                <a16:creationId xmlns:a16="http://schemas.microsoft.com/office/drawing/2014/main" id="{A4E4BA28-A449-42BB-A176-9B5CFDA88DBB}"/>
+                <a16:creationId xmlns:a16="http://schemas.microsoft.com/office/drawing/2014/main" id="{D47289DD-0801-48F5-B1F1-D8DA33EB5EA8}"/>
               </a:ext>
             </a:extLst>
           </p:cNvPr>
@@ -33856,7 +34200,7 @@
           <p:cNvPr id="12" name="">
             <a:extLst xmlns:a="http://schemas.openxmlformats.org/drawingml/2006/main">
               <a:ext uri="{FF2B5EF4-FFF2-40B4-BE49-F238E27FC236}">
-                <a16:creationId xmlns:a16="http://schemas.microsoft.com/office/drawing/2014/main" id="{F94CEE58-2ECB-4F97-B07E-7FBE198040B6}"/>
+                <a16:creationId xmlns:a16="http://schemas.microsoft.com/office/drawing/2014/main" id="{99A96A6A-F282-4436-849A-4B5D5D5B35E1}"/>
               </a:ext>
             </a:extLst>
           </p:cNvPr>
@@ -34014,7 +34358,7 @@
           <p:cNvPr id="13" name="">
             <a:extLst xmlns:a="http://schemas.openxmlformats.org/drawingml/2006/main">
               <a:ext uri="{FF2B5EF4-FFF2-40B4-BE49-F238E27FC236}">
-                <a16:creationId xmlns:a16="http://schemas.microsoft.com/office/drawing/2014/main" id="{C50CEB4A-807D-40B6-AD93-DEEA28C71768}"/>
+                <a16:creationId xmlns:a16="http://schemas.microsoft.com/office/drawing/2014/main" id="{D9D07CA0-6BA8-4B83-843A-F114319B961B}"/>
               </a:ext>
             </a:extLst>
           </p:cNvPr>
@@ -34198,7 +34542,7 @@
     </p:spTree>
     <p:extLst>
       <p:ext uri="{BB962C8B-B14F-4D97-AF65-F5344CB8AC3E}">
-        <p14:creationId xmlns:p14="http://schemas.microsoft.com/office/powerpoint/2010/main" val="2107213750"/>
+        <p14:creationId xmlns:p14="http://schemas.microsoft.com/office/powerpoint/2010/main" val="157706165"/>
       </p:ext>
     </p:extLst>
   </p:cSld>

</xml_diff>